<commit_message>
docs: clarify gwie vs llm-d routing roles
</commit_message>
<xml_diff>
--- a/llm/kaito-llm-d-pd-slides.pptx
+++ b/llm/kaito-llm-d-pd-slides.pptx
@@ -3452,8 +3452,8 @@
                 <a:latin typeface="Aptos"/>
               </a:rPr>
               <a:t>Control plane: KAITO
-Routing contract: GWIE
-Scheduling substrate: llm-d Router
+Gateway-facing contract: GWIE
+Routing intelligence: llm-d Router
 Runtime + KV path: vLLM + NIXL</a:t>
             </a:r>
           </a:p>
@@ -5599,7 +5599,7 @@
               </a:defRPr>
             </a:pPr>
             <a:r>
-              <a:t>inference routing contract</a:t>
+              <a:t>gateway-facing routing contract</a:t>
             </a:r>
           </a:p>
           <a:p>
@@ -5614,7 +5614,7 @@
               </a:defRPr>
             </a:pPr>
             <a:r>
-              <a:t>InferencePool model</a:t>
+              <a:t>InferencePool API model</a:t>
             </a:r>
           </a:p>
           <a:p>
@@ -5961,7 +5961,7 @@
                 </a:solidFill>
                 <a:latin typeface="Aptos"/>
               </a:rPr>
-              <a:t>KAITO makes P/D operable. llm-d makes it routable. GWIE makes it Kubernetes-native.</a:t>
+              <a:t>KAITO makes P/D operable. llm-d provides the routing intelligence. GWIE provides the Kubernetes-native contract.</a:t>
             </a:r>
           </a:p>
         </p:txBody>
@@ -6233,7 +6233,7 @@
                 </a:solidFill>
                 <a:latin typeface="Aptos"/>
               </a:rPr>
-              <a:t>This is the anchor architecture slide: one user endpoint, one routing surface, two role-specific backends, and a direct KV path.</a:t>
+              <a:t>This is the anchor architecture slide: one user endpoint, one gateway-facing contract surface, two role-specific backends, and a direct KV path.</a:t>
             </a:r>
           </a:p>
         </p:txBody>
@@ -6493,8 +6493,8 @@
         </p:nvSpPr>
         <p:spPr>
           <a:xfrm>
-            <a:off x="4526280" y="2121408"/>
-            <a:ext cx="1737360" cy="402336"/>
+            <a:off x="4315968" y="2121408"/>
+            <a:ext cx="2194560" cy="402336"/>
           </a:xfrm>
           <a:prstGeom prst="roundRect">
             <a:avLst/>
@@ -6530,13 +6530,14 @@
           <a:p>
             <a:pPr algn="ctr"/>
             <a:r>
-              <a:rPr sz="1600" b="1">
+              <a:rPr sz="1500" b="1">
                 <a:solidFill>
                   <a:srgbClr val="0F172A"/>
                 </a:solidFill>
                 <a:latin typeface="Aptos"/>
               </a:rPr>
-              <a:t>InferencePool</a:t>
+              <a:t>InferencePool
+(GWIE CRD)</a:t>
             </a:r>
           </a:p>
         </p:txBody>
@@ -7600,7 +7601,7 @@
                 </a:solidFill>
                 <a:latin typeface="Aptos"/>
               </a:rPr>
-              <a:t>KAITO owns topology + wiring; llm-d owns EPP decisions; vLLM/NIXL own execution + handoff.</a:t>
+              <a:t>KAITO owns topology + wiring; GWIE carries the contract; llm-d owns EPP decisions; vLLM/NIXL own execution + handoff.</a:t>
             </a:r>
           </a:p>
         </p:txBody>
@@ -10473,7 +10474,7 @@
                 </a:solidFill>
                 <a:latin typeface="Aptos"/>
               </a:rPr>
-              <a:t>The user sees one endpoint. The platform coordinates routing, prefill placement, KV movement, and decode execution across multiple pods.</a:t>
+              <a:t>The user sees one endpoint. GWIE carries the gateway-facing contract, llm-d makes the routing decisions, and the platform coordinates prefill placement, KV movement, and decode execution across multiple pods.</a:t>
             </a:r>
           </a:p>
         </p:txBody>

</xml_diff>

<commit_message>
docs: polish kaito llm-d pd deck visuals
</commit_message>
<xml_diff>
--- a/llm/kaito-llm-d-pd-slides.pptx
+++ b/llm/kaito-llm-d-pd-slides.pptx
@@ -7665,7 +7665,163 @@
       </p:sp>
       <p:sp>
         <p:nvSpPr>
-          <p:cNvPr id="7" name="Rounded Rectangle 6"/>
+          <p:cNvPr id="7" name="Rectangle 6"/>
+          <p:cNvSpPr/>
+          <p:nvPr/>
+        </p:nvSpPr>
+        <p:spPr>
+          <a:xfrm>
+            <a:off x="1234440" y="1755648"/>
+            <a:ext cx="2148840" cy="292608"/>
+          </a:xfrm>
+          <a:prstGeom prst="rect">
+            <a:avLst/>
+          </a:prstGeom>
+          <a:noFill/>
+          <a:ln>
+            <a:noFill/>
+          </a:ln>
+        </p:spPr>
+        <p:style>
+          <a:lnRef idx="1">
+            <a:schemeClr val="accent1"/>
+          </a:lnRef>
+          <a:fillRef idx="3">
+            <a:schemeClr val="accent1"/>
+          </a:fillRef>
+          <a:effectRef idx="2">
+            <a:schemeClr val="accent1"/>
+          </a:effectRef>
+          <a:fontRef idx="minor">
+            <a:schemeClr val="lt1"/>
+          </a:fontRef>
+        </p:style>
+        <p:txBody>
+          <a:bodyPr rtlCol="0" anchor="ctr" wrap="square" lIns="73152" rIns="73152" tIns="73152" bIns="73152">
+            <a:noAutofit/>
+          </a:bodyPr>
+          <a:lstStyle/>
+          <a:p>
+            <a:pPr algn="ctr"/>
+            <a:r>
+              <a:rPr sz="1200" b="1">
+                <a:solidFill>
+                  <a:srgbClr val="2563EB"/>
+                </a:solidFill>
+                <a:latin typeface="Aptos"/>
+              </a:rPr>
+              <a:t>control-plane abstraction</a:t>
+            </a:r>
+          </a:p>
+        </p:txBody>
+      </p:sp>
+      <p:sp>
+        <p:nvSpPr>
+          <p:cNvPr id="8" name="Rectangle 7"/>
+          <p:cNvSpPr/>
+          <p:nvPr/>
+        </p:nvSpPr>
+        <p:spPr>
+          <a:xfrm>
+            <a:off x="5047488" y="1755648"/>
+            <a:ext cx="2057400" cy="292608"/>
+          </a:xfrm>
+          <a:prstGeom prst="rect">
+            <a:avLst/>
+          </a:prstGeom>
+          <a:noFill/>
+          <a:ln>
+            <a:noFill/>
+          </a:ln>
+        </p:spPr>
+        <p:style>
+          <a:lnRef idx="1">
+            <a:schemeClr val="accent1"/>
+          </a:lnRef>
+          <a:fillRef idx="3">
+            <a:schemeClr val="accent1"/>
+          </a:fillRef>
+          <a:effectRef idx="2">
+            <a:schemeClr val="accent1"/>
+          </a:effectRef>
+          <a:fontRef idx="minor">
+            <a:schemeClr val="lt1"/>
+          </a:fontRef>
+        </p:style>
+        <p:txBody>
+          <a:bodyPr rtlCol="0" anchor="ctr" wrap="square" lIns="73152" rIns="73152" tIns="73152" bIns="73152">
+            <a:noAutofit/>
+          </a:bodyPr>
+          <a:lstStyle/>
+          <a:p>
+            <a:pPr algn="ctr"/>
+            <a:r>
+              <a:rPr sz="1200" b="1">
+                <a:solidFill>
+                  <a:srgbClr val="16A34A"/>
+                </a:solidFill>
+                <a:latin typeface="Aptos"/>
+              </a:rPr>
+              <a:t>gateway-facing contract</a:t>
+            </a:r>
+          </a:p>
+        </p:txBody>
+      </p:sp>
+      <p:sp>
+        <p:nvSpPr>
+          <p:cNvPr id="9" name="Rectangle 8"/>
+          <p:cNvSpPr/>
+          <p:nvPr/>
+        </p:nvSpPr>
+        <p:spPr>
+          <a:xfrm>
+            <a:off x="8705088" y="1755648"/>
+            <a:ext cx="2148840" cy="292608"/>
+          </a:xfrm>
+          <a:prstGeom prst="rect">
+            <a:avLst/>
+          </a:prstGeom>
+          <a:noFill/>
+          <a:ln>
+            <a:noFill/>
+          </a:ln>
+        </p:spPr>
+        <p:style>
+          <a:lnRef idx="1">
+            <a:schemeClr val="accent1"/>
+          </a:lnRef>
+          <a:fillRef idx="3">
+            <a:schemeClr val="accent1"/>
+          </a:fillRef>
+          <a:effectRef idx="2">
+            <a:schemeClr val="accent1"/>
+          </a:effectRef>
+          <a:fontRef idx="minor">
+            <a:schemeClr val="lt1"/>
+          </a:fontRef>
+        </p:style>
+        <p:txBody>
+          <a:bodyPr rtlCol="0" anchor="ctr" wrap="square" lIns="73152" rIns="73152" tIns="73152" bIns="73152">
+            <a:noAutofit/>
+          </a:bodyPr>
+          <a:lstStyle/>
+          <a:p>
+            <a:pPr algn="ctr"/>
+            <a:r>
+              <a:rPr sz="1200" b="1">
+                <a:solidFill>
+                  <a:srgbClr val="EA580C"/>
+                </a:solidFill>
+                <a:latin typeface="Aptos"/>
+              </a:rPr>
+              <a:t>routing intelligence</a:t>
+            </a:r>
+          </a:p>
+        </p:txBody>
+      </p:sp>
+      <p:sp>
+        <p:nvSpPr>
+          <p:cNvPr id="10" name="Rounded Rectangle 9"/>
           <p:cNvSpPr/>
           <p:nvPr/>
         </p:nvSpPr>
@@ -7721,7 +7877,7 @@
       </p:sp>
       <p:sp>
         <p:nvSpPr>
-          <p:cNvPr id="8" name="Rectangle 7"/>
+          <p:cNvPr id="11" name="Rectangle 10"/>
           <p:cNvSpPr/>
           <p:nvPr/>
         </p:nvSpPr>
@@ -7773,7 +7929,7 @@
       </p:sp>
       <p:sp>
         <p:nvSpPr>
-          <p:cNvPr id="9" name="TextBox 8"/>
+          <p:cNvPr id="12" name="TextBox 11"/>
           <p:cNvSpPr txBox="1"/>
           <p:nvPr/>
         </p:nvSpPr>
@@ -7856,7 +8012,7 @@
       </p:sp>
       <p:sp>
         <p:nvSpPr>
-          <p:cNvPr id="10" name="Rounded Rectangle 9"/>
+          <p:cNvPr id="13" name="Rounded Rectangle 12"/>
           <p:cNvSpPr/>
           <p:nvPr/>
         </p:nvSpPr>
@@ -7912,7 +8068,7 @@
       </p:sp>
       <p:sp>
         <p:nvSpPr>
-          <p:cNvPr id="11" name="Rectangle 10"/>
+          <p:cNvPr id="14" name="Rectangle 13"/>
           <p:cNvSpPr/>
           <p:nvPr/>
         </p:nvSpPr>
@@ -7964,7 +8120,7 @@
       </p:sp>
       <p:sp>
         <p:nvSpPr>
-          <p:cNvPr id="12" name="TextBox 11"/>
+          <p:cNvPr id="15" name="TextBox 14"/>
           <p:cNvSpPr txBox="1"/>
           <p:nvPr/>
         </p:nvSpPr>
@@ -8047,7 +8203,7 @@
       </p:sp>
       <p:sp>
         <p:nvSpPr>
-          <p:cNvPr id="13" name="Rounded Rectangle 12"/>
+          <p:cNvPr id="16" name="Rounded Rectangle 15"/>
           <p:cNvSpPr/>
           <p:nvPr/>
         </p:nvSpPr>
@@ -8103,7 +8259,7 @@
       </p:sp>
       <p:sp>
         <p:nvSpPr>
-          <p:cNvPr id="14" name="Rectangle 13"/>
+          <p:cNvPr id="17" name="Rectangle 16"/>
           <p:cNvSpPr/>
           <p:nvPr/>
         </p:nvSpPr>
@@ -8155,7 +8311,7 @@
       </p:sp>
       <p:sp>
         <p:nvSpPr>
-          <p:cNvPr id="15" name="TextBox 14"/>
+          <p:cNvPr id="18" name="TextBox 17"/>
           <p:cNvSpPr txBox="1"/>
           <p:nvPr/>
         </p:nvSpPr>
@@ -8238,7 +8394,7 @@
       </p:sp>
       <p:cxnSp>
         <p:nvCxnSpPr>
-          <p:cNvPr id="16" name="Connector 15"/>
+          <p:cNvPr id="19" name="Connector 18"/>
           <p:cNvCxnSpPr/>
           <p:nvPr/>
         </p:nvCxnSpPr>
@@ -8273,7 +8429,7 @@
       </p:cxnSp>
       <p:cxnSp>
         <p:nvCxnSpPr>
-          <p:cNvPr id="17" name="Connector 16"/>
+          <p:cNvPr id="20" name="Connector 19"/>
           <p:cNvCxnSpPr/>
           <p:nvPr/>
         </p:nvCxnSpPr>
@@ -8308,7 +8464,59 @@
       </p:cxnSp>
       <p:sp>
         <p:nvSpPr>
-          <p:cNvPr id="18" name="Rounded Rectangle 17"/>
+          <p:cNvPr id="21" name="Rectangle 20"/>
+          <p:cNvSpPr/>
+          <p:nvPr/>
+        </p:nvSpPr>
+        <p:spPr>
+          <a:xfrm>
+            <a:off x="2468880" y="4553712"/>
+            <a:ext cx="7315200" cy="310896"/>
+          </a:xfrm>
+          <a:prstGeom prst="rect">
+            <a:avLst/>
+          </a:prstGeom>
+          <a:noFill/>
+          <a:ln>
+            <a:noFill/>
+          </a:ln>
+        </p:spPr>
+        <p:style>
+          <a:lnRef idx="1">
+            <a:schemeClr val="accent1"/>
+          </a:lnRef>
+          <a:fillRef idx="3">
+            <a:schemeClr val="accent1"/>
+          </a:fillRef>
+          <a:effectRef idx="2">
+            <a:schemeClr val="accent1"/>
+          </a:effectRef>
+          <a:fontRef idx="minor">
+            <a:schemeClr val="lt1"/>
+          </a:fontRef>
+        </p:style>
+        <p:txBody>
+          <a:bodyPr rtlCol="0" anchor="ctr" wrap="square" lIns="73152" rIns="73152" tIns="73152" bIns="73152">
+            <a:noAutofit/>
+          </a:bodyPr>
+          <a:lstStyle/>
+          <a:p>
+            <a:pPr algn="ctr"/>
+            <a:r>
+              <a:rPr sz="1300" b="1">
+                <a:solidFill>
+                  <a:srgbClr val="64748B"/>
+                </a:solidFill>
+                <a:latin typeface="Aptos"/>
+              </a:rPr>
+              <a:t>contract + routing together become a usable platform path only when the controller owns the topology and wiring</a:t>
+            </a:r>
+          </a:p>
+        </p:txBody>
+      </p:sp>
+      <p:sp>
+        <p:nvSpPr>
+          <p:cNvPr id="22" name="Rounded Rectangle 21"/>
           <p:cNvSpPr/>
           <p:nvPr/>
         </p:nvSpPr>
@@ -8737,103 +8945,8 @@
         </p:nvSpPr>
         <p:spPr>
           <a:xfrm>
-            <a:off x="960120" y="2029968"/>
-            <a:ext cx="10012680" cy="713232"/>
-          </a:xfrm>
-          <a:prstGeom prst="roundRect">
-            <a:avLst/>
-          </a:prstGeom>
-          <a:solidFill>
-            <a:srgbClr val="F1F5F9"/>
-          </a:solidFill>
-          <a:ln>
-            <a:noFill/>
-          </a:ln>
-        </p:spPr>
-        <p:style>
-          <a:lnRef idx="1">
-            <a:schemeClr val="accent1"/>
-          </a:lnRef>
-          <a:fillRef idx="3">
-            <a:schemeClr val="accent1"/>
-          </a:fillRef>
-          <a:effectRef idx="2">
-            <a:schemeClr val="accent1"/>
-          </a:effectRef>
-          <a:fontRef idx="minor">
-            <a:schemeClr val="lt1"/>
-          </a:fontRef>
-        </p:style>
-        <p:txBody>
-          <a:bodyPr rtlCol="0" anchor="ctr"/>
-          <a:lstStyle/>
-          <a:p>
-            <a:pPr algn="ctr"/>
-          </a:p>
-        </p:txBody>
-      </p:sp>
-      <p:sp>
-        <p:nvSpPr>
-          <p:cNvPr id="10" name="Rectangle 9"/>
-          <p:cNvSpPr/>
-          <p:nvPr/>
-        </p:nvSpPr>
-        <p:spPr>
-          <a:xfrm>
-            <a:off x="1097280" y="2194560"/>
-            <a:ext cx="1417320" cy="182880"/>
-          </a:xfrm>
-          <a:prstGeom prst="rect">
-            <a:avLst/>
-          </a:prstGeom>
-          <a:noFill/>
-          <a:ln>
-            <a:noFill/>
-          </a:ln>
-        </p:spPr>
-        <p:style>
-          <a:lnRef idx="1">
-            <a:schemeClr val="accent1"/>
-          </a:lnRef>
-          <a:fillRef idx="3">
-            <a:schemeClr val="accent1"/>
-          </a:fillRef>
-          <a:effectRef idx="2">
-            <a:schemeClr val="accent1"/>
-          </a:effectRef>
-          <a:fontRef idx="minor">
-            <a:schemeClr val="lt1"/>
-          </a:fontRef>
-        </p:style>
-        <p:txBody>
-          <a:bodyPr rtlCol="0" anchor="ctr" wrap="square" lIns="73152" rIns="73152" tIns="73152" bIns="73152">
-            <a:noAutofit/>
-          </a:bodyPr>
-          <a:lstStyle/>
-          <a:p>
-            <a:pPr algn="l"/>
-            <a:r>
-              <a:rPr sz="1200" b="1">
-                <a:solidFill>
-                  <a:srgbClr val="2563EB"/>
-                </a:solidFill>
-                <a:latin typeface="Aptos"/>
-              </a:rPr>
-              <a:t>control plane</a:t>
-            </a:r>
-          </a:p>
-        </p:txBody>
-      </p:sp>
-      <p:sp>
-        <p:nvSpPr>
-          <p:cNvPr id="11" name="Rounded Rectangle 10"/>
-          <p:cNvSpPr/>
-          <p:nvPr/>
-        </p:nvSpPr>
-        <p:spPr>
-          <a:xfrm>
-            <a:off x="1965960" y="2121408"/>
-            <a:ext cx="2240280" cy="402336"/>
+            <a:off x="8915400" y="1764792"/>
+            <a:ext cx="1051560" cy="274320"/>
           </a:xfrm>
           <a:prstGeom prst="roundRect">
             <a:avLst/>
@@ -8869,7 +8982,214 @@
           <a:p>
             <a:pPr algn="ctr"/>
             <a:r>
-              <a:rPr sz="1600" b="1">
+              <a:rPr sz="1100" b="1">
+                <a:solidFill>
+                  <a:srgbClr val="0F172A"/>
+                </a:solidFill>
+                <a:latin typeface="Aptos"/>
+              </a:rPr>
+              <a:t>user traffic</a:t>
+            </a:r>
+          </a:p>
+        </p:txBody>
+      </p:sp>
+      <p:sp>
+        <p:nvSpPr>
+          <p:cNvPr id="10" name="Rounded Rectangle 9"/>
+          <p:cNvSpPr/>
+          <p:nvPr/>
+        </p:nvSpPr>
+        <p:spPr>
+          <a:xfrm>
+            <a:off x="10058400" y="1764792"/>
+            <a:ext cx="1051560" cy="274320"/>
+          </a:xfrm>
+          <a:prstGeom prst="roundRect">
+            <a:avLst/>
+          </a:prstGeom>
+          <a:solidFill>
+            <a:srgbClr val="EDE9FE"/>
+          </a:solidFill>
+          <a:ln w="13970">
+            <a:solidFill>
+              <a:srgbClr val="6D28D9"/>
+            </a:solidFill>
+          </a:ln>
+        </p:spPr>
+        <p:style>
+          <a:lnRef idx="1">
+            <a:schemeClr val="accent1"/>
+          </a:lnRef>
+          <a:fillRef idx="3">
+            <a:schemeClr val="accent1"/>
+          </a:fillRef>
+          <a:effectRef idx="2">
+            <a:schemeClr val="accent1"/>
+          </a:effectRef>
+          <a:fontRef idx="minor">
+            <a:schemeClr val="lt1"/>
+          </a:fontRef>
+        </p:style>
+        <p:txBody>
+          <a:bodyPr rtlCol="0" anchor="ctr" wrap="square" lIns="73152" rIns="73152" tIns="73152" bIns="73152">
+            <a:noAutofit/>
+          </a:bodyPr>
+          <a:lstStyle/>
+          <a:p>
+            <a:pPr algn="ctr"/>
+            <a:r>
+              <a:rPr sz="1100" b="1">
+                <a:solidFill>
+                  <a:srgbClr val="0F172A"/>
+                </a:solidFill>
+                <a:latin typeface="Aptos"/>
+              </a:rPr>
+              <a:t>KV handoff</a:t>
+            </a:r>
+          </a:p>
+        </p:txBody>
+      </p:sp>
+      <p:sp>
+        <p:nvSpPr>
+          <p:cNvPr id="11" name="Rounded Rectangle 10"/>
+          <p:cNvSpPr/>
+          <p:nvPr/>
+        </p:nvSpPr>
+        <p:spPr>
+          <a:xfrm>
+            <a:off x="960120" y="2029968"/>
+            <a:ext cx="10012680" cy="749808"/>
+          </a:xfrm>
+          <a:prstGeom prst="roundRect">
+            <a:avLst/>
+          </a:prstGeom>
+          <a:solidFill>
+            <a:srgbClr val="F1F5F9"/>
+          </a:solidFill>
+          <a:ln>
+            <a:noFill/>
+          </a:ln>
+        </p:spPr>
+        <p:style>
+          <a:lnRef idx="1">
+            <a:schemeClr val="accent1"/>
+          </a:lnRef>
+          <a:fillRef idx="3">
+            <a:schemeClr val="accent1"/>
+          </a:fillRef>
+          <a:effectRef idx="2">
+            <a:schemeClr val="accent1"/>
+          </a:effectRef>
+          <a:fontRef idx="minor">
+            <a:schemeClr val="lt1"/>
+          </a:fontRef>
+        </p:style>
+        <p:txBody>
+          <a:bodyPr rtlCol="0" anchor="ctr"/>
+          <a:lstStyle/>
+          <a:p>
+            <a:pPr algn="ctr"/>
+          </a:p>
+        </p:txBody>
+      </p:sp>
+      <p:sp>
+        <p:nvSpPr>
+          <p:cNvPr id="12" name="Rectangle 11"/>
+          <p:cNvSpPr/>
+          <p:nvPr/>
+        </p:nvSpPr>
+        <p:spPr>
+          <a:xfrm>
+            <a:off x="1097280" y="2212848"/>
+            <a:ext cx="1417320" cy="182880"/>
+          </a:xfrm>
+          <a:prstGeom prst="rect">
+            <a:avLst/>
+          </a:prstGeom>
+          <a:noFill/>
+          <a:ln>
+            <a:noFill/>
+          </a:ln>
+        </p:spPr>
+        <p:style>
+          <a:lnRef idx="1">
+            <a:schemeClr val="accent1"/>
+          </a:lnRef>
+          <a:fillRef idx="3">
+            <a:schemeClr val="accent1"/>
+          </a:fillRef>
+          <a:effectRef idx="2">
+            <a:schemeClr val="accent1"/>
+          </a:effectRef>
+          <a:fontRef idx="minor">
+            <a:schemeClr val="lt1"/>
+          </a:fontRef>
+        </p:style>
+        <p:txBody>
+          <a:bodyPr rtlCol="0" anchor="ctr" wrap="square" lIns="73152" rIns="73152" tIns="73152" bIns="73152">
+            <a:noAutofit/>
+          </a:bodyPr>
+          <a:lstStyle/>
+          <a:p>
+            <a:pPr algn="l"/>
+            <a:r>
+              <a:rPr sz="1200" b="1">
+                <a:solidFill>
+                  <a:srgbClr val="2563EB"/>
+                </a:solidFill>
+                <a:latin typeface="Aptos"/>
+              </a:rPr>
+              <a:t>control plane</a:t>
+            </a:r>
+          </a:p>
+        </p:txBody>
+      </p:sp>
+      <p:sp>
+        <p:nvSpPr>
+          <p:cNvPr id="13" name="Rounded Rectangle 12"/>
+          <p:cNvSpPr/>
+          <p:nvPr/>
+        </p:nvSpPr>
+        <p:spPr>
+          <a:xfrm>
+            <a:off x="1874519" y="2139696"/>
+            <a:ext cx="2331720" cy="420624"/>
+          </a:xfrm>
+          <a:prstGeom prst="roundRect">
+            <a:avLst/>
+          </a:prstGeom>
+          <a:solidFill>
+            <a:srgbClr val="DBEAFE"/>
+          </a:solidFill>
+          <a:ln w="13970">
+            <a:solidFill>
+              <a:srgbClr val="2563EB"/>
+            </a:solidFill>
+          </a:ln>
+        </p:spPr>
+        <p:style>
+          <a:lnRef idx="1">
+            <a:schemeClr val="accent1"/>
+          </a:lnRef>
+          <a:fillRef idx="3">
+            <a:schemeClr val="accent1"/>
+          </a:fillRef>
+          <a:effectRef idx="2">
+            <a:schemeClr val="accent1"/>
+          </a:effectRef>
+          <a:fontRef idx="minor">
+            <a:schemeClr val="lt1"/>
+          </a:fontRef>
+        </p:style>
+        <p:txBody>
+          <a:bodyPr rtlCol="0" anchor="ctr" wrap="square" lIns="73152" rIns="73152" tIns="73152" bIns="73152">
+            <a:noAutofit/>
+          </a:bodyPr>
+          <a:lstStyle/>
+          <a:p>
+            <a:pPr algn="ctr"/>
+            <a:r>
+              <a:rPr sz="1500" b="1">
                 <a:solidFill>
                   <a:srgbClr val="0F172A"/>
                 </a:solidFill>
@@ -8883,14 +9203,14 @@
       </p:sp>
       <p:sp>
         <p:nvSpPr>
-          <p:cNvPr id="12" name="Rounded Rectangle 11"/>
-          <p:cNvSpPr/>
-          <p:nvPr/>
-        </p:nvSpPr>
-        <p:spPr>
-          <a:xfrm>
-            <a:off x="4315968" y="2121408"/>
-            <a:ext cx="2194560" cy="402336"/>
+          <p:cNvPr id="14" name="Rounded Rectangle 13"/>
+          <p:cNvSpPr/>
+          <p:nvPr/>
+        </p:nvSpPr>
+        <p:spPr>
+          <a:xfrm>
+            <a:off x="4370832" y="2139696"/>
+            <a:ext cx="1874519" cy="420624"/>
           </a:xfrm>
           <a:prstGeom prst="roundRect">
             <a:avLst/>
@@ -8926,7 +9246,7 @@
           <a:p>
             <a:pPr algn="ctr"/>
             <a:r>
-              <a:rPr sz="1500" b="1">
+              <a:rPr sz="1400" b="1">
                 <a:solidFill>
                   <a:srgbClr val="0F172A"/>
                 </a:solidFill>
@@ -8940,14 +9260,14 @@
       </p:sp>
       <p:sp>
         <p:nvSpPr>
-          <p:cNvPr id="13" name="Rounded Rectangle 12"/>
-          <p:cNvSpPr/>
-          <p:nvPr/>
-        </p:nvSpPr>
-        <p:spPr>
-          <a:xfrm>
-            <a:off x="6583680" y="2121408"/>
-            <a:ext cx="2423160" cy="402336"/>
+          <p:cNvPr id="15" name="Rounded Rectangle 14"/>
+          <p:cNvSpPr/>
+          <p:nvPr/>
+        </p:nvSpPr>
+        <p:spPr>
+          <a:xfrm>
+            <a:off x="6419088" y="2139696"/>
+            <a:ext cx="2633472" cy="420624"/>
           </a:xfrm>
           <a:prstGeom prst="roundRect">
             <a:avLst/>
@@ -8983,7 +9303,7 @@
           <a:p>
             <a:pPr algn="ctr"/>
             <a:r>
-              <a:rPr sz="1500" b="1">
+              <a:rPr sz="1400" b="1">
                 <a:solidFill>
                   <a:srgbClr val="0F172A"/>
                 </a:solidFill>
@@ -8996,14 +9316,14 @@
       </p:sp>
       <p:sp>
         <p:nvSpPr>
-          <p:cNvPr id="14" name="Rounded Rectangle 13"/>
-          <p:cNvSpPr/>
-          <p:nvPr/>
-        </p:nvSpPr>
-        <p:spPr>
-          <a:xfrm>
-            <a:off x="9281160" y="2121408"/>
-            <a:ext cx="1280160" cy="402336"/>
+          <p:cNvPr id="16" name="Rounded Rectangle 15"/>
+          <p:cNvSpPr/>
+          <p:nvPr/>
+        </p:nvSpPr>
+        <p:spPr>
+          <a:xfrm>
+            <a:off x="9308592" y="2139696"/>
+            <a:ext cx="1261872" cy="420624"/>
           </a:xfrm>
           <a:prstGeom prst="roundRect">
             <a:avLst/>
@@ -9039,7 +9359,7 @@
           <a:p>
             <a:pPr algn="ctr"/>
             <a:r>
-              <a:rPr sz="1600" b="1">
+              <a:rPr sz="1500" b="1">
                 <a:solidFill>
                   <a:srgbClr val="0F172A"/>
                 </a:solidFill>
@@ -9052,14 +9372,100 @@
       </p:sp>
       <p:sp>
         <p:nvSpPr>
-          <p:cNvPr id="15" name="Rectangle 14"/>
-          <p:cNvSpPr/>
-          <p:nvPr/>
-        </p:nvSpPr>
-        <p:spPr>
-          <a:xfrm>
-            <a:off x="1051560" y="2907792"/>
-            <a:ext cx="1143000" cy="182880"/>
+          <p:cNvPr id="17" name="Rounded Rectangle 16"/>
+          <p:cNvSpPr/>
+          <p:nvPr/>
+        </p:nvSpPr>
+        <p:spPr>
+          <a:xfrm>
+            <a:off x="960120" y="2907792"/>
+            <a:ext cx="10012680" cy="1234440"/>
+          </a:xfrm>
+          <a:prstGeom prst="roundRect">
+            <a:avLst/>
+          </a:prstGeom>
+          <a:solidFill>
+            <a:srgbClr val="DBEAFE"/>
+          </a:solidFill>
+          <a:ln>
+            <a:noFill/>
+          </a:ln>
+        </p:spPr>
+        <p:style>
+          <a:lnRef idx="1">
+            <a:schemeClr val="accent1"/>
+          </a:lnRef>
+          <a:fillRef idx="3">
+            <a:schemeClr val="accent1"/>
+          </a:fillRef>
+          <a:effectRef idx="2">
+            <a:schemeClr val="accent1"/>
+          </a:effectRef>
+          <a:fontRef idx="minor">
+            <a:schemeClr val="lt1"/>
+          </a:fontRef>
+        </p:style>
+        <p:txBody>
+          <a:bodyPr rtlCol="0" anchor="ctr"/>
+          <a:lstStyle/>
+          <a:p>
+            <a:pPr algn="ctr"/>
+          </a:p>
+        </p:txBody>
+      </p:sp>
+      <p:sp>
+        <p:nvSpPr>
+          <p:cNvPr id="18" name="Rounded Rectangle 17"/>
+          <p:cNvSpPr/>
+          <p:nvPr/>
+        </p:nvSpPr>
+        <p:spPr>
+          <a:xfrm>
+            <a:off x="5989320" y="4297680"/>
+            <a:ext cx="3794760" cy="548640"/>
+          </a:xfrm>
+          <a:prstGeom prst="roundRect">
+            <a:avLst/>
+          </a:prstGeom>
+          <a:solidFill>
+            <a:srgbClr val="EDE9FE"/>
+          </a:solidFill>
+          <a:ln>
+            <a:noFill/>
+          </a:ln>
+        </p:spPr>
+        <p:style>
+          <a:lnRef idx="1">
+            <a:schemeClr val="accent1"/>
+          </a:lnRef>
+          <a:fillRef idx="3">
+            <a:schemeClr val="accent1"/>
+          </a:fillRef>
+          <a:effectRef idx="2">
+            <a:schemeClr val="accent1"/>
+          </a:effectRef>
+          <a:fontRef idx="minor">
+            <a:schemeClr val="lt1"/>
+          </a:fontRef>
+        </p:style>
+        <p:txBody>
+          <a:bodyPr rtlCol="0" anchor="ctr"/>
+          <a:lstStyle/>
+          <a:p>
+            <a:pPr algn="ctr"/>
+          </a:p>
+        </p:txBody>
+      </p:sp>
+      <p:sp>
+        <p:nvSpPr>
+          <p:cNvPr id="19" name="Rectangle 18"/>
+          <p:cNvSpPr/>
+          <p:nvPr/>
+        </p:nvSpPr>
+        <p:spPr>
+          <a:xfrm>
+            <a:off x="1097280" y="2980944"/>
+            <a:ext cx="1005840" cy="182880"/>
           </a:xfrm>
           <a:prstGeom prst="rect">
             <a:avLst/>
@@ -9104,14 +9510,14 @@
       </p:sp>
       <p:sp>
         <p:nvSpPr>
-          <p:cNvPr id="16" name="Rectangle 15"/>
-          <p:cNvSpPr/>
-          <p:nvPr/>
-        </p:nvSpPr>
-        <p:spPr>
-          <a:xfrm>
-            <a:off x="1051560" y="5285232"/>
-            <a:ext cx="1005840" cy="182880"/>
+          <p:cNvPr id="20" name="Rectangle 19"/>
+          <p:cNvSpPr/>
+          <p:nvPr/>
+        </p:nvSpPr>
+        <p:spPr>
+          <a:xfrm>
+            <a:off x="6108192" y="4425696"/>
+            <a:ext cx="914400" cy="164592"/>
           </a:xfrm>
           <a:prstGeom prst="rect">
             <a:avLst/>
@@ -9156,14 +9562,14 @@
       </p:sp>
       <p:sp>
         <p:nvSpPr>
-          <p:cNvPr id="17" name="Rounded Rectangle 16"/>
-          <p:cNvSpPr/>
-          <p:nvPr/>
-        </p:nvSpPr>
-        <p:spPr>
-          <a:xfrm>
-            <a:off x="1051560" y="3154680"/>
-            <a:ext cx="1005840" cy="676656"/>
+          <p:cNvPr id="21" name="Rounded Rectangle 20"/>
+          <p:cNvSpPr/>
+          <p:nvPr/>
+        </p:nvSpPr>
+        <p:spPr>
+          <a:xfrm>
+            <a:off x="1078992" y="3310128"/>
+            <a:ext cx="1005840" cy="585216"/>
           </a:xfrm>
           <a:prstGeom prst="roundRect">
             <a:avLst/>
@@ -9199,7 +9605,7 @@
           <a:p>
             <a:pPr algn="ctr"/>
             <a:r>
-              <a:rPr sz="1800" b="1">
+              <a:rPr sz="1700" b="1">
                 <a:solidFill>
                   <a:srgbClr val="0F172A"/>
                 </a:solidFill>
@@ -9212,14 +9618,14 @@
       </p:sp>
       <p:sp>
         <p:nvSpPr>
-          <p:cNvPr id="18" name="Rounded Rectangle 17"/>
-          <p:cNvSpPr/>
-          <p:nvPr/>
-        </p:nvSpPr>
-        <p:spPr>
-          <a:xfrm>
-            <a:off x="2331720" y="3154680"/>
-            <a:ext cx="1280160" cy="676656"/>
+          <p:cNvPr id="22" name="Rounded Rectangle 21"/>
+          <p:cNvSpPr/>
+          <p:nvPr/>
+        </p:nvSpPr>
+        <p:spPr>
+          <a:xfrm>
+            <a:off x="2377440" y="3310128"/>
+            <a:ext cx="1234440" cy="585216"/>
           </a:xfrm>
           <a:prstGeom prst="roundRect">
             <a:avLst/>
@@ -9255,7 +9661,7 @@
           <a:p>
             <a:pPr algn="ctr"/>
             <a:r>
-              <a:rPr sz="1800" b="1">
+              <a:rPr sz="1700" b="1">
                 <a:solidFill>
                   <a:srgbClr val="0F172A"/>
                 </a:solidFill>
@@ -9268,14 +9674,14 @@
       </p:sp>
       <p:sp>
         <p:nvSpPr>
-          <p:cNvPr id="19" name="Rounded Rectangle 18"/>
-          <p:cNvSpPr/>
-          <p:nvPr/>
-        </p:nvSpPr>
-        <p:spPr>
-          <a:xfrm>
-            <a:off x="3886200" y="2999232"/>
-            <a:ext cx="1874519" cy="969264"/>
+          <p:cNvPr id="23" name="Rounded Rectangle 22"/>
+          <p:cNvSpPr/>
+          <p:nvPr/>
+        </p:nvSpPr>
+        <p:spPr>
+          <a:xfrm>
+            <a:off x="3950208" y="3163824"/>
+            <a:ext cx="1874519" cy="877824"/>
           </a:xfrm>
           <a:prstGeom prst="roundRect">
             <a:avLst/>
@@ -9311,7 +9717,7 @@
           <a:p>
             <a:pPr algn="ctr"/>
             <a:r>
-              <a:rPr sz="1800" b="1">
+              <a:rPr sz="1700" b="1">
                 <a:solidFill>
                   <a:srgbClr val="0F172A"/>
                 </a:solidFill>
@@ -9325,14 +9731,14 @@
       </p:sp>
       <p:sp>
         <p:nvSpPr>
-          <p:cNvPr id="20" name="Rounded Rectangle 19"/>
-          <p:cNvSpPr/>
-          <p:nvPr/>
-        </p:nvSpPr>
-        <p:spPr>
-          <a:xfrm>
-            <a:off x="6217920" y="2761488"/>
-            <a:ext cx="1965960" cy="768096"/>
+          <p:cNvPr id="24" name="Rounded Rectangle 23"/>
+          <p:cNvSpPr/>
+          <p:nvPr/>
+        </p:nvSpPr>
+        <p:spPr>
+          <a:xfrm>
+            <a:off x="6327648" y="2999232"/>
+            <a:ext cx="1874519" cy="658368"/>
           </a:xfrm>
           <a:prstGeom prst="roundRect">
             <a:avLst/>
@@ -9368,7 +9774,7 @@
           <a:p>
             <a:pPr algn="ctr"/>
             <a:r>
-              <a:rPr sz="1800" b="1">
+              <a:rPr sz="1700" b="1">
                 <a:solidFill>
                   <a:srgbClr val="0F172A"/>
                 </a:solidFill>
@@ -9382,14 +9788,14 @@
       </p:sp>
       <p:sp>
         <p:nvSpPr>
-          <p:cNvPr id="21" name="Rounded Rectangle 20"/>
-          <p:cNvSpPr/>
-          <p:nvPr/>
-        </p:nvSpPr>
-        <p:spPr>
-          <a:xfrm>
-            <a:off x="6217920" y="4187952"/>
-            <a:ext cx="1965960" cy="768096"/>
+          <p:cNvPr id="25" name="Rounded Rectangle 24"/>
+          <p:cNvSpPr/>
+          <p:nvPr/>
+        </p:nvSpPr>
+        <p:spPr>
+          <a:xfrm>
+            <a:off x="6327648" y="3675887"/>
+            <a:ext cx="1874519" cy="658368"/>
           </a:xfrm>
           <a:prstGeom prst="roundRect">
             <a:avLst/>
@@ -9425,7 +9831,7 @@
           <a:p>
             <a:pPr algn="ctr"/>
             <a:r>
-              <a:rPr sz="1800" b="1">
+              <a:rPr sz="1700" b="1">
                 <a:solidFill>
                   <a:srgbClr val="0F172A"/>
                 </a:solidFill>
@@ -9439,14 +9845,14 @@
       </p:sp>
       <p:sp>
         <p:nvSpPr>
-          <p:cNvPr id="22" name="Rounded Rectangle 21"/>
-          <p:cNvSpPr/>
-          <p:nvPr/>
-        </p:nvSpPr>
-        <p:spPr>
-          <a:xfrm>
-            <a:off x="8549640" y="3950208"/>
-            <a:ext cx="1920240" cy="960120"/>
+          <p:cNvPr id="26" name="Rounded Rectangle 25"/>
+          <p:cNvSpPr/>
+          <p:nvPr/>
+        </p:nvSpPr>
+        <p:spPr>
+          <a:xfrm>
+            <a:off x="8613648" y="3511296"/>
+            <a:ext cx="2148840" cy="841248"/>
           </a:xfrm>
           <a:prstGeom prst="roundRect">
             <a:avLst/>
@@ -9482,7 +9888,7 @@
           <a:p>
             <a:pPr algn="ctr"/>
             <a:r>
-              <a:rPr sz="1600" b="1">
+              <a:rPr sz="1500" b="1">
                 <a:solidFill>
                   <a:srgbClr val="0F172A"/>
                 </a:solidFill>
@@ -9496,14 +9902,14 @@
       </p:sp>
       <p:cxnSp>
         <p:nvCxnSpPr>
-          <p:cNvPr id="23" name="Connector 22"/>
+          <p:cNvPr id="27" name="Connector 26"/>
           <p:cNvCxnSpPr/>
           <p:nvPr/>
         </p:nvCxnSpPr>
         <p:spPr>
           <a:xfrm>
-            <a:off x="2057400" y="3493008"/>
-            <a:ext cx="274320" cy="0"/>
+            <a:off x="2084831" y="3602736"/>
+            <a:ext cx="292609" cy="0"/>
           </a:xfrm>
           <a:prstGeom prst="line">
             <a:avLst/>
@@ -9531,14 +9937,14 @@
       </p:cxnSp>
       <p:cxnSp>
         <p:nvCxnSpPr>
-          <p:cNvPr id="24" name="Connector 23"/>
+          <p:cNvPr id="28" name="Connector 27"/>
           <p:cNvCxnSpPr/>
           <p:nvPr/>
         </p:nvCxnSpPr>
         <p:spPr>
           <a:xfrm>
-            <a:off x="3611880" y="3493008"/>
-            <a:ext cx="274320" cy="0"/>
+            <a:off x="3611880" y="3602736"/>
+            <a:ext cx="338328" cy="0"/>
           </a:xfrm>
           <a:prstGeom prst="line">
             <a:avLst/>
@@ -9566,14 +9972,14 @@
       </p:cxnSp>
       <p:cxnSp>
         <p:nvCxnSpPr>
-          <p:cNvPr id="25" name="Connector 24"/>
+          <p:cNvPr id="29" name="Connector 28"/>
           <p:cNvCxnSpPr/>
           <p:nvPr/>
         </p:nvCxnSpPr>
         <p:spPr>
           <a:xfrm>
-            <a:off x="5760720" y="3493008"/>
-            <a:ext cx="457200" cy="1078992"/>
+            <a:off x="5824728" y="3602736"/>
+            <a:ext cx="502920" cy="402336"/>
           </a:xfrm>
           <a:prstGeom prst="line">
             <a:avLst/>
@@ -9601,14 +10007,14 @@
       </p:cxnSp>
       <p:cxnSp>
         <p:nvCxnSpPr>
-          <p:cNvPr id="26" name="Connector 25"/>
+          <p:cNvPr id="30" name="Connector 29"/>
           <p:cNvCxnSpPr/>
           <p:nvPr/>
         </p:nvCxnSpPr>
         <p:spPr>
           <a:xfrm flipV="1">
-            <a:off x="8183879" y="4434840"/>
-            <a:ext cx="365761" cy="137160"/>
+            <a:off x="8202168" y="3931920"/>
+            <a:ext cx="411480" cy="73152"/>
           </a:xfrm>
           <a:prstGeom prst="line">
             <a:avLst/>
@@ -9634,16 +10040,68 @@
           </a:fontRef>
         </p:style>
       </p:cxnSp>
+      <p:sp>
+        <p:nvSpPr>
+          <p:cNvPr id="31" name="Rectangle 30"/>
+          <p:cNvSpPr/>
+          <p:nvPr/>
+        </p:nvSpPr>
+        <p:spPr>
+          <a:xfrm>
+            <a:off x="4983480" y="2944368"/>
+            <a:ext cx="914400" cy="237744"/>
+          </a:xfrm>
+          <a:prstGeom prst="rect">
+            <a:avLst/>
+          </a:prstGeom>
+          <a:noFill/>
+          <a:ln>
+            <a:noFill/>
+          </a:ln>
+        </p:spPr>
+        <p:style>
+          <a:lnRef idx="1">
+            <a:schemeClr val="accent1"/>
+          </a:lnRef>
+          <a:fillRef idx="3">
+            <a:schemeClr val="accent1"/>
+          </a:fillRef>
+          <a:effectRef idx="2">
+            <a:schemeClr val="accent1"/>
+          </a:effectRef>
+          <a:fontRef idx="minor">
+            <a:schemeClr val="lt1"/>
+          </a:fontRef>
+        </p:style>
+        <p:txBody>
+          <a:bodyPr rtlCol="0" anchor="ctr" wrap="square" lIns="73152" rIns="73152" tIns="73152" bIns="73152">
+            <a:noAutofit/>
+          </a:bodyPr>
+          <a:lstStyle/>
+          <a:p>
+            <a:pPr algn="ctr"/>
+            <a:r>
+              <a:rPr sz="1100" b="1">
+                <a:solidFill>
+                  <a:srgbClr val="64748B"/>
+                </a:solidFill>
+                <a:latin typeface="Aptos"/>
+              </a:rPr>
+              <a:t>selects decode</a:t>
+            </a:r>
+          </a:p>
+        </p:txBody>
+      </p:sp>
       <p:cxnSp>
         <p:nvCxnSpPr>
-          <p:cNvPr id="27" name="Connector 26"/>
+          <p:cNvPr id="32" name="Connector 31"/>
           <p:cNvCxnSpPr/>
           <p:nvPr/>
         </p:nvCxnSpPr>
         <p:spPr>
           <a:xfrm flipV="1">
-            <a:off x="5760720" y="3127248"/>
-            <a:ext cx="457200" cy="237744"/>
+            <a:off x="5824728" y="3328416"/>
+            <a:ext cx="502920" cy="164592"/>
           </a:xfrm>
           <a:prstGeom prst="line">
             <a:avLst/>
@@ -9671,14 +10129,14 @@
       </p:cxnSp>
       <p:sp>
         <p:nvSpPr>
-          <p:cNvPr id="28" name="Rectangle 27"/>
-          <p:cNvSpPr/>
-          <p:nvPr/>
-        </p:nvSpPr>
-        <p:spPr>
-          <a:xfrm>
-            <a:off x="5074920" y="2743200"/>
-            <a:ext cx="868680" cy="274320"/>
+          <p:cNvPr id="33" name="Rectangle 32"/>
+          <p:cNvSpPr/>
+          <p:nvPr/>
+        </p:nvSpPr>
+        <p:spPr>
+          <a:xfrm>
+            <a:off x="5010912" y="2761488"/>
+            <a:ext cx="932688" cy="219456"/>
           </a:xfrm>
           <a:prstGeom prst="rect">
             <a:avLst/>
@@ -9710,27 +10168,27 @@
           <a:p>
             <a:pPr algn="ctr"/>
             <a:r>
-              <a:rPr sz="1100" b="1">
+              <a:rPr sz="1000" b="1">
                 <a:solidFill>
                   <a:srgbClr val="64748B"/>
                 </a:solidFill>
                 <a:latin typeface="Aptos"/>
               </a:rPr>
-              <a:t>selects</a:t>
+              <a:t>optional prefill</a:t>
             </a:r>
           </a:p>
         </p:txBody>
       </p:sp>
       <p:cxnSp>
         <p:nvCxnSpPr>
-          <p:cNvPr id="29" name="Connector 28"/>
+          <p:cNvPr id="34" name="Connector 33"/>
           <p:cNvCxnSpPr/>
           <p:nvPr/>
         </p:nvCxnSpPr>
         <p:spPr>
           <a:xfrm>
-            <a:off x="8183879" y="3145536"/>
-            <a:ext cx="365761" cy="1152144"/>
+            <a:off x="8202168" y="3328416"/>
+            <a:ext cx="411480" cy="420623"/>
           </a:xfrm>
           <a:prstGeom prst="line">
             <a:avLst/>
@@ -9758,14 +10216,14 @@
       </p:cxnSp>
       <p:sp>
         <p:nvSpPr>
-          <p:cNvPr id="30" name="Rounded Rectangle 29"/>
-          <p:cNvSpPr/>
-          <p:nvPr/>
-        </p:nvSpPr>
-        <p:spPr>
-          <a:xfrm>
-            <a:off x="8065008" y="3364992"/>
-            <a:ext cx="822960" cy="256032"/>
+          <p:cNvPr id="35" name="Rounded Rectangle 34"/>
+          <p:cNvSpPr/>
+          <p:nvPr/>
+        </p:nvSpPr>
+        <p:spPr>
+          <a:xfrm>
+            <a:off x="8046720" y="3218688"/>
+            <a:ext cx="868680" cy="256032"/>
           </a:xfrm>
           <a:prstGeom prst="roundRect">
             <a:avLst/>
@@ -9814,14 +10272,14 @@
       </p:sp>
       <p:sp>
         <p:nvSpPr>
-          <p:cNvPr id="31" name="Rounded Rectangle 30"/>
-          <p:cNvSpPr/>
-          <p:nvPr/>
-        </p:nvSpPr>
-        <p:spPr>
-          <a:xfrm>
-            <a:off x="1005840" y="5504688"/>
-            <a:ext cx="4160520" cy="384048"/>
+          <p:cNvPr id="36" name="Rounded Rectangle 35"/>
+          <p:cNvSpPr/>
+          <p:nvPr/>
+        </p:nvSpPr>
+        <p:spPr>
+          <a:xfrm>
+            <a:off x="987552" y="5047488"/>
+            <a:ext cx="4800600" cy="512064"/>
           </a:xfrm>
           <a:prstGeom prst="roundRect">
             <a:avLst/>
@@ -9857,14 +10315,14 @@
       </p:sp>
       <p:sp>
         <p:nvSpPr>
-          <p:cNvPr id="32" name="Rectangle 31"/>
-          <p:cNvSpPr/>
-          <p:nvPr/>
-        </p:nvSpPr>
-        <p:spPr>
-          <a:xfrm>
-            <a:off x="1078992" y="5568696"/>
-            <a:ext cx="4023360" cy="219456"/>
+          <p:cNvPr id="37" name="Rectangle 36"/>
+          <p:cNvSpPr/>
+          <p:nvPr/>
+        </p:nvSpPr>
+        <p:spPr>
+          <a:xfrm>
+            <a:off x="1133856" y="5175504"/>
+            <a:ext cx="4526280" cy="219456"/>
           </a:xfrm>
           <a:prstGeom prst="rect">
             <a:avLst/>
@@ -9902,21 +10360,21 @@
                 </a:solidFill>
                 <a:latin typeface="Aptos"/>
               </a:rPr>
-              <a:t>Request routing and KV transfer are separate paths.</a:t>
-            </a:r>
-          </a:p>
-        </p:txBody>
-      </p:sp>
-      <p:sp>
-        <p:nvSpPr>
-          <p:cNvPr id="33" name="Rounded Rectangle 32"/>
-          <p:cNvSpPr/>
-          <p:nvPr/>
-        </p:nvSpPr>
-        <p:spPr>
-          <a:xfrm>
-            <a:off x="5623560" y="5504688"/>
-            <a:ext cx="5212080" cy="384048"/>
+              <a:t>Client traffic and KV-cache movement follow different paths.</a:t>
+            </a:r>
+          </a:p>
+        </p:txBody>
+      </p:sp>
+      <p:sp>
+        <p:nvSpPr>
+          <p:cNvPr id="38" name="Rounded Rectangle 37"/>
+          <p:cNvSpPr/>
+          <p:nvPr/>
+        </p:nvSpPr>
+        <p:spPr>
+          <a:xfrm>
+            <a:off x="5989320" y="5047488"/>
+            <a:ext cx="5074920" cy="512064"/>
           </a:xfrm>
           <a:prstGeom prst="roundRect">
             <a:avLst/>
@@ -9952,14 +10410,14 @@
       </p:sp>
       <p:sp>
         <p:nvSpPr>
-          <p:cNvPr id="34" name="Rectangle 33"/>
-          <p:cNvSpPr/>
-          <p:nvPr/>
-        </p:nvSpPr>
-        <p:spPr>
-          <a:xfrm>
-            <a:off x="5742432" y="5568696"/>
-            <a:ext cx="4956048" cy="219456"/>
+          <p:cNvPr id="39" name="Rectangle 38"/>
+          <p:cNvSpPr/>
+          <p:nvPr/>
+        </p:nvSpPr>
+        <p:spPr>
+          <a:xfrm>
+            <a:off x="6144768" y="5175504"/>
+            <a:ext cx="4754880" cy="219456"/>
           </a:xfrm>
           <a:prstGeom prst="rect">
             <a:avLst/>
@@ -9997,7 +10455,7 @@
                 </a:solidFill>
                 <a:latin typeface="Aptos"/>
               </a:rPr>
-              <a:t>KAITO owns topology + wiring; GWIE carries the contract; llm-d owns EPP decisions; vLLM/NIXL own execution + handoff.</a:t>
+              <a:t>KAITO owns topology + wiring; GWIE carries the contract; llm-d owns EPP decisions.</a:t>
             </a:r>
           </a:p>
         </p:txBody>
@@ -11993,8 +12451,176 @@
         </p:nvSpPr>
         <p:spPr>
           <a:xfrm>
-            <a:off x="658368" y="1783080"/>
-            <a:ext cx="1280160" cy="566928"/>
+            <a:off x="841248" y="1572768"/>
+            <a:ext cx="1005840" cy="256032"/>
+          </a:xfrm>
+          <a:prstGeom prst="roundRect">
+            <a:avLst/>
+          </a:prstGeom>
+          <a:solidFill>
+            <a:srgbClr val="DBEAFE"/>
+          </a:solidFill>
+          <a:ln w="13970">
+            <a:solidFill>
+              <a:srgbClr val="2563EB"/>
+            </a:solidFill>
+          </a:ln>
+        </p:spPr>
+        <p:style>
+          <a:lnRef idx="1">
+            <a:schemeClr val="accent1"/>
+          </a:lnRef>
+          <a:fillRef idx="3">
+            <a:schemeClr val="accent1"/>
+          </a:fillRef>
+          <a:effectRef idx="2">
+            <a:schemeClr val="accent1"/>
+          </a:effectRef>
+          <a:fontRef idx="minor">
+            <a:schemeClr val="lt1"/>
+          </a:fontRef>
+        </p:style>
+        <p:txBody>
+          <a:bodyPr rtlCol="0" anchor="ctr" wrap="square" lIns="73152" rIns="73152" tIns="73152" bIns="73152">
+            <a:noAutofit/>
+          </a:bodyPr>
+          <a:lstStyle/>
+          <a:p>
+            <a:pPr algn="ctr"/>
+            <a:r>
+              <a:rPr sz="1100" b="1">
+                <a:solidFill>
+                  <a:srgbClr val="2563EB"/>
+                </a:solidFill>
+                <a:latin typeface="Aptos"/>
+              </a:rPr>
+              <a:t>request path</a:t>
+            </a:r>
+          </a:p>
+        </p:txBody>
+      </p:sp>
+      <p:sp>
+        <p:nvSpPr>
+          <p:cNvPr id="8" name="Rounded Rectangle 7"/>
+          <p:cNvSpPr/>
+          <p:nvPr/>
+        </p:nvSpPr>
+        <p:spPr>
+          <a:xfrm>
+            <a:off x="6912864" y="2770632"/>
+            <a:ext cx="914400" cy="256032"/>
+          </a:xfrm>
+          <a:prstGeom prst="roundRect">
+            <a:avLst/>
+          </a:prstGeom>
+          <a:solidFill>
+            <a:srgbClr val="FFEDD5"/>
+          </a:solidFill>
+          <a:ln w="13970">
+            <a:solidFill>
+              <a:srgbClr val="EA580C"/>
+            </a:solidFill>
+          </a:ln>
+        </p:spPr>
+        <p:style>
+          <a:lnRef idx="1">
+            <a:schemeClr val="accent1"/>
+          </a:lnRef>
+          <a:fillRef idx="3">
+            <a:schemeClr val="accent1"/>
+          </a:fillRef>
+          <a:effectRef idx="2">
+            <a:schemeClr val="accent1"/>
+          </a:effectRef>
+          <a:fontRef idx="minor">
+            <a:schemeClr val="lt1"/>
+          </a:fontRef>
+        </p:style>
+        <p:txBody>
+          <a:bodyPr rtlCol="0" anchor="ctr" wrap="square" lIns="73152" rIns="73152" tIns="73152" bIns="73152">
+            <a:noAutofit/>
+          </a:bodyPr>
+          <a:lstStyle/>
+          <a:p>
+            <a:pPr algn="ctr"/>
+            <a:r>
+              <a:rPr sz="1100" b="1">
+                <a:solidFill>
+                  <a:srgbClr val="EA580C"/>
+                </a:solidFill>
+                <a:latin typeface="Aptos"/>
+              </a:rPr>
+              <a:t>prefill path</a:t>
+            </a:r>
+          </a:p>
+        </p:txBody>
+      </p:sp>
+      <p:sp>
+        <p:nvSpPr>
+          <p:cNvPr id="9" name="Rounded Rectangle 8"/>
+          <p:cNvSpPr/>
+          <p:nvPr/>
+        </p:nvSpPr>
+        <p:spPr>
+          <a:xfrm>
+            <a:off x="8211312" y="3035808"/>
+            <a:ext cx="914400" cy="256032"/>
+          </a:xfrm>
+          <a:prstGeom prst="roundRect">
+            <a:avLst/>
+          </a:prstGeom>
+          <a:solidFill>
+            <a:srgbClr val="EDE9FE"/>
+          </a:solidFill>
+          <a:ln w="13970">
+            <a:solidFill>
+              <a:srgbClr val="6D28D9"/>
+            </a:solidFill>
+          </a:ln>
+        </p:spPr>
+        <p:style>
+          <a:lnRef idx="1">
+            <a:schemeClr val="accent1"/>
+          </a:lnRef>
+          <a:fillRef idx="3">
+            <a:schemeClr val="accent1"/>
+          </a:fillRef>
+          <a:effectRef idx="2">
+            <a:schemeClr val="accent1"/>
+          </a:effectRef>
+          <a:fontRef idx="minor">
+            <a:schemeClr val="lt1"/>
+          </a:fontRef>
+        </p:style>
+        <p:txBody>
+          <a:bodyPr rtlCol="0" anchor="ctr" wrap="square" lIns="73152" rIns="73152" tIns="73152" bIns="73152">
+            <a:noAutofit/>
+          </a:bodyPr>
+          <a:lstStyle/>
+          <a:p>
+            <a:pPr algn="ctr"/>
+            <a:r>
+              <a:rPr sz="1100" b="1">
+                <a:solidFill>
+                  <a:srgbClr val="6D28D9"/>
+                </a:solidFill>
+                <a:latin typeface="Aptos"/>
+              </a:rPr>
+              <a:t>KV path</a:t>
+            </a:r>
+          </a:p>
+        </p:txBody>
+      </p:sp>
+      <p:sp>
+        <p:nvSpPr>
+          <p:cNvPr id="10" name="Rounded Rectangle 9"/>
+          <p:cNvSpPr/>
+          <p:nvPr/>
+        </p:nvSpPr>
+        <p:spPr>
+          <a:xfrm>
+            <a:off x="658368" y="1810512"/>
+            <a:ext cx="1051560" cy="585216"/>
           </a:xfrm>
           <a:prstGeom prst="roundRect">
             <a:avLst/>
@@ -12030,27 +12656,27 @@
           <a:p>
             <a:pPr algn="ctr"/>
             <a:r>
-              <a:rPr sz="1500" b="1">
+              <a:rPr sz="1400" b="1">
                 <a:solidFill>
                   <a:srgbClr val="0F172A"/>
                 </a:solidFill>
                 <a:latin typeface="Aptos"/>
               </a:rPr>
-              <a:t>Client</a:t>
-            </a:r>
-          </a:p>
-        </p:txBody>
-      </p:sp>
-      <p:sp>
-        <p:nvSpPr>
-          <p:cNvPr id="8" name="Rounded Rectangle 7"/>
-          <p:cNvSpPr/>
-          <p:nvPr/>
-        </p:nvSpPr>
-        <p:spPr>
-          <a:xfrm>
-            <a:off x="1920240" y="1783080"/>
-            <a:ext cx="1280160" cy="566928"/>
+              <a:t>1  Client</a:t>
+            </a:r>
+          </a:p>
+        </p:txBody>
+      </p:sp>
+      <p:sp>
+        <p:nvSpPr>
+          <p:cNvPr id="11" name="Rounded Rectangle 10"/>
+          <p:cNvSpPr/>
+          <p:nvPr/>
+        </p:nvSpPr>
+        <p:spPr>
+          <a:xfrm>
+            <a:off x="1965960" y="1810512"/>
+            <a:ext cx="1280160" cy="585216"/>
           </a:xfrm>
           <a:prstGeom prst="roundRect">
             <a:avLst/>
@@ -12086,27 +12712,27 @@
           <a:p>
             <a:pPr algn="ctr"/>
             <a:r>
-              <a:rPr sz="1500" b="1">
+              <a:rPr sz="1400" b="1">
                 <a:solidFill>
                   <a:srgbClr val="0F172A"/>
                 </a:solidFill>
                 <a:latin typeface="Aptos"/>
               </a:rPr>
-              <a:t>Gateway</a:t>
-            </a:r>
-          </a:p>
-        </p:txBody>
-      </p:sp>
-      <p:sp>
-        <p:nvSpPr>
-          <p:cNvPr id="9" name="Rounded Rectangle 8"/>
-          <p:cNvSpPr/>
-          <p:nvPr/>
-        </p:nvSpPr>
-        <p:spPr>
-          <a:xfrm>
-            <a:off x="3291840" y="1783080"/>
-            <a:ext cx="1280160" cy="566928"/>
+              <a:t>2  Gateway</a:t>
+            </a:r>
+          </a:p>
+        </p:txBody>
+      </p:sp>
+      <p:sp>
+        <p:nvSpPr>
+          <p:cNvPr id="12" name="Rounded Rectangle 11"/>
+          <p:cNvSpPr/>
+          <p:nvPr/>
+        </p:nvSpPr>
+        <p:spPr>
+          <a:xfrm>
+            <a:off x="3520440" y="1810512"/>
+            <a:ext cx="1508760" cy="585216"/>
           </a:xfrm>
           <a:prstGeom prst="roundRect">
             <a:avLst/>
@@ -12142,27 +12768,27 @@
           <a:p>
             <a:pPr algn="ctr"/>
             <a:r>
-              <a:rPr sz="1500" b="1">
+              <a:rPr sz="1400" b="1">
                 <a:solidFill>
                   <a:srgbClr val="0F172A"/>
                 </a:solidFill>
                 <a:latin typeface="Aptos"/>
               </a:rPr>
-              <a:t>InferencePool</a:t>
-            </a:r>
-          </a:p>
-        </p:txBody>
-      </p:sp>
-      <p:sp>
-        <p:nvSpPr>
-          <p:cNvPr id="10" name="Rounded Rectangle 9"/>
-          <p:cNvSpPr/>
-          <p:nvPr/>
-        </p:nvSpPr>
-        <p:spPr>
-          <a:xfrm>
-            <a:off x="4919472" y="1783080"/>
-            <a:ext cx="1280160" cy="566928"/>
+              <a:t>3  InferencePool</a:t>
+            </a:r>
+          </a:p>
+        </p:txBody>
+      </p:sp>
+      <p:sp>
+        <p:nvSpPr>
+          <p:cNvPr id="13" name="Rounded Rectangle 12"/>
+          <p:cNvSpPr/>
+          <p:nvPr/>
+        </p:nvSpPr>
+        <p:spPr>
+          <a:xfrm>
+            <a:off x="5440680" y="1810512"/>
+            <a:ext cx="1783080" cy="585216"/>
           </a:xfrm>
           <a:prstGeom prst="roundRect">
             <a:avLst/>
@@ -12198,27 +12824,27 @@
           <a:p>
             <a:pPr algn="ctr"/>
             <a:r>
-              <a:rPr sz="1500" b="1">
+              <a:rPr sz="1400" b="1">
                 <a:solidFill>
                   <a:srgbClr val="0F172A"/>
                 </a:solidFill>
                 <a:latin typeface="Aptos"/>
               </a:rPr>
-              <a:t>llm-d Router EPP</a:t>
-            </a:r>
-          </a:p>
-        </p:txBody>
-      </p:sp>
-      <p:sp>
-        <p:nvSpPr>
-          <p:cNvPr id="11" name="Rounded Rectangle 10"/>
-          <p:cNvSpPr/>
-          <p:nvPr/>
-        </p:nvSpPr>
-        <p:spPr>
-          <a:xfrm>
-            <a:off x="6949440" y="1783080"/>
-            <a:ext cx="1280160" cy="566928"/>
+              <a:t>4  llm-d Router EPP</a:t>
+            </a:r>
+          </a:p>
+        </p:txBody>
+      </p:sp>
+      <p:sp>
+        <p:nvSpPr>
+          <p:cNvPr id="14" name="Rounded Rectangle 13"/>
+          <p:cNvSpPr/>
+          <p:nvPr/>
+        </p:nvSpPr>
+        <p:spPr>
+          <a:xfrm>
+            <a:off x="7662672" y="1810512"/>
+            <a:ext cx="1645920" cy="585216"/>
           </a:xfrm>
           <a:prstGeom prst="roundRect">
             <a:avLst/>
@@ -12254,27 +12880,27 @@
           <a:p>
             <a:pPr algn="ctr"/>
             <a:r>
-              <a:rPr sz="1500" b="1">
+              <a:rPr sz="1400" b="1">
                 <a:solidFill>
                   <a:srgbClr val="0F172A"/>
                 </a:solidFill>
                 <a:latin typeface="Aptos"/>
               </a:rPr>
-              <a:t>Decode sidecar</a:t>
-            </a:r>
-          </a:p>
-        </p:txBody>
-      </p:sp>
-      <p:sp>
-        <p:nvSpPr>
-          <p:cNvPr id="12" name="Rounded Rectangle 11"/>
-          <p:cNvSpPr/>
-          <p:nvPr/>
-        </p:nvSpPr>
-        <p:spPr>
-          <a:xfrm>
-            <a:off x="9144000" y="1783080"/>
-            <a:ext cx="1280160" cy="566928"/>
+              <a:t>5  Decode sidecar</a:t>
+            </a:r>
+          </a:p>
+        </p:txBody>
+      </p:sp>
+      <p:sp>
+        <p:nvSpPr>
+          <p:cNvPr id="15" name="Rounded Rectangle 14"/>
+          <p:cNvSpPr/>
+          <p:nvPr/>
+        </p:nvSpPr>
+        <p:spPr>
+          <a:xfrm>
+            <a:off x="9921240" y="1810512"/>
+            <a:ext cx="1325880" cy="585216"/>
           </a:xfrm>
           <a:prstGeom prst="roundRect">
             <a:avLst/>
@@ -12310,122 +12936,17 @@
           <a:p>
             <a:pPr algn="ctr"/>
             <a:r>
-              <a:rPr sz="1500" b="1">
+              <a:rPr sz="1400" b="1">
                 <a:solidFill>
                   <a:srgbClr val="0F172A"/>
                 </a:solidFill>
                 <a:latin typeface="Aptos"/>
               </a:rPr>
-              <a:t>Decode vLLM</a:t>
-            </a:r>
-          </a:p>
-        </p:txBody>
-      </p:sp>
-      <p:cxnSp>
-        <p:nvCxnSpPr>
-          <p:cNvPr id="13" name="Connector 12"/>
-          <p:cNvCxnSpPr/>
-          <p:nvPr/>
-        </p:nvCxnSpPr>
-        <p:spPr>
-          <a:xfrm flipH="1">
-            <a:off x="1920240" y="2066544"/>
-            <a:ext cx="18288" cy="0"/>
-          </a:xfrm>
-          <a:prstGeom prst="line">
-            <a:avLst/>
-          </a:prstGeom>
-          <a:ln w="30480">
-            <a:solidFill>
-              <a:srgbClr val="2563EB"/>
-            </a:solidFill>
-          </a:ln>
-        </p:spPr>
-        <p:style>
-          <a:lnRef idx="2">
-            <a:schemeClr val="accent1"/>
-          </a:lnRef>
-          <a:fillRef idx="0">
-            <a:schemeClr val="accent1"/>
-          </a:fillRef>
-          <a:effectRef idx="1">
-            <a:schemeClr val="accent1"/>
-          </a:effectRef>
-          <a:fontRef idx="minor">
-            <a:schemeClr val="tx1"/>
-          </a:fontRef>
-        </p:style>
-      </p:cxnSp>
-      <p:cxnSp>
-        <p:nvCxnSpPr>
-          <p:cNvPr id="14" name="Connector 13"/>
-          <p:cNvCxnSpPr/>
-          <p:nvPr/>
-        </p:nvCxnSpPr>
-        <p:spPr>
-          <a:xfrm>
-            <a:off x="3200400" y="2066544"/>
-            <a:ext cx="91440" cy="0"/>
-          </a:xfrm>
-          <a:prstGeom prst="line">
-            <a:avLst/>
-          </a:prstGeom>
-          <a:ln w="30480">
-            <a:solidFill>
-              <a:srgbClr val="2563EB"/>
-            </a:solidFill>
-          </a:ln>
-        </p:spPr>
-        <p:style>
-          <a:lnRef idx="2">
-            <a:schemeClr val="accent1"/>
-          </a:lnRef>
-          <a:fillRef idx="0">
-            <a:schemeClr val="accent1"/>
-          </a:fillRef>
-          <a:effectRef idx="1">
-            <a:schemeClr val="accent1"/>
-          </a:effectRef>
-          <a:fontRef idx="minor">
-            <a:schemeClr val="tx1"/>
-          </a:fontRef>
-        </p:style>
-      </p:cxnSp>
-      <p:cxnSp>
-        <p:nvCxnSpPr>
-          <p:cNvPr id="15" name="Connector 14"/>
-          <p:cNvCxnSpPr/>
-          <p:nvPr/>
-        </p:nvCxnSpPr>
-        <p:spPr>
-          <a:xfrm>
-            <a:off x="4572000" y="2066544"/>
-            <a:ext cx="347472" cy="0"/>
-          </a:xfrm>
-          <a:prstGeom prst="line">
-            <a:avLst/>
-          </a:prstGeom>
-          <a:ln w="30480">
-            <a:solidFill>
-              <a:srgbClr val="2563EB"/>
-            </a:solidFill>
-          </a:ln>
-        </p:spPr>
-        <p:style>
-          <a:lnRef idx="2">
-            <a:schemeClr val="accent1"/>
-          </a:lnRef>
-          <a:fillRef idx="0">
-            <a:schemeClr val="accent1"/>
-          </a:fillRef>
-          <a:effectRef idx="1">
-            <a:schemeClr val="accent1"/>
-          </a:effectRef>
-          <a:fontRef idx="minor">
-            <a:schemeClr val="tx1"/>
-          </a:fontRef>
-        </p:style>
-      </p:cxnSp>
+              <a:t>6  Decode vLLM</a:t>
+            </a:r>
+          </a:p>
+        </p:txBody>
+      </p:sp>
       <p:cxnSp>
         <p:nvCxnSpPr>
           <p:cNvPr id="16" name="Connector 15"/>
@@ -12434,13 +12955,13 @@
         </p:nvCxnSpPr>
         <p:spPr>
           <a:xfrm>
-            <a:off x="6199632" y="2066544"/>
-            <a:ext cx="749808" cy="0"/>
+            <a:off x="1709928" y="2103120"/>
+            <a:ext cx="256032" cy="0"/>
           </a:xfrm>
           <a:prstGeom prst="line">
             <a:avLst/>
           </a:prstGeom>
-          <a:ln w="30480">
+          <a:ln w="31750">
             <a:solidFill>
               <a:srgbClr val="2563EB"/>
             </a:solidFill>
@@ -12469,13 +12990,13 @@
         </p:nvCxnSpPr>
         <p:spPr>
           <a:xfrm>
-            <a:off x="8229600" y="2066544"/>
-            <a:ext cx="914400" cy="0"/>
+            <a:off x="3246120" y="2103120"/>
+            <a:ext cx="274320" cy="0"/>
           </a:xfrm>
           <a:prstGeom prst="line">
             <a:avLst/>
           </a:prstGeom>
-          <a:ln w="30480">
+          <a:ln w="31750">
             <a:solidFill>
               <a:srgbClr val="2563EB"/>
             </a:solidFill>
@@ -12496,62 +13017,41 @@
           </a:fontRef>
         </p:style>
       </p:cxnSp>
-      <p:sp>
-        <p:nvSpPr>
-          <p:cNvPr id="18" name="Rounded Rectangle 17"/>
-          <p:cNvSpPr/>
-          <p:nvPr/>
-        </p:nvSpPr>
-        <p:spPr>
-          <a:xfrm>
-            <a:off x="6949440" y="2907792"/>
-            <a:ext cx="1280160" cy="566928"/>
-          </a:xfrm>
-          <a:prstGeom prst="roundRect">
-            <a:avLst/>
-          </a:prstGeom>
-          <a:solidFill>
-            <a:srgbClr val="FFEDD5"/>
-          </a:solidFill>
-          <a:ln w="13970">
+      <p:cxnSp>
+        <p:nvCxnSpPr>
+          <p:cNvPr id="18" name="Connector 17"/>
+          <p:cNvCxnSpPr/>
+          <p:nvPr/>
+        </p:nvCxnSpPr>
+        <p:spPr>
+          <a:xfrm>
+            <a:off x="5029200" y="2103120"/>
+            <a:ext cx="411480" cy="0"/>
+          </a:xfrm>
+          <a:prstGeom prst="line">
+            <a:avLst/>
+          </a:prstGeom>
+          <a:ln w="31750">
             <a:solidFill>
-              <a:srgbClr val="EA580C"/>
+              <a:srgbClr val="2563EB"/>
             </a:solidFill>
           </a:ln>
         </p:spPr>
         <p:style>
-          <a:lnRef idx="1">
-            <a:schemeClr val="accent1"/>
-          </a:lnRef>
-          <a:fillRef idx="3">
-            <a:schemeClr val="accent1"/>
-          </a:fillRef>
-          <a:effectRef idx="2">
-            <a:schemeClr val="accent1"/>
-          </a:effectRef>
-          <a:fontRef idx="minor">
-            <a:schemeClr val="lt1"/>
-          </a:fontRef>
-        </p:style>
-        <p:txBody>
-          <a:bodyPr rtlCol="0" anchor="ctr" wrap="square" lIns="73152" rIns="73152" tIns="73152" bIns="73152">
-            <a:noAutofit/>
-          </a:bodyPr>
-          <a:lstStyle/>
-          <a:p>
-            <a:pPr algn="ctr"/>
-            <a:r>
-              <a:rPr sz="1500" b="1">
-                <a:solidFill>
-                  <a:srgbClr val="0F172A"/>
-                </a:solidFill>
-                <a:latin typeface="Aptos"/>
-              </a:rPr>
-              <a:t>Prefill</a:t>
-            </a:r>
-          </a:p>
-        </p:txBody>
-      </p:sp>
+          <a:lnRef idx="2">
+            <a:schemeClr val="accent1"/>
+          </a:lnRef>
+          <a:fillRef idx="0">
+            <a:schemeClr val="accent1"/>
+          </a:fillRef>
+          <a:effectRef idx="1">
+            <a:schemeClr val="accent1"/>
+          </a:effectRef>
+          <a:fontRef idx="minor">
+            <a:schemeClr val="tx1"/>
+          </a:fontRef>
+        </p:style>
+      </p:cxnSp>
       <p:cxnSp>
         <p:nvCxnSpPr>
           <p:cNvPr id="19" name="Connector 18"/>
@@ -12560,15 +13060,15 @@
         </p:nvCxnSpPr>
         <p:spPr>
           <a:xfrm>
-            <a:off x="7589520" y="2350008"/>
-            <a:ext cx="0" cy="557784"/>
+            <a:off x="7223760" y="2103120"/>
+            <a:ext cx="438912" cy="0"/>
           </a:xfrm>
           <a:prstGeom prst="line">
             <a:avLst/>
           </a:prstGeom>
-          <a:ln w="30480">
+          <a:ln w="31750">
             <a:solidFill>
-              <a:srgbClr val="6D28D9"/>
+              <a:srgbClr val="2563EB"/>
             </a:solidFill>
           </a:ln>
         </p:spPr>
@@ -12594,14 +13094,192 @@
           <p:nvPr/>
         </p:nvCxnSpPr>
         <p:spPr>
+          <a:xfrm>
+            <a:off x="9308592" y="2103120"/>
+            <a:ext cx="612648" cy="0"/>
+          </a:xfrm>
+          <a:prstGeom prst="line">
+            <a:avLst/>
+          </a:prstGeom>
+          <a:ln w="31750">
+            <a:solidFill>
+              <a:srgbClr val="2563EB"/>
+            </a:solidFill>
+          </a:ln>
+        </p:spPr>
+        <p:style>
+          <a:lnRef idx="2">
+            <a:schemeClr val="accent1"/>
+          </a:lnRef>
+          <a:fillRef idx="0">
+            <a:schemeClr val="accent1"/>
+          </a:fillRef>
+          <a:effectRef idx="1">
+            <a:schemeClr val="accent1"/>
+          </a:effectRef>
+          <a:fontRef idx="minor">
+            <a:schemeClr val="tx1"/>
+          </a:fontRef>
+        </p:style>
+      </p:cxnSp>
+      <p:sp>
+        <p:nvSpPr>
+          <p:cNvPr id="21" name="Rounded Rectangle 20"/>
+          <p:cNvSpPr/>
+          <p:nvPr/>
+        </p:nvSpPr>
+        <p:spPr>
+          <a:xfrm>
+            <a:off x="7635240" y="3017520"/>
+            <a:ext cx="1664208" cy="585216"/>
+          </a:xfrm>
+          <a:prstGeom prst="roundRect">
+            <a:avLst/>
+          </a:prstGeom>
+          <a:solidFill>
+            <a:srgbClr val="FFEDD5"/>
+          </a:solidFill>
+          <a:ln w="13970">
+            <a:solidFill>
+              <a:srgbClr val="EA580C"/>
+            </a:solidFill>
+          </a:ln>
+        </p:spPr>
+        <p:style>
+          <a:lnRef idx="1">
+            <a:schemeClr val="accent1"/>
+          </a:lnRef>
+          <a:fillRef idx="3">
+            <a:schemeClr val="accent1"/>
+          </a:fillRef>
+          <a:effectRef idx="2">
+            <a:schemeClr val="accent1"/>
+          </a:effectRef>
+          <a:fontRef idx="minor">
+            <a:schemeClr val="lt1"/>
+          </a:fontRef>
+        </p:style>
+        <p:txBody>
+          <a:bodyPr rtlCol="0" anchor="ctr" wrap="square" lIns="73152" rIns="73152" tIns="73152" bIns="73152">
+            <a:noAutofit/>
+          </a:bodyPr>
+          <a:lstStyle/>
+          <a:p>
+            <a:pPr algn="ctr"/>
+            <a:r>
+              <a:rPr sz="1500" b="1">
+                <a:solidFill>
+                  <a:srgbClr val="0F172A"/>
+                </a:solidFill>
+                <a:latin typeface="Aptos"/>
+              </a:rPr>
+              <a:t>Prefill</a:t>
+            </a:r>
+          </a:p>
+        </p:txBody>
+      </p:sp>
+      <p:cxnSp>
+        <p:nvCxnSpPr>
+          <p:cNvPr id="22" name="Connector 21"/>
+          <p:cNvCxnSpPr/>
+          <p:nvPr/>
+        </p:nvCxnSpPr>
+        <p:spPr>
+          <a:xfrm>
+            <a:off x="8485632" y="2395728"/>
+            <a:ext cx="0" cy="621792"/>
+          </a:xfrm>
+          <a:prstGeom prst="line">
+            <a:avLst/>
+          </a:prstGeom>
+          <a:ln w="31750">
+            <a:solidFill>
+              <a:srgbClr val="EA580C"/>
+            </a:solidFill>
+          </a:ln>
+        </p:spPr>
+        <p:style>
+          <a:lnRef idx="2">
+            <a:schemeClr val="accent1"/>
+          </a:lnRef>
+          <a:fillRef idx="0">
+            <a:schemeClr val="accent1"/>
+          </a:fillRef>
+          <a:effectRef idx="1">
+            <a:schemeClr val="accent1"/>
+          </a:effectRef>
+          <a:fontRef idx="minor">
+            <a:schemeClr val="tx1"/>
+          </a:fontRef>
+        </p:style>
+      </p:cxnSp>
+      <p:sp>
+        <p:nvSpPr>
+          <p:cNvPr id="23" name="Rectangle 22"/>
+          <p:cNvSpPr/>
+          <p:nvPr/>
+        </p:nvSpPr>
+        <p:spPr>
+          <a:xfrm>
+            <a:off x="7178040" y="2542032"/>
+            <a:ext cx="960120" cy="219456"/>
+          </a:xfrm>
+          <a:prstGeom prst="rect">
+            <a:avLst/>
+          </a:prstGeom>
+          <a:noFill/>
+          <a:ln>
+            <a:noFill/>
+          </a:ln>
+        </p:spPr>
+        <p:style>
+          <a:lnRef idx="1">
+            <a:schemeClr val="accent1"/>
+          </a:lnRef>
+          <a:fillRef idx="3">
+            <a:schemeClr val="accent1"/>
+          </a:fillRef>
+          <a:effectRef idx="2">
+            <a:schemeClr val="accent1"/>
+          </a:effectRef>
+          <a:fontRef idx="minor">
+            <a:schemeClr val="lt1"/>
+          </a:fontRef>
+        </p:style>
+        <p:txBody>
+          <a:bodyPr rtlCol="0" anchor="ctr" wrap="square" lIns="73152" rIns="73152" tIns="73152" bIns="73152">
+            <a:noAutofit/>
+          </a:bodyPr>
+          <a:lstStyle/>
+          <a:p>
+            <a:pPr algn="ctr"/>
+            <a:r>
+              <a:rPr sz="1000" b="1">
+                <a:solidFill>
+                  <a:srgbClr val="64748B"/>
+                </a:solidFill>
+                <a:latin typeface="Aptos"/>
+              </a:rPr>
+              <a:t>dispatches</a:t>
+            </a:r>
+          </a:p>
+        </p:txBody>
+      </p:sp>
+      <p:cxnSp>
+        <p:nvCxnSpPr>
+          <p:cNvPr id="24" name="Connector 23"/>
+          <p:cNvCxnSpPr/>
+          <p:nvPr/>
+        </p:nvCxnSpPr>
+        <p:spPr>
           <a:xfrm flipV="1">
-            <a:off x="8229600" y="2350008"/>
-            <a:ext cx="914400" cy="841248"/>
+            <a:off x="9299448" y="2395728"/>
+            <a:ext cx="621792" cy="914400"/>
           </a:xfrm>
           <a:prstGeom prst="line">
             <a:avLst/>
           </a:prstGeom>
-          <a:ln w="30480">
+          <a:ln w="31750">
             <a:solidFill>
               <a:srgbClr val="6D28D9"/>
             </a:solidFill>
@@ -12624,28 +13302,181 @@
       </p:cxnSp>
       <p:sp>
         <p:nvSpPr>
-          <p:cNvPr id="21" name="Rounded Rectangle 20"/>
-          <p:cNvSpPr/>
-          <p:nvPr/>
-        </p:nvSpPr>
-        <p:spPr>
-          <a:xfrm>
-            <a:off x="8229600" y="2971800"/>
-            <a:ext cx="1115568" cy="329184"/>
-          </a:xfrm>
-          <a:prstGeom prst="roundRect">
-            <a:avLst/>
-          </a:prstGeom>
-          <a:solidFill>
-            <a:srgbClr val="EDE9FE"/>
-          </a:solidFill>
-          <a:ln w="13970">
+          <p:cNvPr id="25" name="Rectangle 24"/>
+          <p:cNvSpPr/>
+          <p:nvPr/>
+        </p:nvSpPr>
+        <p:spPr>
+          <a:xfrm>
+            <a:off x="8915400" y="3456432"/>
+            <a:ext cx="868680" cy="219456"/>
+          </a:xfrm>
+          <a:prstGeom prst="rect">
+            <a:avLst/>
+          </a:prstGeom>
+          <a:noFill/>
+          <a:ln>
+            <a:noFill/>
+          </a:ln>
+        </p:spPr>
+        <p:style>
+          <a:lnRef idx="1">
+            <a:schemeClr val="accent1"/>
+          </a:lnRef>
+          <a:fillRef idx="3">
+            <a:schemeClr val="accent1"/>
+          </a:fillRef>
+          <a:effectRef idx="2">
+            <a:schemeClr val="accent1"/>
+          </a:effectRef>
+          <a:fontRef idx="minor">
+            <a:schemeClr val="lt1"/>
+          </a:fontRef>
+        </p:style>
+        <p:txBody>
+          <a:bodyPr rtlCol="0" anchor="ctr" wrap="square" lIns="73152" rIns="73152" tIns="73152" bIns="73152">
+            <a:noAutofit/>
+          </a:bodyPr>
+          <a:lstStyle/>
+          <a:p>
+            <a:pPr algn="ctr"/>
+            <a:r>
+              <a:rPr sz="1000" b="1">
+                <a:solidFill>
+                  <a:srgbClr val="64748B"/>
+                </a:solidFill>
+                <a:latin typeface="Aptos"/>
+              </a:rPr>
+              <a:t>handoff</a:t>
+            </a:r>
+          </a:p>
+        </p:txBody>
+      </p:sp>
+      <p:cxnSp>
+        <p:nvCxnSpPr>
+          <p:cNvPr id="26" name="Connector 25"/>
+          <p:cNvCxnSpPr/>
+          <p:nvPr/>
+        </p:nvCxnSpPr>
+        <p:spPr>
+          <a:xfrm>
+            <a:off x="9921240" y="2395728"/>
+            <a:ext cx="640080" cy="0"/>
+          </a:xfrm>
+          <a:prstGeom prst="line">
+            <a:avLst/>
+          </a:prstGeom>
+          <a:ln w="27940">
             <a:solidFill>
-              <a:srgbClr val="6D28D9"/>
+              <a:srgbClr val="16A34A"/>
             </a:solidFill>
           </a:ln>
         </p:spPr>
         <p:style>
+          <a:lnRef idx="2">
+            <a:schemeClr val="accent1"/>
+          </a:lnRef>
+          <a:fillRef idx="0">
+            <a:schemeClr val="accent1"/>
+          </a:fillRef>
+          <a:effectRef idx="1">
+            <a:schemeClr val="accent1"/>
+          </a:effectRef>
+          <a:fontRef idx="minor">
+            <a:schemeClr val="tx1"/>
+          </a:fontRef>
+        </p:style>
+      </p:cxnSp>
+      <p:cxnSp>
+        <p:nvCxnSpPr>
+          <p:cNvPr id="27" name="Connector 26"/>
+          <p:cNvCxnSpPr/>
+          <p:nvPr/>
+        </p:nvCxnSpPr>
+        <p:spPr>
+          <a:xfrm flipV="1">
+            <a:off x="10561320" y="1417320"/>
+            <a:ext cx="0" cy="978408"/>
+          </a:xfrm>
+          <a:prstGeom prst="line">
+            <a:avLst/>
+          </a:prstGeom>
+          <a:ln w="27940">
+            <a:solidFill>
+              <a:srgbClr val="16A34A"/>
+            </a:solidFill>
+          </a:ln>
+        </p:spPr>
+        <p:style>
+          <a:lnRef idx="2">
+            <a:schemeClr val="accent1"/>
+          </a:lnRef>
+          <a:fillRef idx="0">
+            <a:schemeClr val="accent1"/>
+          </a:fillRef>
+          <a:effectRef idx="1">
+            <a:schemeClr val="accent1"/>
+          </a:effectRef>
+          <a:fontRef idx="minor">
+            <a:schemeClr val="tx1"/>
+          </a:fontRef>
+        </p:style>
+      </p:cxnSp>
+      <p:cxnSp>
+        <p:nvCxnSpPr>
+          <p:cNvPr id="28" name="Connector 27"/>
+          <p:cNvCxnSpPr/>
+          <p:nvPr/>
+        </p:nvCxnSpPr>
+        <p:spPr>
+          <a:xfrm flipH="1">
+            <a:off x="2606040" y="1417320"/>
+            <a:ext cx="7955280" cy="0"/>
+          </a:xfrm>
+          <a:prstGeom prst="line">
+            <a:avLst/>
+          </a:prstGeom>
+          <a:ln w="27940">
+            <a:solidFill>
+              <a:srgbClr val="16A34A"/>
+            </a:solidFill>
+          </a:ln>
+        </p:spPr>
+        <p:style>
+          <a:lnRef idx="2">
+            <a:schemeClr val="accent1"/>
+          </a:lnRef>
+          <a:fillRef idx="0">
+            <a:schemeClr val="accent1"/>
+          </a:fillRef>
+          <a:effectRef idx="1">
+            <a:schemeClr val="accent1"/>
+          </a:effectRef>
+          <a:fontRef idx="minor">
+            <a:schemeClr val="tx1"/>
+          </a:fontRef>
+        </p:style>
+      </p:cxnSp>
+      <p:sp>
+        <p:nvSpPr>
+          <p:cNvPr id="29" name="Rectangle 28"/>
+          <p:cNvSpPr/>
+          <p:nvPr/>
+        </p:nvSpPr>
+        <p:spPr>
+          <a:xfrm>
+            <a:off x="6144768" y="1225296"/>
+            <a:ext cx="1234440" cy="219456"/>
+          </a:xfrm>
+          <a:prstGeom prst="rect">
+            <a:avLst/>
+          </a:prstGeom>
+          <a:noFill/>
+          <a:ln>
+            <a:noFill/>
+          </a:ln>
+        </p:spPr>
+        <p:style>
           <a:lnRef idx="1">
             <a:schemeClr val="accent1"/>
           </a:lnRef>
@@ -12667,27 +13498,27 @@
           <a:p>
             <a:pPr algn="ctr"/>
             <a:r>
-              <a:rPr sz="1200" b="1">
-                <a:solidFill>
-                  <a:srgbClr val="6D28D9"/>
+              <a:rPr sz="1000" b="1">
+                <a:solidFill>
+                  <a:srgbClr val="64748B"/>
                 </a:solidFill>
                 <a:latin typeface="Aptos"/>
               </a:rPr>
-              <a:t>NIXL KV</a:t>
-            </a:r>
-          </a:p>
-        </p:txBody>
-      </p:sp>
-      <p:sp>
-        <p:nvSpPr>
-          <p:cNvPr id="22" name="TextBox 21"/>
+              <a:t>response stream</a:t>
+            </a:r>
+          </a:p>
+        </p:txBody>
+      </p:sp>
+      <p:sp>
+        <p:nvSpPr>
+          <p:cNvPr id="30" name="TextBox 29"/>
           <p:cNvSpPr txBox="1"/>
           <p:nvPr/>
         </p:nvSpPr>
         <p:spPr>
           <a:xfrm>
-            <a:off x="749808" y="3749039"/>
-            <a:ext cx="7543800" cy="1874519"/>
+            <a:off x="749808" y="3858768"/>
+            <a:ext cx="7406640" cy="1783080"/>
           </a:xfrm>
           <a:prstGeom prst="rect">
             <a:avLst/>
@@ -12763,14 +13594,14 @@
       </p:sp>
       <p:sp>
         <p:nvSpPr>
-          <p:cNvPr id="23" name="Rounded Rectangle 22"/>
-          <p:cNvSpPr/>
-          <p:nvPr/>
-        </p:nvSpPr>
-        <p:spPr>
-          <a:xfrm>
-            <a:off x="8549640" y="3730752"/>
-            <a:ext cx="2743200" cy="1481328"/>
+          <p:cNvPr id="31" name="Rounded Rectangle 30"/>
+          <p:cNvSpPr/>
+          <p:nvPr/>
+        </p:nvSpPr>
+        <p:spPr>
+          <a:xfrm>
+            <a:off x="8522208" y="3785615"/>
+            <a:ext cx="2770632" cy="1554480"/>
           </a:xfrm>
           <a:prstGeom prst="roundRect">
             <a:avLst/>
@@ -12814,14 +13645,15 @@
               </a:rPr>
               <a:t>• Decode is the coordination point
 • Prefill is selected only when it helps
-• KV transfer bridges the two phases</a:t>
-            </a:r>
-          </a:p>
-        </p:txBody>
-      </p:sp>
-      <p:sp>
-        <p:nvSpPr>
-          <p:cNvPr id="24" name="Rounded Rectangle 23"/>
+• KV transfer bridges the two phases
+• The client still sees one endpoint</a:t>
+            </a:r>
+          </a:p>
+        </p:txBody>
+      </p:sp>
+      <p:sp>
+        <p:nvSpPr>
+          <p:cNvPr id="32" name="Rounded Rectangle 31"/>
           <p:cNvSpPr/>
           <p:nvPr/>
         </p:nvSpPr>
@@ -12870,7 +13702,7 @@
                 </a:solidFill>
                 <a:latin typeface="Aptos"/>
               </a:rPr>
-              <a:t>The user sees one endpoint. GWIE carries the gateway-facing contract, llm-d makes the routing decisions, and the platform coordinates prefill placement, KV movement, and decode execution across multiple pods.</a:t>
+              <a:t>GWIE carries the gateway-facing contract, llm-d makes the routing decisions, and the platform coordinates prefill placement, KV movement, and decode execution across multiple pods.</a:t>
             </a:r>
           </a:p>
         </p:txBody>
@@ -13156,7 +13988,7 @@
         <p:spPr>
           <a:xfrm>
             <a:off x="777240" y="1874519"/>
-            <a:ext cx="5074920" cy="3474720"/>
+            <a:ext cx="4983480" cy="3474720"/>
           </a:xfrm>
           <a:prstGeom prst="rect">
             <a:avLst/>
@@ -13238,8 +14070,8 @@
         </p:nvSpPr>
         <p:spPr>
           <a:xfrm>
-            <a:off x="6629400" y="1691640"/>
-            <a:ext cx="4526280" cy="4251960"/>
+            <a:off x="6510528" y="1645920"/>
+            <a:ext cx="4663440" cy="4343400"/>
           </a:xfrm>
           <a:prstGeom prst="roundRect">
             <a:avLst/>
@@ -13283,7 +14115,7 @@
         </p:nvSpPr>
         <p:spPr>
           <a:xfrm>
-            <a:off x="7973568" y="1828800"/>
+            <a:off x="7973568" y="1810512"/>
             <a:ext cx="1828800" cy="320040"/>
           </a:xfrm>
           <a:prstGeom prst="rect">
@@ -13335,8 +14167,120 @@
         </p:nvSpPr>
         <p:spPr>
           <a:xfrm>
-            <a:off x="7132320" y="2560320"/>
-            <a:ext cx="3520440" cy="749808"/>
+            <a:off x="6784848" y="2267712"/>
+            <a:ext cx="987552" cy="274320"/>
+          </a:xfrm>
+          <a:prstGeom prst="roundRect">
+            <a:avLst/>
+          </a:prstGeom>
+          <a:solidFill>
+            <a:srgbClr val="DCFCE7"/>
+          </a:solidFill>
+          <a:ln w="13970">
+            <a:solidFill>
+              <a:srgbClr val="16A34A"/>
+            </a:solidFill>
+          </a:ln>
+        </p:spPr>
+        <p:style>
+          <a:lnRef idx="1">
+            <a:schemeClr val="accent1"/>
+          </a:lnRef>
+          <a:fillRef idx="3">
+            <a:schemeClr val="accent1"/>
+          </a:fillRef>
+          <a:effectRef idx="2">
+            <a:schemeClr val="accent1"/>
+          </a:effectRef>
+          <a:fontRef idx="minor">
+            <a:schemeClr val="lt1"/>
+          </a:fontRef>
+        </p:style>
+        <p:txBody>
+          <a:bodyPr rtlCol="0" anchor="ctr" wrap="square" lIns="73152" rIns="73152" tIns="73152" bIns="73152">
+            <a:noAutofit/>
+          </a:bodyPr>
+          <a:lstStyle/>
+          <a:p>
+            <a:pPr algn="ctr"/>
+            <a:r>
+              <a:rPr sz="1100" b="1">
+                <a:solidFill>
+                  <a:srgbClr val="16A34A"/>
+                </a:solidFill>
+                <a:latin typeface="Aptos"/>
+              </a:rPr>
+              <a:t>external request</a:t>
+            </a:r>
+          </a:p>
+        </p:txBody>
+      </p:sp>
+      <p:sp>
+        <p:nvSpPr>
+          <p:cNvPr id="11" name="Rounded Rectangle 10"/>
+          <p:cNvSpPr/>
+          <p:nvPr/>
+        </p:nvSpPr>
+        <p:spPr>
+          <a:xfrm>
+            <a:off x="10131552" y="2267712"/>
+            <a:ext cx="914400" cy="274320"/>
+          </a:xfrm>
+          <a:prstGeom prst="roundRect">
+            <a:avLst/>
+          </a:prstGeom>
+          <a:solidFill>
+            <a:srgbClr val="FFEDD5"/>
+          </a:solidFill>
+          <a:ln w="13970">
+            <a:solidFill>
+              <a:srgbClr val="EA580C"/>
+            </a:solidFill>
+          </a:ln>
+        </p:spPr>
+        <p:style>
+          <a:lnRef idx="1">
+            <a:schemeClr val="accent1"/>
+          </a:lnRef>
+          <a:fillRef idx="3">
+            <a:schemeClr val="accent1"/>
+          </a:fillRef>
+          <a:effectRef idx="2">
+            <a:schemeClr val="accent1"/>
+          </a:effectRef>
+          <a:fontRef idx="minor">
+            <a:schemeClr val="lt1"/>
+          </a:fontRef>
+        </p:style>
+        <p:txBody>
+          <a:bodyPr rtlCol="0" anchor="ctr" wrap="square" lIns="73152" rIns="73152" tIns="73152" bIns="73152">
+            <a:noAutofit/>
+          </a:bodyPr>
+          <a:lstStyle/>
+          <a:p>
+            <a:pPr algn="ctr"/>
+            <a:r>
+              <a:rPr sz="1100" b="1">
+                <a:solidFill>
+                  <a:srgbClr val="EA580C"/>
+                </a:solidFill>
+                <a:latin typeface="Aptos"/>
+              </a:rPr>
+              <a:t>KV handoff</a:t>
+            </a:r>
+          </a:p>
+        </p:txBody>
+      </p:sp>
+      <p:sp>
+        <p:nvSpPr>
+          <p:cNvPr id="12" name="Rounded Rectangle 11"/>
+          <p:cNvSpPr/>
+          <p:nvPr/>
+        </p:nvSpPr>
+        <p:spPr>
+          <a:xfrm>
+            <a:off x="7059168" y="2697480"/>
+            <a:ext cx="3566160" cy="768096"/>
           </a:xfrm>
           <a:prstGeom prst="roundRect">
             <a:avLst/>
@@ -13386,14 +14330,14 @@
       </p:sp>
       <p:sp>
         <p:nvSpPr>
-          <p:cNvPr id="11" name="Rounded Rectangle 10"/>
-          <p:cNvSpPr/>
-          <p:nvPr/>
-        </p:nvSpPr>
-        <p:spPr>
-          <a:xfrm>
-            <a:off x="7132320" y="3886200"/>
-            <a:ext cx="3520440" cy="749808"/>
+          <p:cNvPr id="13" name="Rounded Rectangle 12"/>
+          <p:cNvSpPr/>
+          <p:nvPr/>
+        </p:nvSpPr>
+        <p:spPr>
+          <a:xfrm>
+            <a:off x="7059168" y="4041648"/>
+            <a:ext cx="3566160" cy="768096"/>
           </a:xfrm>
           <a:prstGeom prst="roundRect">
             <a:avLst/>
@@ -13443,13 +14387,104 @@
       </p:sp>
       <p:cxnSp>
         <p:nvCxnSpPr>
-          <p:cNvPr id="12" name="Connector 11"/>
+          <p:cNvPr id="14" name="Connector 13"/>
           <p:cNvCxnSpPr/>
           <p:nvPr/>
         </p:nvCxnSpPr>
         <p:spPr>
           <a:xfrm>
-            <a:off x="8887968" y="3310128"/>
+            <a:off x="6309360" y="3072384"/>
+            <a:ext cx="749808" cy="0"/>
+          </a:xfrm>
+          <a:prstGeom prst="line">
+            <a:avLst/>
+          </a:prstGeom>
+          <a:ln w="35560">
+            <a:solidFill>
+              <a:srgbClr val="16A34A"/>
+            </a:solidFill>
+          </a:ln>
+        </p:spPr>
+        <p:style>
+          <a:lnRef idx="2">
+            <a:schemeClr val="accent1"/>
+          </a:lnRef>
+          <a:fillRef idx="0">
+            <a:schemeClr val="accent1"/>
+          </a:fillRef>
+          <a:effectRef idx="1">
+            <a:schemeClr val="accent1"/>
+          </a:effectRef>
+          <a:fontRef idx="minor">
+            <a:schemeClr val="tx1"/>
+          </a:fontRef>
+        </p:style>
+      </p:cxnSp>
+      <p:sp>
+        <p:nvSpPr>
+          <p:cNvPr id="15" name="Rounded Rectangle 14"/>
+          <p:cNvSpPr/>
+          <p:nvPr/>
+        </p:nvSpPr>
+        <p:spPr>
+          <a:xfrm>
+            <a:off x="5504688" y="2880360"/>
+            <a:ext cx="749808" cy="292608"/>
+          </a:xfrm>
+          <a:prstGeom prst="roundRect">
+            <a:avLst/>
+          </a:prstGeom>
+          <a:solidFill>
+            <a:srgbClr val="DCFCE7"/>
+          </a:solidFill>
+          <a:ln w="13970">
+            <a:solidFill>
+              <a:srgbClr val="16A34A"/>
+            </a:solidFill>
+          </a:ln>
+        </p:spPr>
+        <p:style>
+          <a:lnRef idx="1">
+            <a:schemeClr val="accent1"/>
+          </a:lnRef>
+          <a:fillRef idx="3">
+            <a:schemeClr val="accent1"/>
+          </a:fillRef>
+          <a:effectRef idx="2">
+            <a:schemeClr val="accent1"/>
+          </a:effectRef>
+          <a:fontRef idx="minor">
+            <a:schemeClr val="lt1"/>
+          </a:fontRef>
+        </p:style>
+        <p:txBody>
+          <a:bodyPr rtlCol="0" anchor="ctr" wrap="square" lIns="73152" rIns="73152" tIns="73152" bIns="73152">
+            <a:noAutofit/>
+          </a:bodyPr>
+          <a:lstStyle/>
+          <a:p>
+            <a:pPr algn="ctr"/>
+            <a:r>
+              <a:rPr sz="1100" b="1">
+                <a:solidFill>
+                  <a:srgbClr val="0F172A"/>
+                </a:solidFill>
+                <a:latin typeface="Aptos"/>
+              </a:rPr>
+              <a:t>from EPP</a:t>
+            </a:r>
+          </a:p>
+        </p:txBody>
+      </p:sp>
+      <p:cxnSp>
+        <p:nvCxnSpPr>
+          <p:cNvPr id="16" name="Connector 15"/>
+          <p:cNvCxnSpPr/>
+          <p:nvPr/>
+        </p:nvCxnSpPr>
+        <p:spPr>
+          <a:xfrm>
+            <a:off x="8842248" y="3465576"/>
             <a:ext cx="0" cy="576072"/>
           </a:xfrm>
           <a:prstGeom prst="line">
@@ -13478,25 +14513,21 @@
       </p:cxnSp>
       <p:sp>
         <p:nvSpPr>
-          <p:cNvPr id="13" name="Rounded Rectangle 12"/>
-          <p:cNvSpPr/>
-          <p:nvPr/>
-        </p:nvSpPr>
-        <p:spPr>
-          <a:xfrm>
-            <a:off x="5623560" y="2697480"/>
-            <a:ext cx="1005840" cy="365760"/>
-          </a:xfrm>
-          <a:prstGeom prst="roundRect">
-            <a:avLst/>
-          </a:prstGeom>
-          <a:solidFill>
-            <a:srgbClr val="DCFCE7"/>
-          </a:solidFill>
-          <a:ln w="13970">
-            <a:solidFill>
-              <a:srgbClr val="16A34A"/>
-            </a:solidFill>
+          <p:cNvPr id="17" name="Rectangle 16"/>
+          <p:cNvSpPr/>
+          <p:nvPr/>
+        </p:nvSpPr>
+        <p:spPr>
+          <a:xfrm>
+            <a:off x="8979408" y="3621024"/>
+            <a:ext cx="1097280" cy="256032"/>
+          </a:xfrm>
+          <a:prstGeom prst="rect">
+            <a:avLst/>
+          </a:prstGeom>
+          <a:noFill/>
+          <a:ln>
+            <a:noFill/>
           </a:ln>
         </p:spPr>
         <p:style>
@@ -13521,34 +14552,34 @@
           <a:p>
             <a:pPr algn="ctr"/>
             <a:r>
-              <a:rPr sz="1200" b="1">
-                <a:solidFill>
-                  <a:srgbClr val="0F172A"/>
+              <a:rPr sz="1100" b="1">
+                <a:solidFill>
+                  <a:srgbClr val="64748B"/>
                 </a:solidFill>
                 <a:latin typeface="Aptos"/>
               </a:rPr>
-              <a:t>from EPP</a:t>
+              <a:t>proxy to local</a:t>
             </a:r>
           </a:p>
         </p:txBody>
       </p:sp>
       <p:cxnSp>
         <p:nvCxnSpPr>
-          <p:cNvPr id="14" name="Connector 13"/>
+          <p:cNvPr id="18" name="Connector 17"/>
           <p:cNvCxnSpPr/>
           <p:nvPr/>
         </p:nvCxnSpPr>
         <p:spPr>
-          <a:xfrm flipH="1">
-            <a:off x="6263640" y="2935224"/>
-            <a:ext cx="365760" cy="0"/>
+          <a:xfrm>
+            <a:off x="10378440" y="3063240"/>
+            <a:ext cx="393192" cy="1216152"/>
           </a:xfrm>
           <a:prstGeom prst="line">
             <a:avLst/>
           </a:prstGeom>
           <a:ln w="33020">
             <a:solidFill>
-              <a:srgbClr val="16A34A"/>
+              <a:srgbClr val="EA580C"/>
             </a:solidFill>
           </a:ln>
         </p:spPr>
@@ -13569,14 +14600,14 @@
       </p:cxnSp>
       <p:sp>
         <p:nvSpPr>
-          <p:cNvPr id="15" name="Rounded Rectangle 14"/>
-          <p:cNvSpPr/>
-          <p:nvPr/>
-        </p:nvSpPr>
-        <p:spPr>
-          <a:xfrm>
-            <a:off x="10808208" y="3310128"/>
-            <a:ext cx="896112" cy="365760"/>
+          <p:cNvPr id="19" name="Rounded Rectangle 18"/>
+          <p:cNvSpPr/>
+          <p:nvPr/>
+        </p:nvSpPr>
+        <p:spPr>
+          <a:xfrm>
+            <a:off x="10277856" y="3675887"/>
+            <a:ext cx="822960" cy="256032"/>
           </a:xfrm>
           <a:prstGeom prst="roundRect">
             <a:avLst/>
@@ -13612,7 +14643,7 @@
           <a:p>
             <a:pPr algn="ctr"/>
             <a:r>
-              <a:rPr sz="1200" b="1">
+              <a:rPr sz="1100" b="1">
                 <a:solidFill>
                   <a:srgbClr val="0F172A"/>
                 </a:solidFill>
@@ -13623,44 +14654,63 @@
           </a:p>
         </p:txBody>
       </p:sp>
-      <p:cxnSp>
-        <p:nvCxnSpPr>
-          <p:cNvPr id="16" name="Connector 15"/>
-          <p:cNvCxnSpPr/>
-          <p:nvPr/>
-        </p:nvCxnSpPr>
-        <p:spPr>
-          <a:xfrm>
-            <a:off x="10561320" y="3493008"/>
-            <a:ext cx="246888" cy="768096"/>
-          </a:xfrm>
-          <a:prstGeom prst="line">
-            <a:avLst/>
-          </a:prstGeom>
-          <a:ln w="33020">
-            <a:solidFill>
-              <a:srgbClr val="EA580C"/>
-            </a:solidFill>
-          </a:ln>
-        </p:spPr>
-        <p:style>
-          <a:lnRef idx="2">
-            <a:schemeClr val="accent1"/>
-          </a:lnRef>
-          <a:fillRef idx="0">
-            <a:schemeClr val="accent1"/>
-          </a:fillRef>
-          <a:effectRef idx="1">
-            <a:schemeClr val="accent1"/>
-          </a:effectRef>
-          <a:fontRef idx="minor">
-            <a:schemeClr val="tx1"/>
-          </a:fontRef>
-        </p:style>
-      </p:cxnSp>
-      <p:sp>
-        <p:nvSpPr>
-          <p:cNvPr id="17" name="Rounded Rectangle 16"/>
+      <p:sp>
+        <p:nvSpPr>
+          <p:cNvPr id="20" name="Rounded Rectangle 19"/>
+          <p:cNvSpPr/>
+          <p:nvPr/>
+        </p:nvSpPr>
+        <p:spPr>
+          <a:xfrm>
+            <a:off x="6839712" y="5102352"/>
+            <a:ext cx="3977639" cy="365760"/>
+          </a:xfrm>
+          <a:prstGeom prst="roundRect">
+            <a:avLst/>
+          </a:prstGeom>
+          <a:solidFill>
+            <a:srgbClr val="F1F5F9"/>
+          </a:solidFill>
+          <a:ln>
+            <a:noFill/>
+          </a:ln>
+        </p:spPr>
+        <p:style>
+          <a:lnRef idx="1">
+            <a:schemeClr val="accent1"/>
+          </a:lnRef>
+          <a:fillRef idx="3">
+            <a:schemeClr val="accent1"/>
+          </a:fillRef>
+          <a:effectRef idx="2">
+            <a:schemeClr val="accent1"/>
+          </a:effectRef>
+          <a:fontRef idx="minor">
+            <a:schemeClr val="lt1"/>
+          </a:fontRef>
+        </p:style>
+        <p:txBody>
+          <a:bodyPr rtlCol="0" anchor="ctr" wrap="square" lIns="73152" rIns="73152" tIns="73152" bIns="73152">
+            <a:noAutofit/>
+          </a:bodyPr>
+          <a:lstStyle/>
+          <a:p>
+            <a:pPr algn="ctr"/>
+            <a:r>
+              <a:rPr sz="1400" b="1">
+                <a:solidFill>
+                  <a:srgbClr val="334155"/>
+                </a:solidFill>
+                <a:latin typeface="Aptos"/>
+              </a:rPr>
+              <a:t>decode pod = coordination point + final response point</a:t>
+            </a:r>
+          </a:p>
+        </p:txBody>
+      </p:sp>
+      <p:sp>
+        <p:nvSpPr>
+          <p:cNvPr id="21" name="Rounded Rectangle 20"/>
           <p:cNvSpPr/>
           <p:nvPr/>
         </p:nvSpPr>

</xml_diff>

<commit_message>
docs: switch pd slide example to qwen 3.8 27b
</commit_message>
<xml_diff>
--- a/llm/kaito-llm-d-pd-slides.pptx
+++ b/llm/kaito-llm-d-pd-slides.pptx
@@ -10825,17 +10825,17 @@
               <a:t>apiVersion: kaito.sh/v1alpha1
 kind: MultiRoleInference
 metadata:
-  name: phi-4-mini
+  name: qwen-3-8-27b
 spec:
   model:
-    name: phi-4-mini-instruct
+    name: Qwen/Qwen3.8-27B
   roles:
     - type: prefill
       replicas: 1
       instanceType: Standard_NC24ads_A100_v4
     - type: decode
       replicas: 1
-      instanceType: Standard_NC24ads_A100_v4</a:t>
+      instanceType: Standard_NC80adis_H100_v5</a:t>
             </a:r>
           </a:p>
         </p:txBody>

</xml_diff>

<commit_message>
docs: tighten pd deck layout and connectors
</commit_message>
<xml_diff>
--- a/llm/kaito-llm-d-pd-slides.pptx
+++ b/llm/kaito-llm-d-pd-slides.pptx
@@ -12507,8 +12507,8 @@
         </p:nvSpPr>
         <p:spPr>
           <a:xfrm>
-            <a:off x="6912864" y="2770632"/>
-            <a:ext cx="914400" cy="256032"/>
+            <a:off x="7114032" y="2688336"/>
+            <a:ext cx="960120" cy="256032"/>
           </a:xfrm>
           <a:prstGeom prst="roundRect">
             <a:avLst/>
@@ -12563,7 +12563,7 @@
         </p:nvSpPr>
         <p:spPr>
           <a:xfrm>
-            <a:off x="8211312" y="3035808"/>
+            <a:off x="8485632" y="2798064"/>
             <a:ext cx="914400" cy="256032"/>
           </a:xfrm>
           <a:prstGeom prst="roundRect">
@@ -13130,7 +13130,7 @@
         </p:nvSpPr>
         <p:spPr>
           <a:xfrm>
-            <a:off x="7635240" y="3017520"/>
+            <a:off x="7589520" y="3072384"/>
             <a:ext cx="1664208" cy="585216"/>
           </a:xfrm>
           <a:prstGeom prst="roundRect">
@@ -13187,7 +13187,7 @@
         <p:spPr>
           <a:xfrm>
             <a:off x="8485632" y="2395728"/>
-            <a:ext cx="0" cy="621792"/>
+            <a:ext cx="0" cy="676656"/>
           </a:xfrm>
           <a:prstGeom prst="line">
             <a:avLst/>
@@ -13988,7 +13988,7 @@
         <p:spPr>
           <a:xfrm>
             <a:off x="777240" y="1874519"/>
-            <a:ext cx="4983480" cy="3474720"/>
+            <a:ext cx="4572000" cy="3474720"/>
           </a:xfrm>
           <a:prstGeom prst="rect">
             <a:avLst/>
@@ -14070,8 +14070,8 @@
         </p:nvSpPr>
         <p:spPr>
           <a:xfrm>
-            <a:off x="6510528" y="1645920"/>
-            <a:ext cx="4663440" cy="4343400"/>
+            <a:off x="6675120" y="1645920"/>
+            <a:ext cx="4498848" cy="4343400"/>
           </a:xfrm>
           <a:prstGeom prst="roundRect">
             <a:avLst/>
@@ -14167,7 +14167,7 @@
         </p:nvSpPr>
         <p:spPr>
           <a:xfrm>
-            <a:off x="6784848" y="2267712"/>
+            <a:off x="6931152" y="2267712"/>
             <a:ext cx="987552" cy="274320"/>
           </a:xfrm>
           <a:prstGeom prst="roundRect">
@@ -14223,7 +14223,7 @@
         </p:nvSpPr>
         <p:spPr>
           <a:xfrm>
-            <a:off x="10131552" y="2267712"/>
+            <a:off x="10058400" y="2267712"/>
             <a:ext cx="914400" cy="274320"/>
           </a:xfrm>
           <a:prstGeom prst="roundRect">
@@ -14279,8 +14279,8 @@
         </p:nvSpPr>
         <p:spPr>
           <a:xfrm>
-            <a:off x="7059168" y="2697480"/>
-            <a:ext cx="3566160" cy="768096"/>
+            <a:off x="7205472" y="2697480"/>
+            <a:ext cx="3401568" cy="768096"/>
           </a:xfrm>
           <a:prstGeom prst="roundRect">
             <a:avLst/>
@@ -14336,8 +14336,8 @@
         </p:nvSpPr>
         <p:spPr>
           <a:xfrm>
-            <a:off x="7059168" y="4041648"/>
-            <a:ext cx="3566160" cy="768096"/>
+            <a:off x="7205472" y="4041648"/>
+            <a:ext cx="3401568" cy="768096"/>
           </a:xfrm>
           <a:prstGeom prst="roundRect">
             <a:avLst/>
@@ -14393,8 +14393,8 @@
         </p:nvCxnSpPr>
         <p:spPr>
           <a:xfrm>
-            <a:off x="6309360" y="3072384"/>
-            <a:ext cx="749808" cy="0"/>
+            <a:off x="6473952" y="3072384"/>
+            <a:ext cx="731520" cy="0"/>
           </a:xfrm>
           <a:prstGeom prst="line">
             <a:avLst/>
@@ -14428,7 +14428,7 @@
         </p:nvSpPr>
         <p:spPr>
           <a:xfrm>
-            <a:off x="5504688" y="2880360"/>
+            <a:off x="5596128" y="2880360"/>
             <a:ext cx="749808" cy="292608"/>
           </a:xfrm>
           <a:prstGeom prst="roundRect">
@@ -14662,8 +14662,8 @@
         </p:nvSpPr>
         <p:spPr>
           <a:xfrm>
-            <a:off x="6839712" y="5102352"/>
-            <a:ext cx="3977639" cy="365760"/>
+            <a:off x="6931152" y="5102352"/>
+            <a:ext cx="3794760" cy="365760"/>
           </a:xfrm>
           <a:prstGeom prst="roundRect">
             <a:avLst/>

</xml_diff>

<commit_message>
docs: redraw pd sequence slide from llm-d docs
</commit_message>
<xml_diff>
--- a/llm/kaito-llm-d-pd-slides.pptx
+++ b/llm/kaito-llm-d-pd-slides.pptx
@@ -12039,7 +12039,7 @@
                 </a:solidFill>
                 <a:latin typeface="Aptos"/>
               </a:rPr>
-              <a:t>The client sees one path; prefill is an optional internal branch.</a:t>
+              <a:t>This mirrors llm-d-router docs/disaggregation.md#pd-sequence as a decode-sidecar-coordinated flow.</a:t>
             </a:r>
           </a:p>
         </p:txBody>
@@ -12052,8 +12052,8 @@
         </p:nvSpPr>
         <p:spPr>
           <a:xfrm>
-            <a:off x="914400" y="1847088"/>
-            <a:ext cx="2011680" cy="201168"/>
+            <a:off x="777240" y="1783080"/>
+            <a:ext cx="1463040" cy="658368"/>
           </a:xfrm>
           <a:prstGeom prst="roundRect">
             <a:avLst/>
@@ -12061,7 +12061,7 @@
           <a:solidFill>
             <a:srgbClr val="FFFFFF"/>
           </a:solidFill>
-          <a:ln w="19050">
+          <a:ln w="17780">
             <a:solidFill>
               <a:srgbClr val="CBD5E1"/>
             </a:solidFill>
@@ -12082,18 +12082,18 @@
           </a:fontRef>
         </p:style>
         <p:txBody>
-          <a:bodyPr rtlCol="0" anchor="ctr" wrap="square" lIns="27432" rIns="27432" tIns="27432" bIns="27432"/>
+          <a:bodyPr rtlCol="0" anchor="ctr" wrap="square" lIns="54864" rIns="54864" tIns="54864" bIns="54864"/>
           <a:lstStyle/>
           <a:p>
             <a:pPr algn="ctr"/>
             <a:r>
-              <a:rPr sz="1200" b="1">
+              <a:rPr sz="1700" b="1">
                 <a:solidFill>
                   <a:srgbClr val="111827"/>
                 </a:solidFill>
                 <a:latin typeface="Aptos"/>
               </a:rPr>
-              <a:t>one user-visible request path</a:t>
+              <a:t>Client</a:t>
             </a:r>
           </a:p>
         </p:txBody>
@@ -12106,8 +12106,8 @@
         </p:nvSpPr>
         <p:spPr>
           <a:xfrm>
-            <a:off x="5532120" y="1847088"/>
-            <a:ext cx="1481328" cy="201168"/>
+            <a:off x="2606040" y="1783080"/>
+            <a:ext cx="1463040" cy="658368"/>
           </a:xfrm>
           <a:prstGeom prst="roundRect">
             <a:avLst/>
@@ -12115,61 +12115,7 @@
           <a:solidFill>
             <a:srgbClr val="FFFFFF"/>
           </a:solidFill>
-          <a:ln w="19050">
-            <a:solidFill>
-              <a:srgbClr val="FDBA74"/>
-            </a:solidFill>
-          </a:ln>
-        </p:spPr>
-        <p:style>
-          <a:lnRef idx="1">
-            <a:schemeClr val="accent1"/>
-          </a:lnRef>
-          <a:fillRef idx="3">
-            <a:schemeClr val="accent1"/>
-          </a:fillRef>
-          <a:effectRef idx="2">
-            <a:schemeClr val="accent1"/>
-          </a:effectRef>
-          <a:fontRef idx="minor">
-            <a:schemeClr val="lt1"/>
-          </a:fontRef>
-        </p:style>
-        <p:txBody>
-          <a:bodyPr rtlCol="0" anchor="ctr" wrap="square" lIns="27432" rIns="27432" tIns="27432" bIns="27432"/>
-          <a:lstStyle/>
-          <a:p>
-            <a:pPr algn="ctr"/>
-            <a:r>
-              <a:rPr sz="1200" b="1">
-                <a:solidFill>
-                  <a:srgbClr val="C2410C"/>
-                </a:solidFill>
-                <a:latin typeface="Aptos"/>
-              </a:rPr>
-              <a:t>optional prefill branch</a:t>
-            </a:r>
-          </a:p>
-        </p:txBody>
-      </p:sp>
-      <p:sp>
-        <p:nvSpPr>
-          <p:cNvPr id="9" name="Rounded Rectangle 8"/>
-          <p:cNvSpPr/>
-          <p:nvPr/>
-        </p:nvSpPr>
-        <p:spPr>
-          <a:xfrm>
-            <a:off x="896112" y="2240280"/>
-            <a:ext cx="914400" cy="566928"/>
-          </a:xfrm>
-          <a:prstGeom prst="roundRect">
-            <a:avLst/>
-          </a:prstGeom>
-          <a:solidFill>
-            <a:srgbClr val="FFFFFF"/>
-          </a:solidFill>
-          <a:ln w="19050">
+          <a:ln w="17780">
             <a:solidFill>
               <a:srgbClr val="CBD5E1"/>
             </a:solidFill>
@@ -12190,7 +12136,7 @@
           </a:fontRef>
         </p:style>
         <p:txBody>
-          <a:bodyPr rtlCol="0" anchor="ctr" wrap="square" lIns="73152" rIns="73152" tIns="73152" bIns="73152"/>
+          <a:bodyPr rtlCol="0" anchor="ctr" wrap="square" lIns="54864" rIns="54864" tIns="54864" bIns="54864"/>
           <a:lstStyle/>
           <a:p>
             <a:pPr algn="ctr"/>
@@ -12201,7 +12147,63 @@
                 </a:solidFill>
                 <a:latin typeface="Aptos"/>
               </a:rPr>
-              <a:t>1  Client</a:t>
+              <a:t>Inference
+Gateway</a:t>
+            </a:r>
+          </a:p>
+        </p:txBody>
+      </p:sp>
+      <p:sp>
+        <p:nvSpPr>
+          <p:cNvPr id="9" name="Rounded Rectangle 8"/>
+          <p:cNvSpPr/>
+          <p:nvPr/>
+        </p:nvSpPr>
+        <p:spPr>
+          <a:xfrm>
+            <a:off x="4572000" y="1783080"/>
+            <a:ext cx="1463040" cy="658368"/>
+          </a:xfrm>
+          <a:prstGeom prst="roundRect">
+            <a:avLst/>
+          </a:prstGeom>
+          <a:solidFill>
+            <a:srgbClr val="EAF2FF"/>
+          </a:solidFill>
+          <a:ln w="17780">
+            <a:solidFill>
+              <a:srgbClr val="2F6FEB"/>
+            </a:solidFill>
+          </a:ln>
+        </p:spPr>
+        <p:style>
+          <a:lnRef idx="1">
+            <a:schemeClr val="accent1"/>
+          </a:lnRef>
+          <a:fillRef idx="3">
+            <a:schemeClr val="accent1"/>
+          </a:fillRef>
+          <a:effectRef idx="2">
+            <a:schemeClr val="accent1"/>
+          </a:effectRef>
+          <a:fontRef idx="minor">
+            <a:schemeClr val="lt1"/>
+          </a:fontRef>
+        </p:style>
+        <p:txBody>
+          <a:bodyPr rtlCol="0" anchor="ctr" wrap="square" lIns="54864" rIns="54864" tIns="54864" bIns="54864"/>
+          <a:lstStyle/>
+          <a:p>
+            <a:pPr algn="ctr"/>
+            <a:r>
+              <a:rPr sz="1700" b="1">
+                <a:solidFill>
+                  <a:srgbClr val="0F2747"/>
+                </a:solidFill>
+                <a:latin typeface="Aptos"/>
+              </a:rPr>
+              <a:t>Decode Worker
+Sidecar</a:t>
             </a:r>
           </a:p>
         </p:txBody>
@@ -12214,124 +12216,360 @@
         </p:nvSpPr>
         <p:spPr>
           <a:xfrm>
-            <a:off x="2084831" y="2240280"/>
-            <a:ext cx="1042415" cy="566928"/>
+            <a:off x="6629400" y="1783080"/>
+            <a:ext cx="1463040" cy="658368"/>
           </a:xfrm>
           <a:prstGeom prst="roundRect">
             <a:avLst/>
           </a:prstGeom>
           <a:solidFill>
-            <a:srgbClr val="FFFFFF"/>
-          </a:solidFill>
-          <a:ln w="19050">
+            <a:srgbClr val="F3E8FF"/>
+          </a:solidFill>
+          <a:ln w="17780">
+            <a:solidFill>
+              <a:srgbClr val="6D28D9"/>
+            </a:solidFill>
+          </a:ln>
+        </p:spPr>
+        <p:style>
+          <a:lnRef idx="1">
+            <a:schemeClr val="accent1"/>
+          </a:lnRef>
+          <a:fillRef idx="3">
+            <a:schemeClr val="accent1"/>
+          </a:fillRef>
+          <a:effectRef idx="2">
+            <a:schemeClr val="accent1"/>
+          </a:effectRef>
+          <a:fontRef idx="minor">
+            <a:schemeClr val="lt1"/>
+          </a:fontRef>
+        </p:style>
+        <p:txBody>
+          <a:bodyPr rtlCol="0" anchor="ctr" wrap="square" lIns="54864" rIns="54864" tIns="54864" bIns="54864"/>
+          <a:lstStyle/>
+          <a:p>
+            <a:pPr algn="ctr"/>
+            <a:r>
+              <a:rPr sz="1700" b="1">
+                <a:solidFill>
+                  <a:srgbClr val="6D28D9"/>
+                </a:solidFill>
+                <a:latin typeface="Aptos"/>
+              </a:rPr>
+              <a:t>Prefill Worker
+(vLLM)</a:t>
+            </a:r>
+          </a:p>
+        </p:txBody>
+      </p:sp>
+      <p:sp>
+        <p:nvSpPr>
+          <p:cNvPr id="11" name="Rounded Rectangle 10"/>
+          <p:cNvSpPr/>
+          <p:nvPr/>
+        </p:nvSpPr>
+        <p:spPr>
+          <a:xfrm>
+            <a:off x="8732520" y="1783080"/>
+            <a:ext cx="1463040" cy="658368"/>
+          </a:xfrm>
+          <a:prstGeom prst="roundRect">
+            <a:avLst/>
+          </a:prstGeom>
+          <a:solidFill>
+            <a:srgbClr val="E8FFFB"/>
+          </a:solidFill>
+          <a:ln w="17780">
+            <a:solidFill>
+              <a:srgbClr val="0F766E"/>
+            </a:solidFill>
+          </a:ln>
+        </p:spPr>
+        <p:style>
+          <a:lnRef idx="1">
+            <a:schemeClr val="accent1"/>
+          </a:lnRef>
+          <a:fillRef idx="3">
+            <a:schemeClr val="accent1"/>
+          </a:fillRef>
+          <a:effectRef idx="2">
+            <a:schemeClr val="accent1"/>
+          </a:effectRef>
+          <a:fontRef idx="minor">
+            <a:schemeClr val="lt1"/>
+          </a:fontRef>
+        </p:style>
+        <p:txBody>
+          <a:bodyPr rtlCol="0" anchor="ctr" wrap="square" lIns="54864" rIns="54864" tIns="54864" bIns="54864"/>
+          <a:lstStyle/>
+          <a:p>
+            <a:pPr algn="ctr"/>
+            <a:r>
+              <a:rPr sz="1700" b="1">
+                <a:solidFill>
+                  <a:srgbClr val="0F766E"/>
+                </a:solidFill>
+                <a:latin typeface="Aptos"/>
+              </a:rPr>
+              <a:t>Decode Worker
+(vLLM)</a:t>
+            </a:r>
+          </a:p>
+        </p:txBody>
+      </p:sp>
+      <p:cxnSp>
+        <p:nvCxnSpPr>
+          <p:cNvPr id="12" name="Connector 11"/>
+          <p:cNvCxnSpPr/>
+          <p:nvPr/>
+        </p:nvCxnSpPr>
+        <p:spPr>
+          <a:xfrm>
+            <a:off x="1508760" y="2487168"/>
+            <a:ext cx="0" cy="2953512"/>
+          </a:xfrm>
+          <a:prstGeom prst="line">
+            <a:avLst/>
+          </a:prstGeom>
+          <a:ln w="12700">
             <a:solidFill>
               <a:srgbClr val="CBD5E1"/>
             </a:solidFill>
-          </a:ln>
-        </p:spPr>
-        <p:style>
-          <a:lnRef idx="1">
-            <a:schemeClr val="accent1"/>
-          </a:lnRef>
-          <a:fillRef idx="3">
-            <a:schemeClr val="accent1"/>
-          </a:fillRef>
-          <a:effectRef idx="2">
-            <a:schemeClr val="accent1"/>
-          </a:effectRef>
-          <a:fontRef idx="minor">
-            <a:schemeClr val="lt1"/>
-          </a:fontRef>
-        </p:style>
-        <p:txBody>
-          <a:bodyPr rtlCol="0" anchor="ctr" wrap="square" lIns="73152" rIns="73152" tIns="73152" bIns="73152"/>
-          <a:lstStyle/>
-          <a:p>
-            <a:pPr algn="ctr"/>
-            <a:r>
-              <a:rPr sz="1700" b="1">
-                <a:solidFill>
-                  <a:srgbClr val="111827"/>
-                </a:solidFill>
-                <a:latin typeface="Aptos"/>
-              </a:rPr>
-              <a:t>2  Gateway</a:t>
-            </a:r>
-          </a:p>
-        </p:txBody>
-      </p:sp>
-      <p:sp>
-        <p:nvSpPr>
-          <p:cNvPr id="11" name="Rounded Rectangle 10"/>
-          <p:cNvSpPr/>
-          <p:nvPr/>
-        </p:nvSpPr>
-        <p:spPr>
-          <a:xfrm>
-            <a:off x="3511296" y="2240280"/>
-            <a:ext cx="1371600" cy="566928"/>
-          </a:xfrm>
-          <a:prstGeom prst="roundRect">
-            <a:avLst/>
-          </a:prstGeom>
-          <a:solidFill>
-            <a:srgbClr val="FFFFFF"/>
-          </a:solidFill>
-          <a:ln w="19050">
+            <a:prstDash val="sysDash"/>
+          </a:ln>
+        </p:spPr>
+        <p:style>
+          <a:lnRef idx="2">
+            <a:schemeClr val="accent1"/>
+          </a:lnRef>
+          <a:fillRef idx="0">
+            <a:schemeClr val="accent1"/>
+          </a:fillRef>
+          <a:effectRef idx="1">
+            <a:schemeClr val="accent1"/>
+          </a:effectRef>
+          <a:fontRef idx="minor">
+            <a:schemeClr val="tx1"/>
+          </a:fontRef>
+        </p:style>
+      </p:cxnSp>
+      <p:cxnSp>
+        <p:nvCxnSpPr>
+          <p:cNvPr id="13" name="Connector 12"/>
+          <p:cNvCxnSpPr/>
+          <p:nvPr/>
+        </p:nvCxnSpPr>
+        <p:spPr>
+          <a:xfrm>
+            <a:off x="3337560" y="2487168"/>
+            <a:ext cx="0" cy="2953512"/>
+          </a:xfrm>
+          <a:prstGeom prst="line">
+            <a:avLst/>
+          </a:prstGeom>
+          <a:ln w="12700">
             <a:solidFill>
               <a:srgbClr val="CBD5E1"/>
             </a:solidFill>
-          </a:ln>
-        </p:spPr>
-        <p:style>
-          <a:lnRef idx="1">
-            <a:schemeClr val="accent1"/>
-          </a:lnRef>
-          <a:fillRef idx="3">
-            <a:schemeClr val="accent1"/>
-          </a:fillRef>
-          <a:effectRef idx="2">
-            <a:schemeClr val="accent1"/>
-          </a:effectRef>
-          <a:fontRef idx="minor">
-            <a:schemeClr val="lt1"/>
-          </a:fontRef>
-        </p:style>
-        <p:txBody>
-          <a:bodyPr rtlCol="0" anchor="ctr" wrap="square" lIns="73152" rIns="73152" tIns="73152" bIns="73152"/>
+            <a:prstDash val="sysDash"/>
+          </a:ln>
+        </p:spPr>
+        <p:style>
+          <a:lnRef idx="2">
+            <a:schemeClr val="accent1"/>
+          </a:lnRef>
+          <a:fillRef idx="0">
+            <a:schemeClr val="accent1"/>
+          </a:fillRef>
+          <a:effectRef idx="1">
+            <a:schemeClr val="accent1"/>
+          </a:effectRef>
+          <a:fontRef idx="minor">
+            <a:schemeClr val="tx1"/>
+          </a:fontRef>
+        </p:style>
+      </p:cxnSp>
+      <p:cxnSp>
+        <p:nvCxnSpPr>
+          <p:cNvPr id="14" name="Connector 13"/>
+          <p:cNvCxnSpPr/>
+          <p:nvPr/>
+        </p:nvCxnSpPr>
+        <p:spPr>
+          <a:xfrm>
+            <a:off x="5303520" y="2487168"/>
+            <a:ext cx="0" cy="2953512"/>
+          </a:xfrm>
+          <a:prstGeom prst="line">
+            <a:avLst/>
+          </a:prstGeom>
+          <a:ln w="12700">
+            <a:solidFill>
+              <a:srgbClr val="CBD5E1"/>
+            </a:solidFill>
+            <a:prstDash val="sysDash"/>
+          </a:ln>
+        </p:spPr>
+        <p:style>
+          <a:lnRef idx="2">
+            <a:schemeClr val="accent1"/>
+          </a:lnRef>
+          <a:fillRef idx="0">
+            <a:schemeClr val="accent1"/>
+          </a:fillRef>
+          <a:effectRef idx="1">
+            <a:schemeClr val="accent1"/>
+          </a:effectRef>
+          <a:fontRef idx="minor">
+            <a:schemeClr val="tx1"/>
+          </a:fontRef>
+        </p:style>
+      </p:cxnSp>
+      <p:cxnSp>
+        <p:nvCxnSpPr>
+          <p:cNvPr id="15" name="Connector 14"/>
+          <p:cNvCxnSpPr/>
+          <p:nvPr/>
+        </p:nvCxnSpPr>
+        <p:spPr>
+          <a:xfrm>
+            <a:off x="7360920" y="2487168"/>
+            <a:ext cx="0" cy="2953512"/>
+          </a:xfrm>
+          <a:prstGeom prst="line">
+            <a:avLst/>
+          </a:prstGeom>
+          <a:ln w="12700">
+            <a:solidFill>
+              <a:srgbClr val="CBD5E1"/>
+            </a:solidFill>
+            <a:prstDash val="sysDash"/>
+          </a:ln>
+        </p:spPr>
+        <p:style>
+          <a:lnRef idx="2">
+            <a:schemeClr val="accent1"/>
+          </a:lnRef>
+          <a:fillRef idx="0">
+            <a:schemeClr val="accent1"/>
+          </a:fillRef>
+          <a:effectRef idx="1">
+            <a:schemeClr val="accent1"/>
+          </a:effectRef>
+          <a:fontRef idx="minor">
+            <a:schemeClr val="tx1"/>
+          </a:fontRef>
+        </p:style>
+      </p:cxnSp>
+      <p:cxnSp>
+        <p:nvCxnSpPr>
+          <p:cNvPr id="16" name="Connector 15"/>
+          <p:cNvCxnSpPr/>
+          <p:nvPr/>
+        </p:nvCxnSpPr>
+        <p:spPr>
+          <a:xfrm>
+            <a:off x="9464040" y="2487168"/>
+            <a:ext cx="0" cy="2953512"/>
+          </a:xfrm>
+          <a:prstGeom prst="line">
+            <a:avLst/>
+          </a:prstGeom>
+          <a:ln w="12700">
+            <a:solidFill>
+              <a:srgbClr val="CBD5E1"/>
+            </a:solidFill>
+            <a:prstDash val="sysDash"/>
+          </a:ln>
+        </p:spPr>
+        <p:style>
+          <a:lnRef idx="2">
+            <a:schemeClr val="accent1"/>
+          </a:lnRef>
+          <a:fillRef idx="0">
+            <a:schemeClr val="accent1"/>
+          </a:fillRef>
+          <a:effectRef idx="1">
+            <a:schemeClr val="accent1"/>
+          </a:effectRef>
+          <a:fontRef idx="minor">
+            <a:schemeClr val="tx1"/>
+          </a:fontRef>
+        </p:style>
+      </p:cxnSp>
+      <p:sp>
+        <p:nvSpPr>
+          <p:cNvPr id="17" name="Right Arrow 16"/>
+          <p:cNvSpPr/>
+          <p:nvPr/>
+        </p:nvSpPr>
+        <p:spPr>
+          <a:xfrm>
+            <a:off x="1508760" y="2697480"/>
+            <a:ext cx="1828800" cy="164592"/>
+          </a:xfrm>
+          <a:prstGeom prst="rightArrow">
+            <a:avLst/>
+          </a:prstGeom>
+          <a:solidFill>
+            <a:srgbClr val="64748B"/>
+          </a:solidFill>
+          <a:ln w="12700">
+            <a:solidFill>
+              <a:srgbClr val="64748B"/>
+            </a:solidFill>
+          </a:ln>
+        </p:spPr>
+        <p:style>
+          <a:lnRef idx="1">
+            <a:schemeClr val="accent1"/>
+          </a:lnRef>
+          <a:fillRef idx="3">
+            <a:schemeClr val="accent1"/>
+          </a:fillRef>
+          <a:effectRef idx="2">
+            <a:schemeClr val="accent1"/>
+          </a:effectRef>
+          <a:fontRef idx="minor">
+            <a:schemeClr val="lt1"/>
+          </a:fontRef>
+        </p:style>
+        <p:txBody>
+          <a:bodyPr rtlCol="0" anchor="ctr" wrap="square" lIns="18288" rIns="18288" tIns="18288" bIns="18288"/>
           <a:lstStyle/>
           <a:p>
             <a:pPr algn="ctr"/>
             <a:r>
-              <a:rPr sz="1700" b="1">
-                <a:solidFill>
-                  <a:srgbClr val="111827"/>
-                </a:solidFill>
-                <a:latin typeface="Aptos"/>
-              </a:rPr>
-              <a:t>3  InferencePool</a:t>
-            </a:r>
-          </a:p>
-        </p:txBody>
-      </p:sp>
-      <p:sp>
-        <p:nvSpPr>
-          <p:cNvPr id="12" name="Rounded Rectangle 11"/>
-          <p:cNvSpPr/>
-          <p:nvPr/>
-        </p:nvSpPr>
-        <p:spPr>
-          <a:xfrm>
-            <a:off x="5321808" y="2240280"/>
-            <a:ext cx="1719072" cy="566928"/>
-          </a:xfrm>
-          <a:prstGeom prst="roundRect">
-            <a:avLst/>
-          </a:prstGeom>
-          <a:solidFill>
-            <a:srgbClr val="FFF2E8"/>
-          </a:solidFill>
-          <a:ln w="19050">
+              <a:rPr sz="1200" b="1">
+                <a:solidFill>
+                  <a:srgbClr val="FFFFFF"/>
+                </a:solidFill>
+                <a:latin typeface="Aptos"/>
+              </a:rPr>
+              <a:t>1  Inference request</a:t>
+            </a:r>
+          </a:p>
+        </p:txBody>
+      </p:sp>
+      <p:sp>
+        <p:nvSpPr>
+          <p:cNvPr id="18" name="Right Arrow 17"/>
+          <p:cNvSpPr/>
+          <p:nvPr/>
+        </p:nvSpPr>
+        <p:spPr>
+          <a:xfrm>
+            <a:off x="3337560" y="3035808"/>
+            <a:ext cx="1965959" cy="164592"/>
+          </a:xfrm>
+          <a:prstGeom prst="rightArrow">
+            <a:avLst/>
+          </a:prstGeom>
+          <a:solidFill>
+            <a:srgbClr val="C2410C"/>
+          </a:solidFill>
+          <a:ln w="12700">
             <a:solidFill>
               <a:srgbClr val="C2410C"/>
             </a:solidFill>
@@ -12352,41 +12590,150 @@
           </a:fontRef>
         </p:style>
         <p:txBody>
-          <a:bodyPr rtlCol="0" anchor="ctr" wrap="square" lIns="73152" rIns="73152" tIns="73152" bIns="73152"/>
+          <a:bodyPr rtlCol="0" anchor="ctr" wrap="square" lIns="18288" rIns="18288" tIns="18288" bIns="18288"/>
           <a:lstStyle/>
           <a:p>
             <a:pPr algn="ctr"/>
             <a:r>
-              <a:rPr sz="1700" b="1">
-                <a:solidFill>
-                  <a:srgbClr val="C2410C"/>
-                </a:solidFill>
-                <a:latin typeface="Aptos"/>
-              </a:rPr>
-              <a:t>4  llm-d Router
-EPP</a:t>
-            </a:r>
-          </a:p>
-        </p:txBody>
-      </p:sp>
-      <p:sp>
-        <p:nvSpPr>
-          <p:cNvPr id="13" name="Rounded Rectangle 12"/>
-          <p:cNvSpPr/>
-          <p:nvPr/>
-        </p:nvSpPr>
-        <p:spPr>
-          <a:xfrm>
-            <a:off x="7635240" y="2240280"/>
-            <a:ext cx="1444752" cy="566928"/>
-          </a:xfrm>
-          <a:prstGeom prst="roundRect">
-            <a:avLst/>
-          </a:prstGeom>
-          <a:solidFill>
-            <a:srgbClr val="EAF2FF"/>
-          </a:solidFill>
-          <a:ln w="19050">
+              <a:rPr sz="1200" b="1">
+                <a:solidFill>
+                  <a:srgbClr val="FFFFFF"/>
+                </a:solidFill>
+                <a:latin typeface="Aptos"/>
+              </a:rPr>
+              <a:t>2  Route to decode sidecar
+(selected prefill worker carried in header)</a:t>
+            </a:r>
+          </a:p>
+        </p:txBody>
+      </p:sp>
+      <p:sp>
+        <p:nvSpPr>
+          <p:cNvPr id="19" name="Right Arrow 18"/>
+          <p:cNvSpPr/>
+          <p:nvPr/>
+        </p:nvSpPr>
+        <p:spPr>
+          <a:xfrm>
+            <a:off x="5303520" y="3584448"/>
+            <a:ext cx="2057400" cy="164592"/>
+          </a:xfrm>
+          <a:prstGeom prst="rightArrow">
+            <a:avLst/>
+          </a:prstGeom>
+          <a:solidFill>
+            <a:srgbClr val="6D28D9"/>
+          </a:solidFill>
+          <a:ln w="12700">
+            <a:solidFill>
+              <a:srgbClr val="6D28D9"/>
+            </a:solidFill>
+          </a:ln>
+        </p:spPr>
+        <p:style>
+          <a:lnRef idx="1">
+            <a:schemeClr val="accent1"/>
+          </a:lnRef>
+          <a:fillRef idx="3">
+            <a:schemeClr val="accent1"/>
+          </a:fillRef>
+          <a:effectRef idx="2">
+            <a:schemeClr val="accent1"/>
+          </a:effectRef>
+          <a:fontRef idx="minor">
+            <a:schemeClr val="lt1"/>
+          </a:fontRef>
+        </p:style>
+        <p:txBody>
+          <a:bodyPr rtlCol="0" anchor="ctr" wrap="square" lIns="18288" rIns="18288" tIns="18288" bIns="18288"/>
+          <a:lstStyle/>
+          <a:p>
+            <a:pPr algn="ctr"/>
+            <a:r>
+              <a:rPr sz="1200" b="1">
+                <a:solidFill>
+                  <a:srgbClr val="FFFFFF"/>
+                </a:solidFill>
+                <a:latin typeface="Aptos"/>
+              </a:rPr>
+              <a:t>3  Remote prefill
+(prompt, max_tokens=1)</a:t>
+            </a:r>
+          </a:p>
+        </p:txBody>
+      </p:sp>
+      <p:sp>
+        <p:nvSpPr>
+          <p:cNvPr id="20" name="Right Arrow 19"/>
+          <p:cNvSpPr/>
+          <p:nvPr/>
+        </p:nvSpPr>
+        <p:spPr>
+          <a:xfrm>
+            <a:off x="5303520" y="4041648"/>
+            <a:ext cx="2057400" cy="164592"/>
+          </a:xfrm>
+          <a:prstGeom prst="rightArrow">
+            <a:avLst/>
+          </a:prstGeom>
+          <a:solidFill>
+            <a:srgbClr val="6D28D9"/>
+          </a:solidFill>
+          <a:ln w="12700">
+            <a:solidFill>
+              <a:srgbClr val="6D28D9"/>
+            </a:solidFill>
+          </a:ln>
+        </p:spPr>
+        <p:style>
+          <a:lnRef idx="1">
+            <a:schemeClr val="accent1"/>
+          </a:lnRef>
+          <a:fillRef idx="3">
+            <a:schemeClr val="accent1"/>
+          </a:fillRef>
+          <a:effectRef idx="2">
+            <a:schemeClr val="accent1"/>
+          </a:effectRef>
+          <a:fontRef idx="minor">
+            <a:schemeClr val="lt1"/>
+          </a:fontRef>
+        </p:style>
+        <p:txBody>
+          <a:bodyPr rtlCol="0" anchor="ctr" wrap="square" lIns="18288" rIns="18288" tIns="18288" bIns="18288"/>
+          <a:lstStyle/>
+          <a:p>
+            <a:pPr algn="ctr"/>
+            <a:r>
+              <a:rPr sz="1200" b="1">
+                <a:solidFill>
+                  <a:srgbClr val="FFFFFF"/>
+                </a:solidFill>
+                <a:latin typeface="Aptos"/>
+              </a:rPr>
+              <a:t>4  Remote KV parameters</a:t>
+            </a:r>
+          </a:p>
+        </p:txBody>
+      </p:sp>
+      <p:sp>
+        <p:nvSpPr>
+          <p:cNvPr id="21" name="Right Arrow 20"/>
+          <p:cNvSpPr/>
+          <p:nvPr/>
+        </p:nvSpPr>
+        <p:spPr>
+          <a:xfrm>
+            <a:off x="5303520" y="4553712"/>
+            <a:ext cx="4160520" cy="164592"/>
+          </a:xfrm>
+          <a:prstGeom prst="rightArrow">
+            <a:avLst/>
+          </a:prstGeom>
+          <a:solidFill>
+            <a:srgbClr val="2F6FEB"/>
+          </a:solidFill>
+          <a:ln w="12700">
             <a:solidFill>
               <a:srgbClr val="2F6FEB"/>
             </a:solidFill>
@@ -12407,40 +12754,148 @@
           </a:fontRef>
         </p:style>
         <p:txBody>
-          <a:bodyPr rtlCol="0" anchor="ctr" wrap="square" lIns="73152" rIns="73152" tIns="73152" bIns="73152"/>
+          <a:bodyPr rtlCol="0" anchor="ctr" wrap="square" lIns="18288" rIns="18288" tIns="18288" bIns="18288"/>
           <a:lstStyle/>
           <a:p>
             <a:pPr algn="ctr"/>
             <a:r>
-              <a:rPr sz="1700" b="1">
-                <a:solidFill>
-                  <a:srgbClr val="0F2747"/>
-                </a:solidFill>
-                <a:latin typeface="Aptos"/>
-              </a:rPr>
-              <a:t>5  Decode sidecar</a:t>
-            </a:r>
-          </a:p>
-        </p:txBody>
-      </p:sp>
-      <p:sp>
-        <p:nvSpPr>
-          <p:cNvPr id="14" name="Rounded Rectangle 13"/>
-          <p:cNvSpPr/>
-          <p:nvPr/>
-        </p:nvSpPr>
-        <p:spPr>
-          <a:xfrm>
-            <a:off x="9400032" y="2240280"/>
-            <a:ext cx="932688" cy="566928"/>
-          </a:xfrm>
-          <a:prstGeom prst="roundRect">
-            <a:avLst/>
-          </a:prstGeom>
-          <a:solidFill>
-            <a:srgbClr val="EAF2FF"/>
-          </a:solidFill>
-          <a:ln w="19050">
+              <a:rPr sz="1200" b="1">
+                <a:solidFill>
+                  <a:srgbClr val="FFFFFF"/>
+                </a:solidFill>
+                <a:latin typeface="Aptos"/>
+              </a:rPr>
+              <a:t>5  remote_prefill=true + prefill ID + memory block IDs</a:t>
+            </a:r>
+          </a:p>
+        </p:txBody>
+      </p:sp>
+      <p:sp>
+        <p:nvSpPr>
+          <p:cNvPr id="22" name="Right Arrow 21"/>
+          <p:cNvSpPr/>
+          <p:nvPr/>
+        </p:nvSpPr>
+        <p:spPr>
+          <a:xfrm>
+            <a:off x="7360920" y="4956048"/>
+            <a:ext cx="2103120" cy="164592"/>
+          </a:xfrm>
+          <a:prstGeom prst="rightArrow">
+            <a:avLst/>
+          </a:prstGeom>
+          <a:solidFill>
+            <a:srgbClr val="0F766E"/>
+          </a:solidFill>
+          <a:ln w="12700">
+            <a:solidFill>
+              <a:srgbClr val="0F766E"/>
+            </a:solidFill>
+          </a:ln>
+        </p:spPr>
+        <p:style>
+          <a:lnRef idx="1">
+            <a:schemeClr val="accent1"/>
+          </a:lnRef>
+          <a:fillRef idx="3">
+            <a:schemeClr val="accent1"/>
+          </a:fillRef>
+          <a:effectRef idx="2">
+            <a:schemeClr val="accent1"/>
+          </a:effectRef>
+          <a:fontRef idx="minor">
+            <a:schemeClr val="lt1"/>
+          </a:fontRef>
+        </p:style>
+        <p:txBody>
+          <a:bodyPr rtlCol="0" anchor="ctr" wrap="square" lIns="18288" rIns="18288" tIns="18288" bIns="18288"/>
+          <a:lstStyle/>
+          <a:p>
+            <a:pPr algn="ctr"/>
+            <a:r>
+              <a:rPr sz="1200" b="1">
+                <a:solidFill>
+                  <a:srgbClr val="FFFFFF"/>
+                </a:solidFill>
+                <a:latin typeface="Aptos"/>
+              </a:rPr>
+              <a:t>6  Read KV cache</a:t>
+            </a:r>
+          </a:p>
+        </p:txBody>
+      </p:sp>
+      <p:sp>
+        <p:nvSpPr>
+          <p:cNvPr id="23" name="Right Arrow 22"/>
+          <p:cNvSpPr/>
+          <p:nvPr/>
+        </p:nvSpPr>
+        <p:spPr>
+          <a:xfrm>
+            <a:off x="5303520" y="5212080"/>
+            <a:ext cx="4160520" cy="164592"/>
+          </a:xfrm>
+          <a:prstGeom prst="rightArrow">
+            <a:avLst/>
+          </a:prstGeom>
+          <a:solidFill>
+            <a:srgbClr val="0F766E"/>
+          </a:solidFill>
+          <a:ln w="12700">
+            <a:solidFill>
+              <a:srgbClr val="0F766E"/>
+            </a:solidFill>
+          </a:ln>
+        </p:spPr>
+        <p:style>
+          <a:lnRef idx="1">
+            <a:schemeClr val="accent1"/>
+          </a:lnRef>
+          <a:fillRef idx="3">
+            <a:schemeClr val="accent1"/>
+          </a:fillRef>
+          <a:effectRef idx="2">
+            <a:schemeClr val="accent1"/>
+          </a:effectRef>
+          <a:fontRef idx="minor">
+            <a:schemeClr val="lt1"/>
+          </a:fontRef>
+        </p:style>
+        <p:txBody>
+          <a:bodyPr rtlCol="0" anchor="ctr" wrap="square" lIns="18288" rIns="18288" tIns="18288" bIns="18288"/>
+          <a:lstStyle/>
+          <a:p>
+            <a:pPr algn="ctr"/>
+            <a:r>
+              <a:rPr sz="1200" b="1">
+                <a:solidFill>
+                  <a:srgbClr val="FFFFFF"/>
+                </a:solidFill>
+                <a:latin typeface="Aptos"/>
+              </a:rPr>
+              <a:t>7  Inference response</a:t>
+            </a:r>
+          </a:p>
+        </p:txBody>
+      </p:sp>
+      <p:sp>
+        <p:nvSpPr>
+          <p:cNvPr id="24" name="Right Arrow 23"/>
+          <p:cNvSpPr/>
+          <p:nvPr/>
+        </p:nvSpPr>
+        <p:spPr>
+          <a:xfrm>
+            <a:off x="3337560" y="5468112"/>
+            <a:ext cx="1965959" cy="164592"/>
+          </a:xfrm>
+          <a:prstGeom prst="rightArrow">
+            <a:avLst/>
+          </a:prstGeom>
+          <a:solidFill>
+            <a:srgbClr val="2F6FEB"/>
+          </a:solidFill>
+          <a:ln w="12700">
             <a:solidFill>
               <a:srgbClr val="2F6FEB"/>
             </a:solidFill>
@@ -12461,41 +12916,257 @@
           </a:fontRef>
         </p:style>
         <p:txBody>
-          <a:bodyPr rtlCol="0" anchor="ctr" wrap="square" lIns="73152" rIns="73152" tIns="73152" bIns="73152"/>
+          <a:bodyPr rtlCol="0" anchor="ctr" wrap="square" lIns="18288" rIns="18288" tIns="18288" bIns="18288"/>
           <a:lstStyle/>
           <a:p>
             <a:pPr algn="ctr"/>
             <a:r>
-              <a:rPr sz="1700" b="1">
-                <a:solidFill>
-                  <a:srgbClr val="0F2747"/>
-                </a:solidFill>
-                <a:latin typeface="Aptos"/>
-              </a:rPr>
-              <a:t>6  Decode
-vLLM</a:t>
-            </a:r>
-          </a:p>
-        </p:txBody>
-      </p:sp>
-      <p:sp>
-        <p:nvSpPr>
-          <p:cNvPr id="15" name="Right Arrow 14"/>
-          <p:cNvSpPr/>
-          <p:nvPr/>
-        </p:nvSpPr>
-        <p:spPr>
-          <a:xfrm>
-            <a:off x="1828800" y="2432304"/>
-            <a:ext cx="201168" cy="164592"/>
+              <a:rPr sz="1200" b="1">
+                <a:solidFill>
+                  <a:srgbClr val="FFFFFF"/>
+                </a:solidFill>
+                <a:latin typeface="Aptos"/>
+              </a:rPr>
+              <a:t>8  Response</a:t>
+            </a:r>
+          </a:p>
+        </p:txBody>
+      </p:sp>
+      <p:sp>
+        <p:nvSpPr>
+          <p:cNvPr id="25" name="Right Arrow 24"/>
+          <p:cNvSpPr/>
+          <p:nvPr/>
+        </p:nvSpPr>
+        <p:spPr>
+          <a:xfrm>
+            <a:off x="1508760" y="5705856"/>
+            <a:ext cx="1828800" cy="164592"/>
           </a:xfrm>
           <a:prstGeom prst="rightArrow">
             <a:avLst/>
           </a:prstGeom>
           <a:solidFill>
-            <a:srgbClr val="2F6FEB"/>
-          </a:solidFill>
-          <a:ln>
+            <a:srgbClr val="64748B"/>
+          </a:solidFill>
+          <a:ln w="12700">
+            <a:solidFill>
+              <a:srgbClr val="64748B"/>
+            </a:solidFill>
+          </a:ln>
+        </p:spPr>
+        <p:style>
+          <a:lnRef idx="1">
+            <a:schemeClr val="accent1"/>
+          </a:lnRef>
+          <a:fillRef idx="3">
+            <a:schemeClr val="accent1"/>
+          </a:fillRef>
+          <a:effectRef idx="2">
+            <a:schemeClr val="accent1"/>
+          </a:effectRef>
+          <a:fontRef idx="minor">
+            <a:schemeClr val="lt1"/>
+          </a:fontRef>
+        </p:style>
+        <p:txBody>
+          <a:bodyPr rtlCol="0" anchor="ctr" wrap="square" lIns="18288" rIns="18288" tIns="18288" bIns="18288"/>
+          <a:lstStyle/>
+          <a:p>
+            <a:pPr algn="ctr"/>
+            <a:r>
+              <a:rPr sz="1200" b="1">
+                <a:solidFill>
+                  <a:srgbClr val="FFFFFF"/>
+                </a:solidFill>
+                <a:latin typeface="Aptos"/>
+              </a:rPr>
+              <a:t>9  Final response</a:t>
+            </a:r>
+          </a:p>
+        </p:txBody>
+      </p:sp>
+      <p:sp>
+        <p:nvSpPr>
+          <p:cNvPr id="26" name="Rounded Rectangle 25"/>
+          <p:cNvSpPr/>
+          <p:nvPr/>
+        </p:nvSpPr>
+        <p:spPr>
+          <a:xfrm>
+            <a:off x="6473952" y="3794760"/>
+            <a:ext cx="1261872" cy="384048"/>
+          </a:xfrm>
+          <a:prstGeom prst="roundRect">
+            <a:avLst/>
+          </a:prstGeom>
+          <a:solidFill>
+            <a:srgbClr val="FFFFFF"/>
+          </a:solidFill>
+          <a:ln w="17780">
+            <a:solidFill>
+              <a:srgbClr val="6D28D9"/>
+            </a:solidFill>
+          </a:ln>
+        </p:spPr>
+        <p:style>
+          <a:lnRef idx="1">
+            <a:schemeClr val="accent1"/>
+          </a:lnRef>
+          <a:fillRef idx="3">
+            <a:schemeClr val="accent1"/>
+          </a:fillRef>
+          <a:effectRef idx="2">
+            <a:schemeClr val="accent1"/>
+          </a:effectRef>
+          <a:fontRef idx="minor">
+            <a:schemeClr val="lt1"/>
+          </a:fontRef>
+        </p:style>
+        <p:txBody>
+          <a:bodyPr rtlCol="0" anchor="ctr" wrap="square" lIns="54864" rIns="54864" tIns="54864" bIns="54864"/>
+          <a:lstStyle/>
+          <a:p>
+            <a:pPr algn="ctr"/>
+            <a:r>
+              <a:rPr sz="1400" b="0">
+                <a:solidFill>
+                  <a:srgbClr val="6D28D9"/>
+                </a:solidFill>
+                <a:latin typeface="Aptos"/>
+              </a:rPr>
+              <a:t>Run prefill</a:t>
+            </a:r>
+          </a:p>
+        </p:txBody>
+      </p:sp>
+      <p:sp>
+        <p:nvSpPr>
+          <p:cNvPr id="27" name="Rounded Rectangle 26"/>
+          <p:cNvSpPr/>
+          <p:nvPr/>
+        </p:nvSpPr>
+        <p:spPr>
+          <a:xfrm>
+            <a:off x="8458200" y="4736592"/>
+            <a:ext cx="1783080" cy="493776"/>
+          </a:xfrm>
+          <a:prstGeom prst="roundRect">
+            <a:avLst/>
+          </a:prstGeom>
+          <a:solidFill>
+            <a:srgbClr val="FFFFFF"/>
+          </a:solidFill>
+          <a:ln w="17780">
+            <a:solidFill>
+              <a:srgbClr val="0F766E"/>
+            </a:solidFill>
+          </a:ln>
+        </p:spPr>
+        <p:style>
+          <a:lnRef idx="1">
+            <a:schemeClr val="accent1"/>
+          </a:lnRef>
+          <a:fillRef idx="3">
+            <a:schemeClr val="accent1"/>
+          </a:fillRef>
+          <a:effectRef idx="2">
+            <a:schemeClr val="accent1"/>
+          </a:effectRef>
+          <a:fontRef idx="minor">
+            <a:schemeClr val="lt1"/>
+          </a:fontRef>
+        </p:style>
+        <p:txBody>
+          <a:bodyPr rtlCol="0" anchor="ctr" wrap="square" lIns="54864" rIns="54864" tIns="54864" bIns="54864"/>
+          <a:lstStyle/>
+          <a:p>
+            <a:pPr algn="ctr"/>
+            <a:r>
+              <a:rPr sz="1400" b="0">
+                <a:solidFill>
+                  <a:srgbClr val="0F766E"/>
+                </a:solidFill>
+                <a:latin typeface="Aptos"/>
+              </a:rPr>
+              <a:t>Schedule decode
+and run decode locally</a:t>
+            </a:r>
+          </a:p>
+        </p:txBody>
+      </p:sp>
+      <p:sp>
+        <p:nvSpPr>
+          <p:cNvPr id="28" name="Rounded Rectangle 27"/>
+          <p:cNvSpPr/>
+          <p:nvPr/>
+        </p:nvSpPr>
+        <p:spPr>
+          <a:xfrm>
+            <a:off x="868680" y="4800600"/>
+            <a:ext cx="2834640" cy="566928"/>
+          </a:xfrm>
+          <a:prstGeom prst="roundRect">
+            <a:avLst/>
+          </a:prstGeom>
+          <a:solidFill>
+            <a:srgbClr val="FFFFFF"/>
+          </a:solidFill>
+          <a:ln w="17780">
+            <a:solidFill>
+              <a:srgbClr val="CBD5E1"/>
+            </a:solidFill>
+          </a:ln>
+        </p:spPr>
+        <p:style>
+          <a:lnRef idx="1">
+            <a:schemeClr val="accent1"/>
+          </a:lnRef>
+          <a:fillRef idx="3">
+            <a:schemeClr val="accent1"/>
+          </a:fillRef>
+          <a:effectRef idx="2">
+            <a:schemeClr val="accent1"/>
+          </a:effectRef>
+          <a:fontRef idx="minor">
+            <a:schemeClr val="lt1"/>
+          </a:fontRef>
+        </p:style>
+        <p:txBody>
+          <a:bodyPr rtlCol="0" anchor="ctr" wrap="square" lIns="54864" rIns="54864" tIns="54864" bIns="54864"/>
+          <a:lstStyle/>
+          <a:p>
+            <a:pPr algn="ctr"/>
+            <a:r>
+              <a:rPr sz="1600" b="0">
+                <a:solidFill>
+                  <a:srgbClr val="111827"/>
+                </a:solidFill>
+                <a:latin typeface="Aptos"/>
+              </a:rPr>
+              <a:t>Client still sees one serving path.</a:t>
+            </a:r>
+          </a:p>
+        </p:txBody>
+      </p:sp>
+      <p:sp>
+        <p:nvSpPr>
+          <p:cNvPr id="29" name="Rounded Rectangle 28"/>
+          <p:cNvSpPr/>
+          <p:nvPr/>
+        </p:nvSpPr>
+        <p:spPr>
+          <a:xfrm>
+            <a:off x="3977639" y="4800600"/>
+            <a:ext cx="2971800" cy="566928"/>
+          </a:xfrm>
+          <a:prstGeom prst="roundRect">
+            <a:avLst/>
+          </a:prstGeom>
+          <a:solidFill>
+            <a:srgbClr val="EAF2FF"/>
+          </a:solidFill>
+          <a:ln w="17780">
             <a:solidFill>
               <a:srgbClr val="2F6FEB"/>
             </a:solidFill>
@@ -12516,31 +13187,42 @@
           </a:fontRef>
         </p:style>
         <p:txBody>
-          <a:bodyPr rtlCol="0" anchor="ctr"/>
-          <a:lstStyle/>
-          <a:p/>
-        </p:txBody>
-      </p:sp>
-      <p:sp>
-        <p:nvSpPr>
-          <p:cNvPr id="16" name="Right Arrow 15"/>
-          <p:cNvSpPr/>
-          <p:nvPr/>
-        </p:nvSpPr>
-        <p:spPr>
-          <a:xfrm>
-            <a:off x="3273552" y="2432304"/>
-            <a:ext cx="219456" cy="164592"/>
-          </a:xfrm>
-          <a:prstGeom prst="rightArrow">
-            <a:avLst/>
-          </a:prstGeom>
-          <a:solidFill>
-            <a:srgbClr val="2F6FEB"/>
-          </a:solidFill>
-          <a:ln>
+          <a:bodyPr rtlCol="0" anchor="ctr" wrap="square" lIns="54864" rIns="54864" tIns="54864" bIns="54864"/>
+          <a:lstStyle/>
+          <a:p>
+            <a:pPr algn="ctr"/>
+            <a:r>
+              <a:rPr sz="1600" b="0">
+                <a:solidFill>
+                  <a:srgbClr val="0F2747"/>
+                </a:solidFill>
+                <a:latin typeface="Aptos"/>
+              </a:rPr>
+              <a:t>Decode sidecar coordinates remote prefill.</a:t>
+            </a:r>
+          </a:p>
+        </p:txBody>
+      </p:sp>
+      <p:sp>
+        <p:nvSpPr>
+          <p:cNvPr id="30" name="Rounded Rectangle 29"/>
+          <p:cNvSpPr/>
+          <p:nvPr/>
+        </p:nvSpPr>
+        <p:spPr>
+          <a:xfrm>
+            <a:off x="7223760" y="4800600"/>
+            <a:ext cx="2971800" cy="566928"/>
+          </a:xfrm>
+          <a:prstGeom prst="roundRect">
+            <a:avLst/>
+          </a:prstGeom>
+          <a:solidFill>
+            <a:srgbClr val="E8FFFB"/>
+          </a:solidFill>
+          <a:ln w="17780">
             <a:solidFill>
-              <a:srgbClr val="2F6FEB"/>
+              <a:srgbClr val="0F766E"/>
             </a:solidFill>
           </a:ln>
         </p:spPr>
@@ -12559,352 +13241,40 @@
           </a:fontRef>
         </p:style>
         <p:txBody>
-          <a:bodyPr rtlCol="0" anchor="ctr"/>
-          <a:lstStyle/>
-          <a:p/>
-        </p:txBody>
-      </p:sp>
-      <p:sp>
-        <p:nvSpPr>
-          <p:cNvPr id="17" name="Right Arrow 16"/>
-          <p:cNvSpPr/>
-          <p:nvPr/>
-        </p:nvSpPr>
-        <p:spPr>
-          <a:xfrm>
-            <a:off x="4956048" y="2432304"/>
-            <a:ext cx="274320" cy="164592"/>
-          </a:xfrm>
-          <a:prstGeom prst="rightArrow">
-            <a:avLst/>
-          </a:prstGeom>
-          <a:solidFill>
-            <a:srgbClr val="C2410C"/>
-          </a:solidFill>
-          <a:ln>
-            <a:solidFill>
-              <a:srgbClr val="C2410C"/>
-            </a:solidFill>
-          </a:ln>
-        </p:spPr>
-        <p:style>
-          <a:lnRef idx="1">
-            <a:schemeClr val="accent1"/>
-          </a:lnRef>
-          <a:fillRef idx="3">
-            <a:schemeClr val="accent1"/>
-          </a:fillRef>
-          <a:effectRef idx="2">
-            <a:schemeClr val="accent1"/>
-          </a:effectRef>
-          <a:fontRef idx="minor">
-            <a:schemeClr val="lt1"/>
-          </a:fontRef>
-        </p:style>
-        <p:txBody>
-          <a:bodyPr rtlCol="0" anchor="ctr"/>
-          <a:lstStyle/>
-          <a:p/>
-        </p:txBody>
-      </p:sp>
-      <p:sp>
-        <p:nvSpPr>
-          <p:cNvPr id="18" name="Right Arrow 17"/>
-          <p:cNvSpPr/>
-          <p:nvPr/>
-        </p:nvSpPr>
-        <p:spPr>
-          <a:xfrm>
-            <a:off x="7269480" y="2432304"/>
-            <a:ext cx="237744" cy="164592"/>
-          </a:xfrm>
-          <a:prstGeom prst="rightArrow">
-            <a:avLst/>
-          </a:prstGeom>
-          <a:solidFill>
-            <a:srgbClr val="2F6FEB"/>
-          </a:solidFill>
-          <a:ln>
-            <a:solidFill>
-              <a:srgbClr val="2F6FEB"/>
-            </a:solidFill>
-          </a:ln>
-        </p:spPr>
-        <p:style>
-          <a:lnRef idx="1">
-            <a:schemeClr val="accent1"/>
-          </a:lnRef>
-          <a:fillRef idx="3">
-            <a:schemeClr val="accent1"/>
-          </a:fillRef>
-          <a:effectRef idx="2">
-            <a:schemeClr val="accent1"/>
-          </a:effectRef>
-          <a:fontRef idx="minor">
-            <a:schemeClr val="lt1"/>
-          </a:fontRef>
-        </p:style>
-        <p:txBody>
-          <a:bodyPr rtlCol="0" anchor="ctr"/>
-          <a:lstStyle/>
-          <a:p/>
-        </p:txBody>
-      </p:sp>
-      <p:sp>
-        <p:nvSpPr>
-          <p:cNvPr id="19" name="Right Arrow 18"/>
-          <p:cNvSpPr/>
-          <p:nvPr/>
-        </p:nvSpPr>
-        <p:spPr>
-          <a:xfrm>
-            <a:off x="9107424" y="2432304"/>
-            <a:ext cx="201168" cy="164592"/>
-          </a:xfrm>
-          <a:prstGeom prst="rightArrow">
-            <a:avLst/>
-          </a:prstGeom>
-          <a:solidFill>
-            <a:srgbClr val="2F6FEB"/>
-          </a:solidFill>
-          <a:ln>
-            <a:solidFill>
-              <a:srgbClr val="2F6FEB"/>
-            </a:solidFill>
-          </a:ln>
-        </p:spPr>
-        <p:style>
-          <a:lnRef idx="1">
-            <a:schemeClr val="accent1"/>
-          </a:lnRef>
-          <a:fillRef idx="3">
-            <a:schemeClr val="accent1"/>
-          </a:fillRef>
-          <a:effectRef idx="2">
-            <a:schemeClr val="accent1"/>
-          </a:effectRef>
-          <a:fontRef idx="minor">
-            <a:schemeClr val="lt1"/>
-          </a:fontRef>
-        </p:style>
-        <p:txBody>
-          <a:bodyPr rtlCol="0" anchor="ctr"/>
-          <a:lstStyle/>
-          <a:p/>
-        </p:txBody>
-      </p:sp>
-      <p:sp>
-        <p:nvSpPr>
-          <p:cNvPr id="20" name="Rounded Rectangle 19"/>
-          <p:cNvSpPr/>
-          <p:nvPr/>
-        </p:nvSpPr>
-        <p:spPr>
-          <a:xfrm>
-            <a:off x="5596128" y="2971800"/>
-            <a:ext cx="1325880" cy="512064"/>
+          <a:bodyPr rtlCol="0" anchor="ctr" wrap="square" lIns="54864" rIns="54864" tIns="54864" bIns="54864"/>
+          <a:lstStyle/>
+          <a:p>
+            <a:pPr algn="ctr"/>
+            <a:r>
+              <a:rPr sz="1600" b="0">
+                <a:solidFill>
+                  <a:srgbClr val="0F766E"/>
+                </a:solidFill>
+                <a:latin typeface="Aptos"/>
+              </a:rPr>
+              <a:t>Decode still runs locally on the chosen decode worker.</a:t>
+            </a:r>
+          </a:p>
+        </p:txBody>
+      </p:sp>
+      <p:sp>
+        <p:nvSpPr>
+          <p:cNvPr id="31" name="Rounded Rectangle 30"/>
+          <p:cNvSpPr/>
+          <p:nvPr/>
+        </p:nvSpPr>
+        <p:spPr>
+          <a:xfrm>
+            <a:off x="694944" y="5632704"/>
+            <a:ext cx="9646920" cy="310896"/>
           </a:xfrm>
           <a:prstGeom prst="roundRect">
             <a:avLst/>
           </a:prstGeom>
           <a:solidFill>
-            <a:srgbClr val="F3E8FF"/>
-          </a:solidFill>
-          <a:ln w="19050">
-            <a:solidFill>
-              <a:srgbClr val="6D28D9"/>
-            </a:solidFill>
-          </a:ln>
-        </p:spPr>
-        <p:style>
-          <a:lnRef idx="1">
-            <a:schemeClr val="accent1"/>
-          </a:lnRef>
-          <a:fillRef idx="3">
-            <a:schemeClr val="accent1"/>
-          </a:fillRef>
-          <a:effectRef idx="2">
-            <a:schemeClr val="accent1"/>
-          </a:effectRef>
-          <a:fontRef idx="minor">
-            <a:schemeClr val="lt1"/>
-          </a:fontRef>
-        </p:style>
-        <p:txBody>
-          <a:bodyPr rtlCol="0" anchor="ctr" wrap="square" lIns="73152" rIns="73152" tIns="73152" bIns="73152"/>
-          <a:lstStyle/>
-          <a:p>
-            <a:pPr algn="ctr"/>
-            <a:r>
-              <a:rPr sz="1900" b="1">
-                <a:solidFill>
-                  <a:srgbClr val="6D28D9"/>
-                </a:solidFill>
-                <a:latin typeface="Aptos"/>
-              </a:rPr>
-              <a:t>Prefill</a:t>
-            </a:r>
-          </a:p>
-        </p:txBody>
-      </p:sp>
-      <p:sp>
-        <p:nvSpPr>
-          <p:cNvPr id="21" name="Down Arrow 20"/>
-          <p:cNvSpPr/>
-          <p:nvPr/>
-        </p:nvSpPr>
-        <p:spPr>
-          <a:xfrm>
-            <a:off x="6071616" y="2779776"/>
-            <a:ext cx="182880" cy="164592"/>
-          </a:xfrm>
-          <a:prstGeom prst="downArrow">
-            <a:avLst/>
-          </a:prstGeom>
-          <a:solidFill>
-            <a:srgbClr val="C2410C"/>
-          </a:solidFill>
-          <a:ln>
-            <a:solidFill>
-              <a:srgbClr val="C2410C"/>
-            </a:solidFill>
-          </a:ln>
-        </p:spPr>
-        <p:style>
-          <a:lnRef idx="1">
-            <a:schemeClr val="accent1"/>
-          </a:lnRef>
-          <a:fillRef idx="3">
-            <a:schemeClr val="accent1"/>
-          </a:fillRef>
-          <a:effectRef idx="2">
-            <a:schemeClr val="accent1"/>
-          </a:effectRef>
-          <a:fontRef idx="minor">
-            <a:schemeClr val="lt1"/>
-          </a:fontRef>
-        </p:style>
-        <p:txBody>
-          <a:bodyPr rtlCol="0" anchor="ctr"/>
-          <a:lstStyle/>
-          <a:p/>
-        </p:txBody>
-      </p:sp>
-      <p:sp>
-        <p:nvSpPr>
-          <p:cNvPr id="22" name="Rounded Rectangle 21"/>
-          <p:cNvSpPr/>
-          <p:nvPr/>
-        </p:nvSpPr>
-        <p:spPr>
-          <a:xfrm>
-            <a:off x="7059168" y="2889504"/>
-            <a:ext cx="914400" cy="201168"/>
-          </a:xfrm>
-          <a:prstGeom prst="roundRect">
-            <a:avLst/>
-          </a:prstGeom>
-          <a:solidFill>
-            <a:srgbClr val="FFFFFF"/>
-          </a:solidFill>
-          <a:ln w="19050">
-            <a:solidFill>
-              <a:srgbClr val="6D28D9"/>
-            </a:solidFill>
-          </a:ln>
-        </p:spPr>
-        <p:style>
-          <a:lnRef idx="1">
-            <a:schemeClr val="accent1"/>
-          </a:lnRef>
-          <a:fillRef idx="3">
-            <a:schemeClr val="accent1"/>
-          </a:fillRef>
-          <a:effectRef idx="2">
-            <a:schemeClr val="accent1"/>
-          </a:effectRef>
-          <a:fontRef idx="minor">
-            <a:schemeClr val="lt1"/>
-          </a:fontRef>
-        </p:style>
-        <p:txBody>
-          <a:bodyPr rtlCol="0" anchor="ctr" wrap="square" lIns="27432" rIns="27432" tIns="27432" bIns="27432"/>
-          <a:lstStyle/>
-          <a:p>
-            <a:pPr algn="ctr"/>
-            <a:r>
-              <a:rPr sz="1200" b="1">
-                <a:solidFill>
-                  <a:srgbClr val="6D28D9"/>
-                </a:solidFill>
-                <a:latin typeface="Aptos"/>
-              </a:rPr>
-              <a:t>KV handoff</a:t>
-            </a:r>
-          </a:p>
-        </p:txBody>
-      </p:sp>
-      <p:sp>
-        <p:nvSpPr>
-          <p:cNvPr id="23" name="Right Arrow 22"/>
-          <p:cNvSpPr/>
-          <p:nvPr/>
-        </p:nvSpPr>
-        <p:spPr>
-          <a:xfrm>
-            <a:off x="7022592" y="3154680"/>
-            <a:ext cx="749808" cy="164592"/>
-          </a:xfrm>
-          <a:prstGeom prst="rightArrow">
-            <a:avLst/>
-          </a:prstGeom>
-          <a:solidFill>
-            <a:srgbClr val="6D28D9"/>
-          </a:solidFill>
-          <a:ln>
-            <a:solidFill>
-              <a:srgbClr val="6D28D9"/>
-            </a:solidFill>
-          </a:ln>
-        </p:spPr>
-        <p:style>
-          <a:lnRef idx="1">
-            <a:schemeClr val="accent1"/>
-          </a:lnRef>
-          <a:fillRef idx="3">
-            <a:schemeClr val="accent1"/>
-          </a:fillRef>
-          <a:effectRef idx="2">
-            <a:schemeClr val="accent1"/>
-          </a:effectRef>
-          <a:fontRef idx="minor">
-            <a:schemeClr val="lt1"/>
-          </a:fontRef>
-        </p:style>
-        <p:txBody>
-          <a:bodyPr rtlCol="0" anchor="ctr"/>
-          <a:lstStyle/>
-          <a:p/>
-        </p:txBody>
-      </p:sp>
-      <p:sp>
-        <p:nvSpPr>
-          <p:cNvPr id="24" name="Rounded Rectangle 23"/>
-          <p:cNvSpPr/>
-          <p:nvPr/>
-        </p:nvSpPr>
-        <p:spPr>
-          <a:xfrm>
-            <a:off x="896112" y="3822191"/>
-            <a:ext cx="5669280" cy="969264"/>
-          </a:xfrm>
-          <a:prstGeom prst="roundRect">
-            <a:avLst/>
-          </a:prstGeom>
-          <a:solidFill>
-            <a:srgbClr val="FFFFFF"/>
-          </a:solidFill>
-          <a:ln w="19050">
+            <a:srgbClr val="F8FAFC"/>
+          </a:solidFill>
+          <a:ln w="17780">
             <a:solidFill>
               <a:srgbClr val="CBD5E1"/>
             </a:solidFill>
@@ -12925,244 +13295,18 @@
           </a:fontRef>
         </p:style>
         <p:txBody>
-          <a:bodyPr rtlCol="0" anchor="ctr" wrap="square" lIns="73152" rIns="73152" tIns="73152" bIns="73152"/>
+          <a:bodyPr rtlCol="0" anchor="ctr" wrap="square" lIns="54864" rIns="54864" tIns="54864" bIns="54864"/>
           <a:lstStyle/>
           <a:p>
             <a:pPr algn="ctr"/>
             <a:r>
-              <a:rPr sz="2000" b="0">
+              <a:rPr sz="1500" b="0">
                 <a:solidFill>
                   <a:srgbClr val="111827"/>
                 </a:solidFill>
                 <a:latin typeface="Aptos"/>
               </a:rPr>
-              <a:t/>
-            </a:r>
-          </a:p>
-        </p:txBody>
-      </p:sp>
-      <p:sp>
-        <p:nvSpPr>
-          <p:cNvPr id="25" name="TextBox 24"/>
-          <p:cNvSpPr txBox="1"/>
-          <p:nvPr/>
-        </p:nvSpPr>
-        <p:spPr>
-          <a:xfrm>
-            <a:off x="896112" y="3822191"/>
-            <a:ext cx="5669280" cy="969264"/>
-          </a:xfrm>
-          <a:prstGeom prst="rect">
-            <a:avLst/>
-          </a:prstGeom>
-          <a:noFill/>
-        </p:spPr>
-        <p:txBody>
-          <a:bodyPr wrap="square" lIns="73152" rIns="45720" anchor="t">
-            <a:spAutoFit/>
-          </a:bodyPr>
-          <a:lstStyle/>
-          <a:p>
-            <a:pPr algn="l"/>
-            <a:r>
-              <a:rPr sz="1600">
-                <a:solidFill>
-                  <a:srgbClr val="111827"/>
-                </a:solidFill>
-                <a:latin typeface="Aptos"/>
-              </a:rPr>
-              <a:t>• Gateway / HTTPRoute forwards the request to the model's InferencePool.</a:t>
-            </a:r>
-          </a:p>
-          <a:p>
-            <a:pPr algn="l"/>
-            <a:r>
-              <a:rPr sz="1600">
-                <a:solidFill>
-                  <a:srgbClr val="111827"/>
-                </a:solidFill>
-                <a:latin typeface="Aptos"/>
-              </a:rPr>
-              <a:t>• llm-d Router EPP decides whether prefill helps and picks the role-specific backends.</a:t>
-            </a:r>
-          </a:p>
-          <a:p>
-            <a:pPr algn="l"/>
-            <a:r>
-              <a:rPr sz="1600">
-                <a:solidFill>
-                  <a:srgbClr val="111827"/>
-                </a:solidFill>
-                <a:latin typeface="Aptos"/>
-              </a:rPr>
-              <a:t>• Decode remains the coordination point, so the client still sees one endpoint.</a:t>
-            </a:r>
-          </a:p>
-        </p:txBody>
-      </p:sp>
-      <p:sp>
-        <p:nvSpPr>
-          <p:cNvPr id="26" name="Rounded Rectangle 25"/>
-          <p:cNvSpPr/>
-          <p:nvPr/>
-        </p:nvSpPr>
-        <p:spPr>
-          <a:xfrm>
-            <a:off x="6876288" y="3822191"/>
-            <a:ext cx="3346704" cy="969264"/>
-          </a:xfrm>
-          <a:prstGeom prst="roundRect">
-            <a:avLst/>
-          </a:prstGeom>
-          <a:solidFill>
-            <a:srgbClr val="EAF2FF"/>
-          </a:solidFill>
-          <a:ln w="19050">
-            <a:solidFill>
-              <a:srgbClr val="2F6FEB"/>
-            </a:solidFill>
-          </a:ln>
-        </p:spPr>
-        <p:style>
-          <a:lnRef idx="1">
-            <a:schemeClr val="accent1"/>
-          </a:lnRef>
-          <a:fillRef idx="3">
-            <a:schemeClr val="accent1"/>
-          </a:fillRef>
-          <a:effectRef idx="2">
-            <a:schemeClr val="accent1"/>
-          </a:effectRef>
-          <a:fontRef idx="minor">
-            <a:schemeClr val="lt1"/>
-          </a:fontRef>
-        </p:style>
-        <p:txBody>
-          <a:bodyPr rtlCol="0" anchor="ctr" wrap="square" lIns="73152" rIns="73152" tIns="73152" bIns="73152"/>
-          <a:lstStyle/>
-          <a:p>
-            <a:pPr algn="ctr"/>
-            <a:r>
-              <a:rPr sz="2000" b="0">
-                <a:solidFill>
-                  <a:srgbClr val="111827"/>
-                </a:solidFill>
-                <a:latin typeface="Aptos"/>
-              </a:rPr>
-              <a:t/>
-            </a:r>
-          </a:p>
-        </p:txBody>
-      </p:sp>
-      <p:sp>
-        <p:nvSpPr>
-          <p:cNvPr id="27" name="TextBox 26"/>
-          <p:cNvSpPr txBox="1"/>
-          <p:nvPr/>
-        </p:nvSpPr>
-        <p:spPr>
-          <a:xfrm>
-            <a:off x="6876288" y="3822191"/>
-            <a:ext cx="3346704" cy="969264"/>
-          </a:xfrm>
-          <a:prstGeom prst="rect">
-            <a:avLst/>
-          </a:prstGeom>
-          <a:noFill/>
-        </p:spPr>
-        <p:txBody>
-          <a:bodyPr wrap="square" lIns="73152" rIns="45720" anchor="t">
-            <a:spAutoFit/>
-          </a:bodyPr>
-          <a:lstStyle/>
-          <a:p>
-            <a:pPr algn="l"/>
-            <a:r>
-              <a:rPr sz="1600">
-                <a:solidFill>
-                  <a:srgbClr val="0F2747"/>
-                </a:solidFill>
-                <a:latin typeface="Aptos"/>
-              </a:rPr>
-              <a:t>• Prefill is conditional, not mandatory.</a:t>
-            </a:r>
-          </a:p>
-          <a:p>
-            <a:pPr algn="l"/>
-            <a:r>
-              <a:rPr sz="1600">
-                <a:solidFill>
-                  <a:srgbClr val="0F2747"/>
-                </a:solidFill>
-                <a:latin typeface="Aptos"/>
-              </a:rPr>
-              <a:t>• KV transfer bridges prefill and decode.</a:t>
-            </a:r>
-          </a:p>
-          <a:p>
-            <a:pPr algn="l"/>
-            <a:r>
-              <a:rPr sz="1600">
-                <a:solidFill>
-                  <a:srgbClr val="0F2747"/>
-                </a:solidFill>
-                <a:latin typeface="Aptos"/>
-              </a:rPr>
-              <a:t>• Response streaming still returns through the decode path.</a:t>
-            </a:r>
-          </a:p>
-        </p:txBody>
-      </p:sp>
-      <p:sp>
-        <p:nvSpPr>
-          <p:cNvPr id="28" name="Rounded Rectangle 27"/>
-          <p:cNvSpPr/>
-          <p:nvPr/>
-        </p:nvSpPr>
-        <p:spPr>
-          <a:xfrm>
-            <a:off x="658368" y="5650992"/>
-            <a:ext cx="9784080" cy="310896"/>
-          </a:xfrm>
-          <a:prstGeom prst="roundRect">
-            <a:avLst/>
-          </a:prstGeom>
-          <a:solidFill>
-            <a:srgbClr val="F8FAFC"/>
-          </a:solidFill>
-          <a:ln w="19050">
-            <a:solidFill>
-              <a:srgbClr val="CBD5E1"/>
-            </a:solidFill>
-          </a:ln>
-        </p:spPr>
-        <p:style>
-          <a:lnRef idx="1">
-            <a:schemeClr val="accent1"/>
-          </a:lnRef>
-          <a:fillRef idx="3">
-            <a:schemeClr val="accent1"/>
-          </a:fillRef>
-          <a:effectRef idx="2">
-            <a:schemeClr val="accent1"/>
-          </a:effectRef>
-          <a:fontRef idx="minor">
-            <a:schemeClr val="lt1"/>
-          </a:fontRef>
-        </p:style>
-        <p:txBody>
-          <a:bodyPr rtlCol="0" anchor="ctr" wrap="square" lIns="73152" rIns="73152" tIns="73152" bIns="73152"/>
-          <a:lstStyle/>
-          <a:p>
-            <a:pPr algn="ctr"/>
-            <a:r>
-              <a:rPr sz="1500" b="0">
-                <a:solidFill>
-                  <a:srgbClr val="111827"/>
-                </a:solidFill>
-                <a:latin typeface="Aptos"/>
-              </a:rPr>
-              <a:t>Gateway contract, routing choice, prefill placement, KV movement, and decode execution are all coordinated under one serving path.</a:t>
+              <a:t>P/D in llm-d is a decode-sidecar-coordinated flow: prefill may run remotely, but decode stays local to the selected decode worker.</a:t>
             </a:r>
           </a:p>
         </p:txBody>

</xml_diff>

<commit_message>
docs: update slide 5 with Qwen A100 prefill and H100 decode topology
</commit_message>
<xml_diff>
--- a/llm/kaito-llm-d-pd-slides.pptx
+++ b/llm/kaito-llm-d-pd-slides.pptx
@@ -1003,7 +1003,7 @@
           <a:lstStyle/>
           <a:p>
             <a:r>
-              <a:t>This is a topology excerpt, not apply-ready YAML. Model configuration, placement and other required fields are omitted for focus. The original example has one prefill replica and two decode replicas. Replica cards are illustrative workers; an InferenceSet remains the controller-managed abstraction for each role.</a:t>
+              <a:t>User-supplied example: kaito.sh/v1alpha1 MultiRoleInference named qwen-3-8-27b, model Qwen/Qwen3.8-27B. The prefill role has replicas: 1 and instanceType: Standard_NC24ads_A100_v4; the decode role has replicas: 2 and instanceType: Standard_NC80adis_H100_v5. The diagram shows role replicas, not the number of GPUs in each VM. Model and SKU identifiers are reproduced as provided; model availability, installed CRD schema, deployment prerequisites, quota and regional SKU support have not been validated by this presentation edit. Replica cards are illustrative workers; each role is managed through its own InferenceSet.</a:t>
             </a:r>
           </a:p>
         </p:txBody>
@@ -13622,7 +13622,7 @@
       </p:sp>
       <p:sp>
         <p:nvSpPr>
-          <p:cNvPr id="5" name="Users describe roles and replica intent; controllers own the expansion."/>
+          <p:cNvPr id="5" name="One model, distinct instance types: 1 A100 prefill replica + 2 H100 decode repli"/>
           <p:cNvSpPr txBox="1"/>
           <p:nvPr/>
         </p:nvSpPr>
@@ -13657,7 +13657,7 @@
               </a:defRPr>
             </a:pPr>
             <a:r>
-              <a:t>Users describe roles and replica intent; controllers own the expansion.</a:t>
+              <a:t>One model, distinct instance types: 1 A100 prefill replica + 2 H100 decode replicas.</a:t>
             </a:r>
           </a:p>
         </p:txBody>
@@ -13755,7 +13755,7 @@
         <p:spPr>
           <a:xfrm>
             <a:off x="548640" y="1847088"/>
-            <a:ext cx="4782312" cy="3767328"/>
+            <a:ext cx="5650992" cy="3767328"/>
           </a:xfrm>
           <a:prstGeom prst="roundRect">
             <a:avLst>
@@ -13793,14 +13793,14 @@
       </p:sp>
       <p:sp>
         <p:nvSpPr>
-          <p:cNvPr id="9" name="MultiRoleInference  /  topology excerpt"/>
+          <p:cNvPr id="9" name="MultiRoleInference  /  model + role placement"/>
           <p:cNvSpPr txBox="1"/>
           <p:nvPr/>
         </p:nvSpPr>
         <p:spPr>
           <a:xfrm>
             <a:off x="777240" y="2039112"/>
-            <a:ext cx="4297680" cy="228600"/>
+            <a:ext cx="5193792" cy="228600"/>
           </a:xfrm>
           <a:prstGeom prst="rect">
             <a:avLst/>
@@ -13828,7 +13828,7 @@
               </a:defRPr>
             </a:pPr>
             <a:r>
-              <a:t>MultiRoleInference  /  topology excerpt</a:t>
+              <a:t>MultiRoleInference  /  model + role placement</a:t>
             </a:r>
           </a:p>
         </p:txBody>
@@ -13841,8 +13841,8 @@
         </p:nvSpPr>
         <p:spPr>
           <a:xfrm>
-            <a:off x="786384" y="2514600"/>
-            <a:ext cx="4334256" cy="2715768"/>
+            <a:off x="786384" y="2468880"/>
+            <a:ext cx="5193792" cy="2971800"/>
           </a:xfrm>
           <a:prstGeom prst="rect">
             <a:avLst/>
@@ -13856,13 +13856,16 @@
           <a:lstStyle/>
           <a:p>
             <a:pPr algn="l">
-              <a:spcBef>
-                <a:spcPts val="0"/>
-              </a:spcBef>
-              <a:spcAft>
-                <a:spcPts val="200"/>
-              </a:spcAft>
-              <a:defRPr sz="1600" b="0">
+              <a:lnSpc>
+                <a:spcPts val="1630"/>
+              </a:lnSpc>
+              <a:spcBef>
+                <a:spcPts val="0"/>
+              </a:spcBef>
+              <a:spcAft>
+                <a:spcPts val="0"/>
+              </a:spcAft>
+              <a:defRPr sz="1400" b="0">
                 <a:solidFill>
                   <a:srgbClr val="FFFFFF"/>
                 </a:solidFill>
@@ -13875,13 +13878,16 @@
           </a:p>
           <a:p>
             <a:pPr algn="l">
-              <a:spcBef>
-                <a:spcPts val="0"/>
-              </a:spcBef>
-              <a:spcAft>
-                <a:spcPts val="200"/>
-              </a:spcAft>
-              <a:defRPr sz="1600" b="0">
+              <a:lnSpc>
+                <a:spcPts val="1630"/>
+              </a:lnSpc>
+              <a:spcBef>
+                <a:spcPts val="0"/>
+              </a:spcBef>
+              <a:spcAft>
+                <a:spcPts val="0"/>
+              </a:spcAft>
+              <a:defRPr sz="1400" b="0">
                 <a:solidFill>
                   <a:srgbClr val="FFFFFF"/>
                 </a:solidFill>
@@ -13894,13 +13900,16 @@
           </a:p>
           <a:p>
             <a:pPr algn="l">
-              <a:spcBef>
-                <a:spcPts val="0"/>
-              </a:spcBef>
-              <a:spcAft>
-                <a:spcPts val="200"/>
-              </a:spcAft>
-              <a:defRPr sz="1600" b="0">
+              <a:lnSpc>
+                <a:spcPts val="1630"/>
+              </a:lnSpc>
+              <a:spcBef>
+                <a:spcPts val="0"/>
+              </a:spcBef>
+              <a:spcAft>
+                <a:spcPts val="0"/>
+              </a:spcAft>
+              <a:defRPr sz="1400" b="0">
                 <a:solidFill>
                   <a:srgbClr val="FFFFFF"/>
                 </a:solidFill>
@@ -13913,13 +13922,16 @@
           </a:p>
           <a:p>
             <a:pPr algn="l">
-              <a:spcBef>
-                <a:spcPts val="0"/>
-              </a:spcBef>
-              <a:spcAft>
-                <a:spcPts val="200"/>
-              </a:spcAft>
-              <a:defRPr sz="1600" b="0">
+              <a:lnSpc>
+                <a:spcPts val="1630"/>
+              </a:lnSpc>
+              <a:spcBef>
+                <a:spcPts val="0"/>
+              </a:spcBef>
+              <a:spcAft>
+                <a:spcPts val="0"/>
+              </a:spcAft>
+              <a:defRPr sz="1400" b="0">
                 <a:solidFill>
                   <a:srgbClr val="FFFFFF"/>
                 </a:solidFill>
@@ -13927,18 +13939,21 @@
               </a:defRPr>
             </a:pPr>
             <a:r>
-              <a:t>  name: qwen-pd</a:t>
+              <a:t>  name: qwen-3-8-27b</a:t>
             </a:r>
           </a:p>
           <a:p>
             <a:pPr algn="l">
-              <a:spcBef>
-                <a:spcPts val="0"/>
-              </a:spcBef>
-              <a:spcAft>
-                <a:spcPts val="200"/>
-              </a:spcAft>
-              <a:defRPr sz="1600" b="0">
+              <a:lnSpc>
+                <a:spcPts val="1630"/>
+              </a:lnSpc>
+              <a:spcBef>
+                <a:spcPts val="0"/>
+              </a:spcBef>
+              <a:spcAft>
+                <a:spcPts val="0"/>
+              </a:spcAft>
+              <a:defRPr sz="1400" b="0">
                 <a:solidFill>
                   <a:srgbClr val="FFFFFF"/>
                 </a:solidFill>
@@ -13951,13 +13966,16 @@
           </a:p>
           <a:p>
             <a:pPr algn="l">
-              <a:spcBef>
-                <a:spcPts val="0"/>
-              </a:spcBef>
-              <a:spcAft>
-                <a:spcPts val="200"/>
-              </a:spcAft>
-              <a:defRPr sz="1600" b="0">
+              <a:lnSpc>
+                <a:spcPts val="1630"/>
+              </a:lnSpc>
+              <a:spcBef>
+                <a:spcPts val="0"/>
+              </a:spcBef>
+              <a:spcAft>
+                <a:spcPts val="0"/>
+              </a:spcAft>
+              <a:defRPr sz="1400" b="0">
                 <a:solidFill>
                   <a:srgbClr val="FFFFFF"/>
                 </a:solidFill>
@@ -13965,18 +13983,65 @@
               </a:defRPr>
             </a:pPr>
             <a:r>
+              <a:t>  model:</a:t>
+            </a:r>
+          </a:p>
+          <a:p>
+            <a:pPr algn="l">
+              <a:lnSpc>
+                <a:spcPts val="1630"/>
+              </a:lnSpc>
+              <a:spcBef>
+                <a:spcPts val="0"/>
+              </a:spcBef>
+              <a:spcAft>
+                <a:spcPts val="0"/>
+              </a:spcAft>
+              <a:defRPr sz="1400" b="0">
+                <a:solidFill>
+                  <a:srgbClr val="FFFFFF"/>
+                </a:solidFill>
+                <a:latin typeface="Consolas"/>
+              </a:defRPr>
+            </a:pPr>
+            <a:r>
+              <a:t>    name: Qwen/Qwen3.8-27B</a:t>
+            </a:r>
+          </a:p>
+          <a:p>
+            <a:pPr algn="l">
+              <a:lnSpc>
+                <a:spcPts val="1630"/>
+              </a:lnSpc>
+              <a:spcBef>
+                <a:spcPts val="0"/>
+              </a:spcBef>
+              <a:spcAft>
+                <a:spcPts val="0"/>
+              </a:spcAft>
+              <a:defRPr sz="1400" b="0">
+                <a:solidFill>
+                  <a:srgbClr val="FFFFFF"/>
+                </a:solidFill>
+                <a:latin typeface="Consolas"/>
+              </a:defRPr>
+            </a:pPr>
+            <a:r>
               <a:t>  roles:</a:t>
             </a:r>
           </a:p>
           <a:p>
             <a:pPr algn="l">
-              <a:spcBef>
-                <a:spcPts val="0"/>
-              </a:spcBef>
-              <a:spcAft>
-                <a:spcPts val="200"/>
-              </a:spcAft>
-              <a:defRPr sz="1600" b="0">
+              <a:lnSpc>
+                <a:spcPts val="1630"/>
+              </a:lnSpc>
+              <a:spcBef>
+                <a:spcPts val="0"/>
+              </a:spcBef>
+              <a:spcAft>
+                <a:spcPts val="0"/>
+              </a:spcAft>
+              <a:defRPr sz="1400" b="0">
                 <a:solidFill>
                   <a:srgbClr val="FFFFFF"/>
                 </a:solidFill>
@@ -13989,13 +14054,16 @@
           </a:p>
           <a:p>
             <a:pPr algn="l">
-              <a:spcBef>
-                <a:spcPts val="0"/>
-              </a:spcBef>
-              <a:spcAft>
-                <a:spcPts val="200"/>
-              </a:spcAft>
-              <a:defRPr sz="1600" b="0">
+              <a:lnSpc>
+                <a:spcPts val="1630"/>
+              </a:lnSpc>
+              <a:spcBef>
+                <a:spcPts val="0"/>
+              </a:spcBef>
+              <a:spcAft>
+                <a:spcPts val="0"/>
+              </a:spcAft>
+              <a:defRPr sz="1400" b="0">
                 <a:solidFill>
                   <a:srgbClr val="FFFFFF"/>
                 </a:solidFill>
@@ -14008,13 +14076,16 @@
           </a:p>
           <a:p>
             <a:pPr algn="l">
-              <a:spcBef>
-                <a:spcPts val="0"/>
-              </a:spcBef>
-              <a:spcAft>
-                <a:spcPts val="200"/>
-              </a:spcAft>
-              <a:defRPr sz="1600" b="0">
+              <a:lnSpc>
+                <a:spcPts val="1630"/>
+              </a:lnSpc>
+              <a:spcBef>
+                <a:spcPts val="0"/>
+              </a:spcBef>
+              <a:spcAft>
+                <a:spcPts val="0"/>
+              </a:spcAft>
+              <a:defRPr sz="1400" b="0">
                 <a:solidFill>
                   <a:srgbClr val="FFFFFF"/>
                 </a:solidFill>
@@ -14022,18 +14093,43 @@
               </a:defRPr>
             </a:pPr>
             <a:r>
+              <a:t>      instanceType: Standard_NC24ads_A100_v4</a:t>
+            </a:r>
+          </a:p>
+          <a:p>
+            <a:pPr algn="l">
+              <a:lnSpc>
+                <a:spcPts val="1630"/>
+              </a:lnSpc>
+              <a:spcBef>
+                <a:spcPts val="0"/>
+              </a:spcBef>
+              <a:spcAft>
+                <a:spcPts val="0"/>
+              </a:spcAft>
+              <a:defRPr sz="1400" b="0">
+                <a:solidFill>
+                  <a:srgbClr val="FFFFFF"/>
+                </a:solidFill>
+                <a:latin typeface="Consolas"/>
+              </a:defRPr>
+            </a:pPr>
+            <a:r>
               <a:t>    - type: decode</a:t>
             </a:r>
           </a:p>
           <a:p>
             <a:pPr algn="l">
-              <a:spcBef>
-                <a:spcPts val="0"/>
-              </a:spcBef>
-              <a:spcAft>
-                <a:spcPts val="200"/>
-              </a:spcAft>
-              <a:defRPr sz="1600" b="0">
+              <a:lnSpc>
+                <a:spcPts val="1630"/>
+              </a:lnSpc>
+              <a:spcBef>
+                <a:spcPts val="0"/>
+              </a:spcBef>
+              <a:spcAft>
+                <a:spcPts val="0"/>
+              </a:spcAft>
+              <a:defRPr sz="1400" b="0">
                 <a:solidFill>
                   <a:srgbClr val="FFFFFF"/>
                 </a:solidFill>
@@ -14044,60 +14140,40 @@
               <a:t>      replicas: 2</a:t>
             </a:r>
           </a:p>
-        </p:txBody>
-      </p:sp>
-      <p:sp>
-        <p:nvSpPr>
-          <p:cNvPr id="11" name="Illustrative excerpt — model and placement omitted."/>
-          <p:cNvSpPr txBox="1"/>
-          <p:nvPr/>
-        </p:nvSpPr>
-        <p:spPr>
-          <a:xfrm>
-            <a:off x="786384" y="5294376"/>
-            <a:ext cx="4251960" cy="164592"/>
-          </a:xfrm>
-          <a:prstGeom prst="rect">
-            <a:avLst/>
-          </a:prstGeom>
-          <a:noFill/>
-        </p:spPr>
-        <p:txBody>
-          <a:bodyPr wrap="square" lIns="0" rIns="0" tIns="0" bIns="0" anchor="t">
-            <a:noAutofit/>
-          </a:bodyPr>
-          <a:lstStyle/>
           <a:p>
             <a:pPr algn="l">
-              <a:spcBef>
-                <a:spcPts val="0"/>
-              </a:spcBef>
-              <a:spcAft>
-                <a:spcPts val="200"/>
-              </a:spcAft>
-              <a:defRPr sz="1000" b="0">
-                <a:solidFill>
-                  <a:srgbClr val="C8D8E7"/>
-                </a:solidFill>
-                <a:latin typeface="Arial"/>
-              </a:defRPr>
-            </a:pPr>
-            <a:r>
-              <a:t>Illustrative excerpt — model and placement omitted.</a:t>
+              <a:lnSpc>
+                <a:spcPts val="1630"/>
+              </a:lnSpc>
+              <a:spcBef>
+                <a:spcPts val="0"/>
+              </a:spcBef>
+              <a:spcAft>
+                <a:spcPts val="0"/>
+              </a:spcAft>
+              <a:defRPr sz="1400" b="0">
+                <a:solidFill>
+                  <a:srgbClr val="FFFFFF"/>
+                </a:solidFill>
+                <a:latin typeface="Consolas"/>
+              </a:defRPr>
+            </a:pPr>
+            <a:r>
+              <a:t>      instanceType: Standard_NC80adis_H100_v5</a:t>
             </a:r>
           </a:p>
         </p:txBody>
       </p:sp>
       <p:cxnSp>
         <p:nvCxnSpPr>
-          <p:cNvPr id="12" name="Flow"/>
+          <p:cNvPr id="11" name="Flow"/>
           <p:cNvCxnSpPr/>
           <p:nvPr/>
         </p:nvCxnSpPr>
         <p:spPr>
           <a:xfrm>
-            <a:off x="5449824" y="3721608"/>
-            <a:ext cx="640080" cy="0"/>
+            <a:off x="6291072" y="3721608"/>
+            <a:ext cx="493776" cy="0"/>
           </a:xfrm>
           <a:prstGeom prst="line">
             <a:avLst/>
@@ -14126,14 +14202,14 @@
       </p:cxnSp>
       <p:sp>
         <p:nvSpPr>
-          <p:cNvPr id="13" name="reconcile"/>
+          <p:cNvPr id="12" name="reconcile"/>
           <p:cNvSpPr txBox="1"/>
           <p:nvPr/>
         </p:nvSpPr>
         <p:spPr>
           <a:xfrm>
-            <a:off x="5404104" y="3310128"/>
-            <a:ext cx="722376" cy="274320"/>
+            <a:off x="6217920" y="3328416"/>
+            <a:ext cx="667512" cy="274320"/>
           </a:xfrm>
           <a:prstGeom prst="rect">
             <a:avLst/>
@@ -14153,7 +14229,7 @@
               <a:spcAft>
                 <a:spcPts val="200"/>
               </a:spcAft>
-              <a:defRPr sz="1000" b="0">
+              <a:defRPr sz="900" b="0">
                 <a:solidFill>
                   <a:srgbClr val="7150C8"/>
                 </a:solidFill>
@@ -14168,14 +14244,14 @@
       </p:sp>
       <p:sp>
         <p:nvSpPr>
-          <p:cNvPr id="14" name="One logical service / InferencePool"/>
+          <p:cNvPr id="13" name="qwen-3-8-27b"/>
           <p:cNvSpPr/>
           <p:nvPr/>
         </p:nvSpPr>
         <p:spPr>
           <a:xfrm>
-            <a:off x="6309360" y="1865376"/>
-            <a:ext cx="5102352" cy="630936"/>
+            <a:off x="6949440" y="1847088"/>
+            <a:ext cx="4690872" cy="786384"/>
           </a:xfrm>
           <a:prstGeom prst="roundRect">
             <a:avLst>
@@ -14216,7 +14292,7 @@
               <a:spcAft>
                 <a:spcPts val="0"/>
               </a:spcAft>
-              <a:defRPr sz="1800" b="1">
+              <a:defRPr sz="2100" b="1">
                 <a:solidFill>
                   <a:srgbClr val="2463D4"/>
                 </a:solidFill>
@@ -14224,7 +14300,68 @@
               </a:defRPr>
             </a:pPr>
             <a:r>
-              <a:t>One logical service / InferencePool</a:t>
+              <a:t>qwen-3-8-27b</a:t>
+            </a:r>
+          </a:p>
+          <a:p>
+            <a:pPr algn="ctr">
+              <a:spcBef>
+                <a:spcPts val="300"/>
+              </a:spcBef>
+              <a:spcAft>
+                <a:spcPts val="0"/>
+              </a:spcAft>
+              <a:defRPr sz="1200" b="0">
+                <a:solidFill>
+                  <a:srgbClr val="5B6E80"/>
+                </a:solidFill>
+                <a:latin typeface="Arial"/>
+              </a:defRPr>
+            </a:pPr>
+            <a:r>
+              <a:t>Qwen/Qwen3.8-27B</a:t>
+            </a:r>
+          </a:p>
+        </p:txBody>
+      </p:sp>
+      <p:sp>
+        <p:nvSpPr>
+          <p:cNvPr id="14" name="ONE LOGICAL SERVICE / INFERENCEPOOL"/>
+          <p:cNvSpPr txBox="1"/>
+          <p:nvPr/>
+        </p:nvSpPr>
+        <p:spPr>
+          <a:xfrm>
+            <a:off x="6976872" y="2743200"/>
+            <a:ext cx="4636008" cy="219456"/>
+          </a:xfrm>
+          <a:prstGeom prst="rect">
+            <a:avLst/>
+          </a:prstGeom>
+          <a:noFill/>
+        </p:spPr>
+        <p:txBody>
+          <a:bodyPr wrap="square" lIns="0" rIns="0" tIns="0" bIns="0" anchor="t">
+            <a:noAutofit/>
+          </a:bodyPr>
+          <a:lstStyle/>
+          <a:p>
+            <a:pPr algn="ctr">
+              <a:spcBef>
+                <a:spcPts val="0"/>
+              </a:spcBef>
+              <a:spcAft>
+                <a:spcPts val="200"/>
+              </a:spcAft>
+              <a:defRPr sz="1100" b="1">
+                <a:solidFill>
+                  <a:srgbClr val="5B6E80"/>
+                </a:solidFill>
+                <a:latin typeface="Arial"/>
+              </a:defRPr>
+            </a:pPr>
+            <a:r>
+              <a:t>ONE LOGICAL SERVICE / INFERENCEPOOL</a:t>
             </a:r>
           </a:p>
         </p:txBody>
@@ -14237,8 +14374,8 @@
         </p:nvSpPr>
         <p:spPr>
           <a:xfrm>
-            <a:off x="6309360" y="2788920"/>
-            <a:ext cx="2267712" cy="2331720"/>
+            <a:off x="6949440" y="3172968"/>
+            <a:ext cx="2221992" cy="2441448"/>
           </a:xfrm>
           <a:prstGeom prst="roundRect">
             <a:avLst>
@@ -14282,8 +14419,8 @@
         </p:nvSpPr>
         <p:spPr>
           <a:xfrm>
-            <a:off x="8869680" y="2788920"/>
-            <a:ext cx="2542032" cy="2331720"/>
+            <a:off x="9409176" y="3172968"/>
+            <a:ext cx="2231136" cy="2441448"/>
           </a:xfrm>
           <a:prstGeom prst="roundRect">
             <a:avLst>
@@ -14327,8 +14464,8 @@
         </p:nvSpPr>
         <p:spPr>
           <a:xfrm>
-            <a:off x="6519672" y="2999232"/>
-            <a:ext cx="1874519" cy="320040"/>
+            <a:off x="7132320" y="3337560"/>
+            <a:ext cx="1856231" cy="320040"/>
           </a:xfrm>
           <a:prstGeom prst="rect">
             <a:avLst/>
@@ -14369,8 +14506,8 @@
         </p:nvSpPr>
         <p:spPr>
           <a:xfrm>
-            <a:off x="9089136" y="2999232"/>
-            <a:ext cx="2084831" cy="320040"/>
+            <a:off x="9592056" y="3337560"/>
+            <a:ext cx="1865376" cy="320040"/>
           </a:xfrm>
           <a:prstGeom prst="rect">
             <a:avLst/>
@@ -14405,14 +14542,98 @@
       </p:sp>
       <p:sp>
         <p:nvSpPr>
-          <p:cNvPr id="19" name="Worker 1"/>
+          <p:cNvPr id="19" name="replicas: 1"/>
+          <p:cNvSpPr txBox="1"/>
+          <p:nvPr/>
+        </p:nvSpPr>
+        <p:spPr>
+          <a:xfrm>
+            <a:off x="7132320" y="3730752"/>
+            <a:ext cx="1856231" cy="219456"/>
+          </a:xfrm>
+          <a:prstGeom prst="rect">
+            <a:avLst/>
+          </a:prstGeom>
+          <a:noFill/>
+        </p:spPr>
+        <p:txBody>
+          <a:bodyPr wrap="square" lIns="0" rIns="0" tIns="0" bIns="0" anchor="t">
+            <a:noAutofit/>
+          </a:bodyPr>
+          <a:lstStyle/>
+          <a:p>
+            <a:pPr algn="l">
+              <a:spcBef>
+                <a:spcPts val="0"/>
+              </a:spcBef>
+              <a:spcAft>
+                <a:spcPts val="200"/>
+              </a:spcAft>
+              <a:defRPr sz="1300" b="0">
+                <a:solidFill>
+                  <a:srgbClr val="A85C05"/>
+                </a:solidFill>
+                <a:latin typeface="Arial"/>
+              </a:defRPr>
+            </a:pPr>
+            <a:r>
+              <a:t>replicas: 1</a:t>
+            </a:r>
+          </a:p>
+        </p:txBody>
+      </p:sp>
+      <p:sp>
+        <p:nvSpPr>
+          <p:cNvPr id="20" name="replicas: 2"/>
+          <p:cNvSpPr txBox="1"/>
+          <p:nvPr/>
+        </p:nvSpPr>
+        <p:spPr>
+          <a:xfrm>
+            <a:off x="9592056" y="3730752"/>
+            <a:ext cx="1865376" cy="219456"/>
+          </a:xfrm>
+          <a:prstGeom prst="rect">
+            <a:avLst/>
+          </a:prstGeom>
+          <a:noFill/>
+        </p:spPr>
+        <p:txBody>
+          <a:bodyPr wrap="square" lIns="0" rIns="0" tIns="0" bIns="0" anchor="t">
+            <a:noAutofit/>
+          </a:bodyPr>
+          <a:lstStyle/>
+          <a:p>
+            <a:pPr algn="l">
+              <a:spcBef>
+                <a:spcPts val="0"/>
+              </a:spcBef>
+              <a:spcAft>
+                <a:spcPts val="200"/>
+              </a:spcAft>
+              <a:defRPr sz="1300" b="0">
+                <a:solidFill>
+                  <a:srgbClr val="087F82"/>
+                </a:solidFill>
+                <a:latin typeface="Arial"/>
+              </a:defRPr>
+            </a:pPr>
+            <a:r>
+              <a:t>replicas: 2</a:t>
+            </a:r>
+          </a:p>
+        </p:txBody>
+      </p:sp>
+      <p:sp>
+        <p:nvSpPr>
+          <p:cNvPr id="21" name="A100 / replica 1"/>
           <p:cNvSpPr/>
           <p:nvPr/>
         </p:nvSpPr>
         <p:spPr>
           <a:xfrm>
-            <a:off x="6547104" y="3666744"/>
-            <a:ext cx="1783080" cy="649224"/>
+            <a:off x="7141464" y="4096512"/>
+            <a:ext cx="1837943" cy="521207"/>
           </a:xfrm>
           <a:prstGeom prst="roundRect">
             <a:avLst>
@@ -14453,7 +14674,7 @@
               <a:spcAft>
                 <a:spcPts val="0"/>
               </a:spcAft>
-              <a:defRPr sz="1700" b="1">
+              <a:defRPr sz="1400" b="1">
                 <a:solidFill>
                   <a:srgbClr val="A85C05"/>
                 </a:solidFill>
@@ -14461,21 +14682,21 @@
               </a:defRPr>
             </a:pPr>
             <a:r>
-              <a:t>Worker 1</a:t>
-            </a:r>
-          </a:p>
-        </p:txBody>
-      </p:sp>
-      <p:sp>
-        <p:nvSpPr>
-          <p:cNvPr id="20" name="Worker 1"/>
+              <a:t>A100 / replica 1</a:t>
+            </a:r>
+          </a:p>
+        </p:txBody>
+      </p:sp>
+      <p:sp>
+        <p:nvSpPr>
+          <p:cNvPr id="22" name="H100 / replica 1"/>
           <p:cNvSpPr/>
           <p:nvPr/>
         </p:nvSpPr>
         <p:spPr>
           <a:xfrm>
-            <a:off x="9098280" y="3648456"/>
-            <a:ext cx="2075688" cy="548640"/>
+            <a:off x="9601200" y="4096512"/>
+            <a:ext cx="1847088" cy="521207"/>
           </a:xfrm>
           <a:prstGeom prst="roundRect">
             <a:avLst>
@@ -14516,7 +14737,7 @@
               <a:spcAft>
                 <a:spcPts val="0"/>
               </a:spcAft>
-              <a:defRPr sz="1700" b="1">
+              <a:defRPr sz="1400" b="1">
                 <a:solidFill>
                   <a:srgbClr val="087F82"/>
                 </a:solidFill>
@@ -14524,21 +14745,21 @@
               </a:defRPr>
             </a:pPr>
             <a:r>
-              <a:t>Worker 1</a:t>
-            </a:r>
-          </a:p>
-        </p:txBody>
-      </p:sp>
-      <p:sp>
-        <p:nvSpPr>
-          <p:cNvPr id="21" name="Worker 2"/>
+              <a:t>H100 / replica 1</a:t>
+            </a:r>
+          </a:p>
+        </p:txBody>
+      </p:sp>
+      <p:sp>
+        <p:nvSpPr>
+          <p:cNvPr id="23" name="H100 / replica 2"/>
           <p:cNvSpPr/>
           <p:nvPr/>
         </p:nvSpPr>
         <p:spPr>
           <a:xfrm>
-            <a:off x="9098280" y="4343400"/>
-            <a:ext cx="2075688" cy="548640"/>
+            <a:off x="9601200" y="4745736"/>
+            <a:ext cx="1847088" cy="521207"/>
           </a:xfrm>
           <a:prstGeom prst="roundRect">
             <a:avLst>
@@ -14579,7 +14800,7 @@
               <a:spcAft>
                 <a:spcPts val="0"/>
               </a:spcAft>
-              <a:defRPr sz="1700" b="1">
+              <a:defRPr sz="1400" b="1">
                 <a:solidFill>
                   <a:srgbClr val="087F82"/>
                 </a:solidFill>
@@ -14587,21 +14808,21 @@
               </a:defRPr>
             </a:pPr>
             <a:r>
-              <a:t>Worker 2</a:t>
-            </a:r>
-          </a:p>
-        </p:txBody>
-      </p:sp>
-      <p:sp>
-        <p:nvSpPr>
-          <p:cNvPr id="22" name="replicas: 1"/>
+              <a:t>H100 / replica 2</a:t>
+            </a:r>
+          </a:p>
+        </p:txBody>
+      </p:sp>
+      <p:sp>
+        <p:nvSpPr>
+          <p:cNvPr id="24" name="Standard_NC24ads_A100_v4"/>
           <p:cNvSpPr txBox="1"/>
           <p:nvPr/>
         </p:nvSpPr>
         <p:spPr>
           <a:xfrm>
-            <a:off x="6528816" y="4608576"/>
-            <a:ext cx="1865376" cy="219456"/>
+            <a:off x="7068312" y="5367528"/>
+            <a:ext cx="1984248" cy="164592"/>
           </a:xfrm>
           <a:prstGeom prst="rect">
             <a:avLst/>
@@ -14614,14 +14835,14 @@
           </a:bodyPr>
           <a:lstStyle/>
           <a:p>
-            <a:pPr algn="l">
+            <a:pPr algn="ctr">
               <a:spcBef>
                 <a:spcPts val="0"/>
               </a:spcBef>
               <a:spcAft>
                 <a:spcPts val="200"/>
               </a:spcAft>
-              <a:defRPr sz="1300" b="0">
+              <a:defRPr sz="900" b="0">
                 <a:solidFill>
                   <a:srgbClr val="A85C05"/>
                 </a:solidFill>
@@ -14629,21 +14850,21 @@
               </a:defRPr>
             </a:pPr>
             <a:r>
-              <a:t>replicas: 1</a:t>
-            </a:r>
-          </a:p>
-        </p:txBody>
-      </p:sp>
-      <p:sp>
-        <p:nvSpPr>
-          <p:cNvPr id="23" name="Independent role intent. Shared service surface."/>
+              <a:t>Standard_NC24ads_A100_v4</a:t>
+            </a:r>
+          </a:p>
+        </p:txBody>
+      </p:sp>
+      <p:sp>
+        <p:nvSpPr>
+          <p:cNvPr id="25" name="Standard_NC80adis_H100_v5"/>
           <p:cNvSpPr txBox="1"/>
           <p:nvPr/>
         </p:nvSpPr>
         <p:spPr>
           <a:xfrm>
-            <a:off x="6345936" y="5330952"/>
-            <a:ext cx="5010912" cy="246888"/>
+            <a:off x="9528048" y="5367528"/>
+            <a:ext cx="1993392" cy="164592"/>
           </a:xfrm>
           <a:prstGeom prst="rect">
             <a:avLst/>
@@ -14656,29 +14877,101 @@
           </a:bodyPr>
           <a:lstStyle/>
           <a:p>
-            <a:pPr algn="l">
+            <a:pPr algn="ctr">
               <a:spcBef>
                 <a:spcPts val="0"/>
               </a:spcBef>
               <a:spcAft>
                 <a:spcPts val="200"/>
               </a:spcAft>
-              <a:defRPr sz="1400" b="1">
-                <a:solidFill>
-                  <a:srgbClr val="5B6E80"/>
-                </a:solidFill>
-                <a:latin typeface="Arial"/>
-              </a:defRPr>
-            </a:pPr>
-            <a:r>
-              <a:t>Independent role intent. Shared service surface.</a:t>
-            </a:r>
-          </a:p>
-        </p:txBody>
-      </p:sp>
-      <p:sp>
-        <p:nvSpPr>
-          <p:cNvPr id="24" name="Panel 23"/>
+              <a:defRPr sz="900" b="0">
+                <a:solidFill>
+                  <a:srgbClr val="087F82"/>
+                </a:solidFill>
+                <a:latin typeface="Arial"/>
+              </a:defRPr>
+            </a:pPr>
+            <a:r>
+              <a:t>Standard_NC80adis_H100_v5</a:t>
+            </a:r>
+          </a:p>
+        </p:txBody>
+      </p:sp>
+      <p:cxnSp>
+        <p:nvCxnSpPr>
+          <p:cNvPr id="26" name="Flow"/>
+          <p:cNvCxnSpPr/>
+          <p:nvPr/>
+        </p:nvCxnSpPr>
+        <p:spPr>
+          <a:xfrm>
+            <a:off x="8065008" y="2999232"/>
+            <a:ext cx="0" cy="137160"/>
+          </a:xfrm>
+          <a:prstGeom prst="line">
+            <a:avLst/>
+          </a:prstGeom>
+          <a:ln w="22860">
+            <a:solidFill>
+              <a:srgbClr val="A85C05"/>
+            </a:solidFill>
+            <a:tailEnd type="triangle" w="sm" len="sm"/>
+          </a:ln>
+        </p:spPr>
+        <p:style>
+          <a:lnRef idx="2">
+            <a:schemeClr val="accent1"/>
+          </a:lnRef>
+          <a:fillRef idx="0">
+            <a:schemeClr val="accent1"/>
+          </a:fillRef>
+          <a:effectRef idx="1">
+            <a:schemeClr val="accent1"/>
+          </a:effectRef>
+          <a:fontRef idx="minor">
+            <a:schemeClr val="tx1"/>
+          </a:fontRef>
+        </p:style>
+      </p:cxnSp>
+      <p:cxnSp>
+        <p:nvCxnSpPr>
+          <p:cNvPr id="27" name="Flow"/>
+          <p:cNvCxnSpPr/>
+          <p:nvPr/>
+        </p:nvCxnSpPr>
+        <p:spPr>
+          <a:xfrm>
+            <a:off x="10524744" y="2999232"/>
+            <a:ext cx="0" cy="137160"/>
+          </a:xfrm>
+          <a:prstGeom prst="line">
+            <a:avLst/>
+          </a:prstGeom>
+          <a:ln w="22860">
+            <a:solidFill>
+              <a:srgbClr val="087F82"/>
+            </a:solidFill>
+            <a:tailEnd type="triangle" w="sm" len="sm"/>
+          </a:ln>
+        </p:spPr>
+        <p:style>
+          <a:lnRef idx="2">
+            <a:schemeClr val="accent1"/>
+          </a:lnRef>
+          <a:fillRef idx="0">
+            <a:schemeClr val="accent1"/>
+          </a:fillRef>
+          <a:effectRef idx="1">
+            <a:schemeClr val="accent1"/>
+          </a:effectRef>
+          <a:fontRef idx="minor">
+            <a:schemeClr val="tx1"/>
+          </a:fontRef>
+        </p:style>
+      </p:cxnSp>
+      <p:sp>
+        <p:nvSpPr>
+          <p:cNvPr id="28" name="Panel 27"/>
           <p:cNvSpPr/>
           <p:nvPr/>
         </p:nvSpPr>
@@ -14723,7 +15016,7 @@
       </p:sp>
       <p:sp>
         <p:nvSpPr>
-          <p:cNvPr id="25" name="Panel 24"/>
+          <p:cNvPr id="29" name="Panel 28"/>
           <p:cNvSpPr/>
           <p:nvPr/>
         </p:nvSpPr>
@@ -14766,7 +15059,7 @@
       </p:sp>
       <p:sp>
         <p:nvSpPr>
-          <p:cNvPr id="26" name="The CRD is the product surface — topology intent in, role-specific serving out."/>
+          <p:cNvPr id="30" name="Same model, independent role placement — A100 for prefill; H100 for decode."/>
           <p:cNvSpPr txBox="1"/>
           <p:nvPr/>
         </p:nvSpPr>
@@ -14801,7 +15094,7 @@
               </a:defRPr>
             </a:pPr>
             <a:r>
-              <a:t>The CRD is the product surface — topology intent in, role-specific serving out.</a:t>
+              <a:t>Same model, independent role placement — A100 for prefill; H100 for decode.</a:t>
             </a:r>
           </a:p>
         </p:txBody>

</xml_diff>